<commit_message>
docs: add Codex Review findings to summary (md + pptx)
- Markdown:
  · Updated overview table to show two AI sources separately
    (Claude Code Agent ~35 + ChatGPT Codex Bot 3)
  · Added new section detailing all 3 Codex findings, status, fix
  · Annotated AI sources with model/agent names

- PPT (slide 4 + slide 6):
  · Slide 4 cards now show three sources with model annotations
  · Slide 6 split into two sections: Claude (4 rounds) + Codex (3 PRs)
  · Bottom callout: multi-AI cross-review beats single AI

https://claude.ai/code/session_018awhBNLzA8t49GoT2mPYxD
</commit_message>
<xml_diff>
--- a/docs/dev_summary.pptx
+++ b/docs/dev_summary.pptx
@@ -6667,7 +6667,7 @@
         <p:spPr>
           <a:xfrm>
             <a:off x="457200" y="1188720"/>
-            <a:ext cx="3657600" cy="2103120"/>
+            <a:ext cx="3657600" cy="2286000"/>
           </a:xfrm>
           <a:prstGeom prst="roundRect">
             <a:avLst/>
@@ -6709,7 +6709,7 @@
         </p:nvSpPr>
         <p:spPr>
           <a:xfrm>
-            <a:off x="457200" y="1371600"/>
+            <a:off x="457200" y="1325880"/>
             <a:ext cx="3657600" cy="365760"/>
           </a:xfrm>
           <a:prstGeom prst="rect">
@@ -6744,7 +6744,7 @@
         </p:nvSpPr>
         <p:spPr>
           <a:xfrm>
-            <a:off x="457200" y="1828800"/>
+            <a:off x="457200" y="1737360"/>
             <a:ext cx="3657600" cy="822960"/>
           </a:xfrm>
           <a:prstGeom prst="rect">
@@ -6760,13 +6760,13 @@
           <a:p>
             <a:pPr algn="ctr"/>
             <a:r>
-              <a:rPr sz="4400" b="1">
+              <a:rPr sz="4000" b="1">
                 <a:solidFill>
                   <a:srgbClr val="FFFFFF"/>
                 </a:solidFill>
                 <a:latin typeface="Microsoft YaHei"/>
               </a:rPr>
-              <a:t>~32 个</a:t>
+              <a:t>~30 个</a:t>
             </a:r>
           </a:p>
         </p:txBody>
@@ -6779,8 +6779,8 @@
         </p:nvSpPr>
         <p:spPr>
           <a:xfrm>
-            <a:off x="457200" y="2788920"/>
-            <a:ext cx="3657600" cy="365760"/>
+            <a:off x="457200" y="2697480"/>
+            <a:ext cx="3657600" cy="320040"/>
           </a:xfrm>
           <a:prstGeom prst="rect">
             <a:avLst/>
@@ -6801,21 +6801,56 @@
                 </a:solidFill>
                 <a:latin typeface="Microsoft YaHei"/>
               </a:rPr>
-              <a:t>UI体验 · 部署环境 · 运行时崩溃</a:t>
-            </a:r>
-          </a:p>
-        </p:txBody>
-      </p:sp>
-      <p:sp>
-        <p:nvSpPr>
-          <p:cNvPr id="8" name="Rounded Rectangle 7"/>
+              <a:t>UI 体验 · 部署环境 · 运行时崩溃</a:t>
+            </a:r>
+          </a:p>
+        </p:txBody>
+      </p:sp>
+      <p:sp>
+        <p:nvSpPr>
+          <p:cNvPr id="8" name="TextBox 7"/>
+          <p:cNvSpPr txBox="1"/>
+          <p:nvPr/>
+        </p:nvSpPr>
+        <p:spPr>
+          <a:xfrm>
+            <a:off x="457200" y="3063239"/>
+            <a:ext cx="3657600" cy="320040"/>
+          </a:xfrm>
+          <a:prstGeom prst="rect">
+            <a:avLst/>
+          </a:prstGeom>
+          <a:noFill/>
+        </p:spPr>
+        <p:txBody>
+          <a:bodyPr wrap="square" lIns="0" rIns="0" tIns="0" bIns="0">
+            <a:spAutoFit/>
+          </a:bodyPr>
+          <a:lstStyle/>
+          <a:p>
+            <a:pPr algn="ctr"/>
+            <a:r>
+              <a:rPr sz="1000" b="0">
+                <a:solidFill>
+                  <a:srgbClr val="FFFFFF"/>
+                </a:solidFill>
+                <a:latin typeface="Microsoft YaHei"/>
+              </a:rPr>
+              <a:t/>
+            </a:r>
+          </a:p>
+        </p:txBody>
+      </p:sp>
+      <p:sp>
+        <p:nvSpPr>
+          <p:cNvPr id="9" name="Rounded Rectangle 8"/>
           <p:cNvSpPr/>
           <p:nvPr/>
         </p:nvSpPr>
         <p:spPr>
           <a:xfrm>
             <a:off x="4297680" y="1188720"/>
-            <a:ext cx="3657600" cy="2103120"/>
+            <a:ext cx="3657600" cy="2286000"/>
           </a:xfrm>
           <a:prstGeom prst="roundRect">
             <a:avLst/>
@@ -6851,13 +6886,13 @@
       </p:sp>
       <p:sp>
         <p:nvSpPr>
-          <p:cNvPr id="9" name="TextBox 8"/>
+          <p:cNvPr id="10" name="TextBox 9"/>
           <p:cNvSpPr txBox="1"/>
           <p:nvPr/>
         </p:nvSpPr>
         <p:spPr>
           <a:xfrm>
-            <a:off x="4297680" y="1371600"/>
+            <a:off x="4297680" y="1325880"/>
             <a:ext cx="3657600" cy="365760"/>
           </a:xfrm>
           <a:prstGeom prst="rect">
@@ -6879,20 +6914,20 @@
                 </a:solidFill>
                 <a:latin typeface="Microsoft YaHei"/>
               </a:rPr>
-              <a:t>🔵 AI 静态审查</a:t>
-            </a:r>
-          </a:p>
-        </p:txBody>
-      </p:sp>
-      <p:sp>
-        <p:nvSpPr>
-          <p:cNvPr id="10" name="TextBox 9"/>
+              <a:t>🔵 AI #1：Claude Code</a:t>
+            </a:r>
+          </a:p>
+        </p:txBody>
+      </p:sp>
+      <p:sp>
+        <p:nvSpPr>
+          <p:cNvPr id="11" name="TextBox 10"/>
           <p:cNvSpPr txBox="1"/>
           <p:nvPr/>
         </p:nvSpPr>
         <p:spPr>
           <a:xfrm>
-            <a:off x="4297680" y="1828800"/>
+            <a:off x="4297680" y="1737360"/>
             <a:ext cx="3657600" cy="822960"/>
           </a:xfrm>
           <a:prstGeom prst="rect">
@@ -6908,7 +6943,7 @@
           <a:p>
             <a:pPr algn="ctr"/>
             <a:r>
-              <a:rPr sz="4400" b="1">
+              <a:rPr sz="4000" b="1">
                 <a:solidFill>
                   <a:srgbClr val="FFFFFF"/>
                 </a:solidFill>
@@ -6921,14 +6956,14 @@
       </p:sp>
       <p:sp>
         <p:nvSpPr>
-          <p:cNvPr id="11" name="TextBox 10"/>
+          <p:cNvPr id="12" name="TextBox 11"/>
           <p:cNvSpPr txBox="1"/>
           <p:nvPr/>
         </p:nvSpPr>
         <p:spPr>
           <a:xfrm>
-            <a:off x="4297680" y="2788920"/>
-            <a:ext cx="3657600" cy="365760"/>
+            <a:off x="4297680" y="2697480"/>
+            <a:ext cx="3657600" cy="320040"/>
           </a:xfrm>
           <a:prstGeom prst="rect">
             <a:avLst/>
@@ -6949,21 +6984,56 @@
                 </a:solidFill>
                 <a:latin typeface="Microsoft YaHei"/>
               </a:rPr>
-              <a:t>逻辑错误 · 并发 · 协议细节</a:t>
-            </a:r>
-          </a:p>
-        </p:txBody>
-      </p:sp>
-      <p:sp>
-        <p:nvSpPr>
-          <p:cNvPr id="12" name="Rounded Rectangle 11"/>
+              <a:t>全量扫描 · 跨文件链路 · 并发陷阱</a:t>
+            </a:r>
+          </a:p>
+        </p:txBody>
+      </p:sp>
+      <p:sp>
+        <p:nvSpPr>
+          <p:cNvPr id="13" name="TextBox 12"/>
+          <p:cNvSpPr txBox="1"/>
+          <p:nvPr/>
+        </p:nvSpPr>
+        <p:spPr>
+          <a:xfrm>
+            <a:off x="4297680" y="3063239"/>
+            <a:ext cx="3657600" cy="320040"/>
+          </a:xfrm>
+          <a:prstGeom prst="rect">
+            <a:avLst/>
+          </a:prstGeom>
+          <a:noFill/>
+        </p:spPr>
+        <p:txBody>
+          <a:bodyPr wrap="square" lIns="0" rIns="0" tIns="0" bIns="0">
+            <a:spAutoFit/>
+          </a:bodyPr>
+          <a:lstStyle/>
+          <a:p>
+            <a:pPr algn="ctr"/>
+            <a:r>
+              <a:rPr sz="1000" b="0">
+                <a:solidFill>
+                  <a:srgbClr val="FFFFFF"/>
+                </a:solidFill>
+                <a:latin typeface="Microsoft YaHei"/>
+              </a:rPr>
+              <a:t>claude-opus-4-7 / sonnet-4-6</a:t>
+            </a:r>
+          </a:p>
+        </p:txBody>
+      </p:sp>
+      <p:sp>
+        <p:nvSpPr>
+          <p:cNvPr id="14" name="Rounded Rectangle 13"/>
           <p:cNvSpPr/>
           <p:nvPr/>
         </p:nvSpPr>
         <p:spPr>
           <a:xfrm>
             <a:off x="8138160" y="1188720"/>
-            <a:ext cx="3657600" cy="2103120"/>
+            <a:ext cx="3657600" cy="2286000"/>
           </a:xfrm>
           <a:prstGeom prst="roundRect">
             <a:avLst/>
@@ -6999,13 +7069,13 @@
       </p:sp>
       <p:sp>
         <p:nvSpPr>
-          <p:cNvPr id="13" name="TextBox 12"/>
+          <p:cNvPr id="15" name="TextBox 14"/>
           <p:cNvSpPr txBox="1"/>
           <p:nvPr/>
         </p:nvSpPr>
         <p:spPr>
           <a:xfrm>
-            <a:off x="8138160" y="1371600"/>
+            <a:off x="8138160" y="1325880"/>
             <a:ext cx="3657600" cy="365760"/>
           </a:xfrm>
           <a:prstGeom prst="rect">
@@ -7027,20 +7097,20 @@
                 </a:solidFill>
                 <a:latin typeface="Microsoft YaHei"/>
               </a:rPr>
-              <a:t>🟡 Code Review Bot</a:t>
-            </a:r>
-          </a:p>
-        </p:txBody>
-      </p:sp>
-      <p:sp>
-        <p:nvSpPr>
-          <p:cNvPr id="14" name="TextBox 13"/>
+              <a:t>🟡 AI #2：ChatGPT Codex</a:t>
+            </a:r>
+          </a:p>
+        </p:txBody>
+      </p:sp>
+      <p:sp>
+        <p:nvSpPr>
+          <p:cNvPr id="16" name="TextBox 15"/>
           <p:cNvSpPr txBox="1"/>
           <p:nvPr/>
         </p:nvSpPr>
         <p:spPr>
           <a:xfrm>
-            <a:off x="8138160" y="1828800"/>
+            <a:off x="8138160" y="1737360"/>
             <a:ext cx="3657600" cy="822960"/>
           </a:xfrm>
           <a:prstGeom prst="rect">
@@ -7056,27 +7126,27 @@
           <a:p>
             <a:pPr algn="ctr"/>
             <a:r>
-              <a:rPr sz="4400" b="1">
+              <a:rPr sz="4000" b="1">
                 <a:solidFill>
                   <a:srgbClr val="FFFFFF"/>
                 </a:solidFill>
                 <a:latin typeface="Microsoft YaHei"/>
               </a:rPr>
-              <a:t>2 个</a:t>
-            </a:r>
-          </a:p>
-        </p:txBody>
-      </p:sp>
-      <p:sp>
-        <p:nvSpPr>
-          <p:cNvPr id="15" name="TextBox 14"/>
+              <a:t>3 个</a:t>
+            </a:r>
+          </a:p>
+        </p:txBody>
+      </p:sp>
+      <p:sp>
+        <p:nvSpPr>
+          <p:cNvPr id="17" name="TextBox 16"/>
           <p:cNvSpPr txBox="1"/>
           <p:nvPr/>
         </p:nvSpPr>
         <p:spPr>
           <a:xfrm>
-            <a:off x="8138160" y="2788920"/>
-            <a:ext cx="3657600" cy="365760"/>
+            <a:off x="8138160" y="2697480"/>
+            <a:ext cx="3657600" cy="320040"/>
           </a:xfrm>
           <a:prstGeom prst="rect">
             <a:avLst/>
@@ -7097,21 +7167,56 @@
                 </a:solidFill>
                 <a:latin typeface="Microsoft YaHei"/>
               </a:rPr>
-              <a:t>PR 自动审查额外发现</a:t>
-            </a:r>
-          </a:p>
-        </p:txBody>
-      </p:sp>
-      <p:sp>
-        <p:nvSpPr>
-          <p:cNvPr id="16" name="Rounded Rectangle 15"/>
+              <a:t>PR 自动审查 · 细粒度风险点</a:t>
+            </a:r>
+          </a:p>
+        </p:txBody>
+      </p:sp>
+      <p:sp>
+        <p:nvSpPr>
+          <p:cNvPr id="18" name="TextBox 17"/>
+          <p:cNvSpPr txBox="1"/>
+          <p:nvPr/>
+        </p:nvSpPr>
+        <p:spPr>
+          <a:xfrm>
+            <a:off x="8138160" y="3063239"/>
+            <a:ext cx="3657600" cy="320040"/>
+          </a:xfrm>
+          <a:prstGeom prst="rect">
+            <a:avLst/>
+          </a:prstGeom>
+          <a:noFill/>
+        </p:spPr>
+        <p:txBody>
+          <a:bodyPr wrap="square" lIns="0" rIns="0" tIns="0" bIns="0">
+            <a:spAutoFit/>
+          </a:bodyPr>
+          <a:lstStyle/>
+          <a:p>
+            <a:pPr algn="ctr"/>
+            <a:r>
+              <a:rPr sz="1000" b="0">
+                <a:solidFill>
+                  <a:srgbClr val="FFFFFF"/>
+                </a:solidFill>
+                <a:latin typeface="Microsoft YaHei"/>
+              </a:rPr>
+              <a:t>chatgpt-codex-connector[bot]</a:t>
+            </a:r>
+          </a:p>
+        </p:txBody>
+      </p:sp>
+      <p:sp>
+        <p:nvSpPr>
+          <p:cNvPr id="19" name="Rounded Rectangle 18"/>
           <p:cNvSpPr/>
           <p:nvPr/>
         </p:nvSpPr>
         <p:spPr>
           <a:xfrm>
-            <a:off x="457200" y="3657600"/>
-            <a:ext cx="11338560" cy="2651760"/>
+            <a:off x="457200" y="3749039"/>
+            <a:ext cx="11338560" cy="2606040"/>
           </a:xfrm>
           <a:prstGeom prst="roundRect">
             <a:avLst/>
@@ -7149,13 +7254,13 @@
       </p:sp>
       <p:sp>
         <p:nvSpPr>
-          <p:cNvPr id="17" name="TextBox 16"/>
+          <p:cNvPr id="20" name="TextBox 19"/>
           <p:cNvSpPr txBox="1"/>
           <p:nvPr/>
         </p:nvSpPr>
         <p:spPr>
           <a:xfrm>
-            <a:off x="731520" y="3840480"/>
+            <a:off x="731520" y="3931920"/>
             <a:ext cx="10972800" cy="457200"/>
           </a:xfrm>
           <a:prstGeom prst="rect">
@@ -7184,13 +7289,13 @@
       </p:sp>
       <p:sp>
         <p:nvSpPr>
-          <p:cNvPr id="18" name="TextBox 17"/>
+          <p:cNvPr id="21" name="TextBox 20"/>
           <p:cNvSpPr txBox="1"/>
           <p:nvPr/>
         </p:nvSpPr>
         <p:spPr>
           <a:xfrm>
-            <a:off x="731520" y="4389120"/>
+            <a:off x="731520" y="4434840"/>
             <a:ext cx="10972800" cy="457200"/>
           </a:xfrm>
           <a:prstGeom prst="rect">
@@ -7206,26 +7311,26 @@
           <a:p>
             <a:pPr algn="l"/>
             <a:r>
-              <a:rPr sz="1600" b="1">
+              <a:rPr sz="1400" b="1">
                 <a:solidFill>
                   <a:srgbClr val="202020"/>
                 </a:solidFill>
                 <a:latin typeface="Microsoft YaHei"/>
               </a:rPr>
-              <a:t>人工看见「症状」，AI 挖出「根因」 — 两者几乎不重叠，而是互补</a:t>
-            </a:r>
-          </a:p>
-        </p:txBody>
-      </p:sp>
-      <p:sp>
-        <p:nvSpPr>
-          <p:cNvPr id="19" name="TextBox 18"/>
+              <a:t>人工看见「症状」 · Claude 挖「根因」 · Codex 找「细节风险」 — 三者几乎不重叠</a:t>
+            </a:r>
+          </a:p>
+        </p:txBody>
+      </p:sp>
+      <p:sp>
+        <p:nvSpPr>
+          <p:cNvPr id="22" name="TextBox 21"/>
           <p:cNvSpPr txBox="1"/>
           <p:nvPr/>
         </p:nvSpPr>
         <p:spPr>
           <a:xfrm>
-            <a:off x="731520" y="4937760"/>
+            <a:off x="731520" y="4892040"/>
             <a:ext cx="10972800" cy="457200"/>
           </a:xfrm>
           <a:prstGeom prst="rect">
@@ -7241,26 +7346,26 @@
           <a:p>
             <a:pPr algn="l"/>
             <a:r>
-              <a:rPr sz="1400" b="0">
+              <a:rPr sz="1200" b="0">
                 <a:solidFill>
                   <a:srgbClr val="202020"/>
                 </a:solidFill>
                 <a:latin typeface="Microsoft YaHei"/>
               </a:rPr>
-              <a:t>·  人工：截图 / 真机崩溃 / 部署环境问题（AI 无法获知）</a:t>
-            </a:r>
-          </a:p>
-        </p:txBody>
-      </p:sp>
-      <p:sp>
-        <p:nvSpPr>
-          <p:cNvPr id="20" name="TextBox 19"/>
+              <a:t>·  人工：截图 / 真机崩溃 / 部署环境问题</a:t>
+            </a:r>
+          </a:p>
+        </p:txBody>
+      </p:sp>
+      <p:sp>
+        <p:nvSpPr>
+          <p:cNvPr id="23" name="TextBox 22"/>
           <p:cNvSpPr txBox="1"/>
           <p:nvPr/>
         </p:nvSpPr>
         <p:spPr>
           <a:xfrm>
-            <a:off x="731520" y="5349240"/>
+            <a:off x="731520" y="5212080"/>
             <a:ext cx="10972800" cy="457200"/>
           </a:xfrm>
           <a:prstGeom prst="rect">
@@ -7276,26 +7381,26 @@
           <a:p>
             <a:pPr algn="l"/>
             <a:r>
-              <a:rPr sz="1400" b="0">
+              <a:rPr sz="1200" b="0">
                 <a:solidFill>
                   <a:srgbClr val="202020"/>
                 </a:solidFill>
                 <a:latin typeface="Microsoft YaHei"/>
               </a:rPr>
-              <a:t>·  AI：跨文件链路 / 时序逻辑 / 并发陷阱（人工难以全量覆盖）</a:t>
-            </a:r>
-          </a:p>
-        </p:txBody>
-      </p:sp>
-      <p:sp>
-        <p:nvSpPr>
-          <p:cNvPr id="21" name="TextBox 20"/>
+              <a:t>·  Claude Code Agent：跨文件链路 / 并发陷阱 / 协议一致性</a:t>
+            </a:r>
+          </a:p>
+        </p:txBody>
+      </p:sp>
+      <p:sp>
+        <p:nvSpPr>
+          <p:cNvPr id="24" name="TextBox 23"/>
           <p:cNvSpPr txBox="1"/>
           <p:nvPr/>
         </p:nvSpPr>
         <p:spPr>
           <a:xfrm>
-            <a:off x="731520" y="5806440"/>
+            <a:off x="731520" y="5532120"/>
             <a:ext cx="10972800" cy="457200"/>
           </a:xfrm>
           <a:prstGeom prst="rect">
@@ -7311,20 +7416,55 @@
           <a:p>
             <a:pPr algn="l"/>
             <a:r>
-              <a:rPr sz="1400" b="0">
-                <a:solidFill>
-                  <a:srgbClr val="606060"/>
+              <a:rPr sz="1200" b="0">
+                <a:solidFill>
+                  <a:srgbClr val="202020"/>
                 </a:solidFill>
                 <a:latin typeface="Microsoft YaHei"/>
               </a:rPr>
-              <a:t>→  任何只有一方参与的流程，都会漏掉至少 40% 的问题</a:t>
-            </a:r>
-          </a:p>
-        </p:txBody>
-      </p:sp>
-      <p:sp>
-        <p:nvSpPr>
-          <p:cNvPr id="22" name="TextBox 21"/>
+              <a:t>·  ChatGPT Codex Bot：UUID 截断 / loading 卡死 / UI/服务端不一致</a:t>
+            </a:r>
+          </a:p>
+        </p:txBody>
+      </p:sp>
+      <p:sp>
+        <p:nvSpPr>
+          <p:cNvPr id="25" name="TextBox 24"/>
+          <p:cNvSpPr txBox="1"/>
+          <p:nvPr/>
+        </p:nvSpPr>
+        <p:spPr>
+          <a:xfrm>
+            <a:off x="731520" y="5897880"/>
+            <a:ext cx="10972800" cy="457200"/>
+          </a:xfrm>
+          <a:prstGeom prst="rect">
+            <a:avLst/>
+          </a:prstGeom>
+          <a:noFill/>
+        </p:spPr>
+        <p:txBody>
+          <a:bodyPr wrap="square" lIns="0" rIns="0" tIns="0" bIns="0">
+            <a:spAutoFit/>
+          </a:bodyPr>
+          <a:lstStyle/>
+          <a:p>
+            <a:pPr algn="l"/>
+            <a:r>
+              <a:rPr sz="1200" b="1">
+                <a:solidFill>
+                  <a:srgbClr val="1A73E8"/>
+                </a:solidFill>
+                <a:latin typeface="Microsoft YaHei"/>
+              </a:rPr>
+              <a:t>→  多 AI 交叉审查比单一审查更可靠</a:t>
+            </a:r>
+          </a:p>
+        </p:txBody>
+      </p:sp>
+      <p:sp>
+        <p:nvSpPr>
+          <p:cNvPr id="26" name="TextBox 25"/>
           <p:cNvSpPr txBox="1"/>
           <p:nvPr/>
         </p:nvSpPr>
@@ -8295,7 +8435,7 @@
                 </a:solidFill>
                 <a:latin typeface="Microsoft YaHei"/>
               </a:rPr>
-              <a:t>四、AI 发现的问题（~35 个，4 轮审查）</a:t>
+              <a:t>四、AI 发现的问题（~38 个）</a:t>
             </a:r>
           </a:p>
         </p:txBody>
@@ -8351,7 +8491,7 @@
         </p:nvSpPr>
         <p:spPr>
           <a:xfrm>
-            <a:off x="457200" y="960120"/>
+            <a:off x="457200" y="914400"/>
             <a:ext cx="11247120" cy="365760"/>
           </a:xfrm>
           <a:prstGeom prst="rect">
@@ -8373,22 +8513,57 @@
                 </a:solidFill>
                 <a:latin typeface="Microsoft YaHei"/>
               </a:rPr>
-              <a:t>第 1 轮：综合审查（~20 个）</a:t>
+              <a:t>🔵 AI #1：Claude Code Agent（~35 个，4 轮审查）</a:t>
+            </a:r>
+          </a:p>
+        </p:txBody>
+      </p:sp>
+      <p:sp>
+        <p:nvSpPr>
+          <p:cNvPr id="5" name="TextBox 4"/>
+          <p:cNvSpPr txBox="1"/>
+          <p:nvPr/>
+        </p:nvSpPr>
+        <p:spPr>
+          <a:xfrm>
+            <a:off x="457200" y="1280160"/>
+            <a:ext cx="11247120" cy="365760"/>
+          </a:xfrm>
+          <a:prstGeom prst="rect">
+            <a:avLst/>
+          </a:prstGeom>
+          <a:noFill/>
+        </p:spPr>
+        <p:txBody>
+          <a:bodyPr wrap="square" lIns="0" rIns="0" tIns="0" bIns="0">
+            <a:spAutoFit/>
+          </a:bodyPr>
+          <a:lstStyle/>
+          <a:p>
+            <a:pPr algn="l"/>
+            <a:r>
+              <a:rPr sz="1000" b="0">
+                <a:solidFill>
+                  <a:srgbClr val="606060"/>
+                </a:solidFill>
+                <a:latin typeface="Microsoft YaHei"/>
+              </a:rPr>
+              <a:t>模型：claude-opus-4-7（1M 上下文）+ claude-sonnet-4-6  ·  工作模式：Level 4「自查自纠」</a:t>
             </a:r>
           </a:p>
         </p:txBody>
       </p:sp>
       <p:graphicFrame>
         <p:nvGraphicFramePr>
-          <p:cNvPr id="5" name="Table 4"/>
+          <p:cNvPr id="6" name="Table 5"/>
           <p:cNvGraphicFramePr>
             <a:graphicFrameLocks noGrp="1"/>
           </p:cNvGraphicFramePr>
           <p:nvPr/>
         </p:nvGraphicFramePr>
         <p:xfrm>
-          <a:off x="457200" y="1371600"/>
-          <a:ext cx="11247120" cy="2377440"/>
+          <a:off x="457200" y="1691640"/>
+          <a:ext cx="11247120" cy="1783080"/>
         </p:xfrm>
         <a:graphic>
           <a:graphicData uri="http://schemas.openxmlformats.org/drawingml/2006/table">
@@ -8397,10 +8572,10 @@
                 <a:tableStyleId>{5C22544A-7EE6-4342-B048-85BDC9FD1C3A}</a:tableStyleId>
               </a:tblPr>
               <a:tblGrid>
-                <a:gridCol w="2560320"/>
-                <a:gridCol w="8686800"/>
+                <a:gridCol w="2743200"/>
+                <a:gridCol w="8503920"/>
               </a:tblGrid>
-              <a:tr h="396240">
+              <a:tr h="445770">
                 <a:tc>
                   <a:txBody>
                     <a:bodyPr lIns="40000" rIns="40000" tIns="15000" bIns="15000"/>
@@ -8414,7 +8589,7 @@
                           </a:solidFill>
                           <a:latin typeface="Microsoft YaHei"/>
                         </a:rPr>
-                        <a:t>类别</a:t>
+                        <a:t>审查轮次</a:t>
                       </a:r>
                     </a:p>
                   </a:txBody>
@@ -8448,21 +8623,21 @@
                   </a:tcPr>
                 </a:tc>
               </a:tr>
-              <a:tr h="396240">
-                <a:tc>
-                  <a:txBody>
-                    <a:bodyPr lIns="40000" rIns="40000" tIns="10000" bIns="10000" wrap="square"/>
-                    <a:lstStyle/>
-                    <a:p>
-                      <a:pPr algn="l"/>
-                      <a:r>
-                        <a:rPr sz="1200">
-                          <a:solidFill>
-                            <a:srgbClr val="202020"/>
-                          </a:solidFill>
-                          <a:latin typeface="Microsoft YaHei"/>
-                        </a:rPr>
-                        <a:t>协议 / 序列化 (4)</a:t>
+              <a:tr h="445770">
+                <a:tc>
+                  <a:txBody>
+                    <a:bodyPr lIns="40000" rIns="40000" tIns="10000" bIns="10000" wrap="square"/>
+                    <a:lstStyle/>
+                    <a:p>
+                      <a:pPr algn="l"/>
+                      <a:r>
+                        <a:rPr sz="1200">
+                          <a:solidFill>
+                            <a:srgbClr val="202020"/>
+                          </a:solidFill>
+                          <a:latin typeface="Microsoft YaHei"/>
+                        </a:rPr>
+                        <a:t>第 1 轮 综合审查 (~20)</a:t>
                       </a:r>
                     </a:p>
                   </a:txBody>
@@ -8485,7 +8660,7 @@
                           </a:solidFill>
                           <a:latin typeface="Microsoft YaHei"/>
                         </a:rPr>
-                        <a:t>sealed class 缺 classDiscriminator；枚举值不对齐</a:t>
+                        <a:t>协议/序列化 4 · 会话/重连 3 · 房间状态机 4 · UI/状态同步 6 · 其他 3</a:t>
                       </a:r>
                     </a:p>
                   </a:txBody>
@@ -8496,21 +8671,21 @@
                   </a:tcPr>
                 </a:tc>
               </a:tr>
-              <a:tr h="396240">
-                <a:tc>
-                  <a:txBody>
-                    <a:bodyPr lIns="40000" rIns="40000" tIns="10000" bIns="10000" wrap="square"/>
-                    <a:lstStyle/>
-                    <a:p>
-                      <a:pPr algn="l"/>
-                      <a:r>
-                        <a:rPr sz="1200">
-                          <a:solidFill>
-                            <a:srgbClr val="202020"/>
-                          </a:solidFill>
-                          <a:latin typeface="Microsoft YaHei"/>
-                        </a:rPr>
-                        <a:t>会话 / 重连 (3)</a:t>
+              <a:tr h="445770">
+                <a:tc>
+                  <a:txBody>
+                    <a:bodyPr lIns="40000" rIns="40000" tIns="10000" bIns="10000" wrap="square"/>
+                    <a:lstStyle/>
+                    <a:p>
+                      <a:pPr algn="l"/>
+                      <a:r>
+                        <a:rPr sz="1200">
+                          <a:solidFill>
+                            <a:srgbClr val="202020"/>
+                          </a:solidFill>
+                          <a:latin typeface="Microsoft YaHei"/>
+                        </a:rPr>
+                        <a:t>第 2-3 轮 深层 (~8)</a:t>
                       </a:r>
                     </a:p>
                   </a:txBody>
@@ -8533,7 +8708,7 @@
                           </a:solidFill>
                           <a:latin typeface="Microsoft YaHei"/>
                         </a:rPr>
-                        <a:t>sessionToken 未设置；leaveRoom 未清空 token</a:t>
+                        <a:t>回合错位 · ArrayList 并发 · AI 回退链缺失 · collectedScore 硬编码 0</a:t>
                       </a:r>
                     </a:p>
                   </a:txBody>
@@ -8544,21 +8719,21 @@
                   </a:tcPr>
                 </a:tc>
               </a:tr>
-              <a:tr h="396240">
-                <a:tc>
-                  <a:txBody>
-                    <a:bodyPr lIns="40000" rIns="40000" tIns="10000" bIns="10000" wrap="square"/>
-                    <a:lstStyle/>
-                    <a:p>
-                      <a:pPr algn="l"/>
-                      <a:r>
-                        <a:rPr sz="1200">
-                          <a:solidFill>
-                            <a:srgbClr val="202020"/>
-                          </a:solidFill>
-                          <a:latin typeface="Microsoft YaHei"/>
-                        </a:rPr>
-                        <a:t>房间状态机 (4)</a:t>
+              <a:tr h="445770">
+                <a:tc>
+                  <a:txBody>
+                    <a:bodyPr lIns="40000" rIns="40000" tIns="10000" bIns="10000" wrap="square"/>
+                    <a:lstStyle/>
+                    <a:p>
+                      <a:pPr algn="l"/>
+                      <a:r>
+                        <a:rPr sz="1200">
+                          <a:solidFill>
+                            <a:srgbClr val="202020"/>
+                          </a:solidFill>
+                          <a:latin typeface="Microsoft YaHei"/>
+                        </a:rPr>
+                        <a:t>第 4 轮 根因 (~7) ⭐</a:t>
                       </a:r>
                     </a:p>
                   </a:txBody>
@@ -8581,103 +8756,7 @@
                           </a:solidFill>
                           <a:latin typeface="Microsoft YaHei"/>
                         </a:rPr>
-                        <a:t>未检查 WAITING；退出不补 AI；重复加入</a:t>
-                      </a:r>
-                    </a:p>
-                  </a:txBody>
-                  <a:tcPr>
-                    <a:solidFill>
-                      <a:srgbClr val="FFFFFF"/>
-                    </a:solidFill>
-                  </a:tcPr>
-                </a:tc>
-              </a:tr>
-              <a:tr h="396240">
-                <a:tc>
-                  <a:txBody>
-                    <a:bodyPr lIns="40000" rIns="40000" tIns="10000" bIns="10000" wrap="square"/>
-                    <a:lstStyle/>
-                    <a:p>
-                      <a:pPr algn="l"/>
-                      <a:r>
-                        <a:rPr sz="1200">
-                          <a:solidFill>
-                            <a:srgbClr val="202020"/>
-                          </a:solidFill>
-                          <a:latin typeface="Microsoft YaHei"/>
-                        </a:rPr>
-                        <a:t>UI / 状态同步 (6)</a:t>
-                      </a:r>
-                    </a:p>
-                  </a:txBody>
-                  <a:tcPr>
-                    <a:solidFill>
-                      <a:srgbClr val="F0F4FF"/>
-                    </a:solidFill>
-                  </a:tcPr>
-                </a:tc>
-                <a:tc>
-                  <a:txBody>
-                    <a:bodyPr lIns="40000" rIns="40000" tIns="10000" bIns="10000" wrap="square"/>
-                    <a:lstStyle/>
-                    <a:p>
-                      <a:pPr algn="l"/>
-                      <a:r>
-                        <a:rPr sz="1200">
-                          <a:solidFill>
-                            <a:srgbClr val="202020"/>
-                          </a:solidFill>
-                          <a:latin typeface="Microsoft YaHei"/>
-                        </a:rPr>
-                        <a:t>seatIndex%2 误算；初始化未刷新；onDestroy 未 guard</a:t>
-                      </a:r>
-                    </a:p>
-                  </a:txBody>
-                  <a:tcPr>
-                    <a:solidFill>
-                      <a:srgbClr val="F0F4FF"/>
-                    </a:solidFill>
-                  </a:tcPr>
-                </a:tc>
-              </a:tr>
-              <a:tr h="396240">
-                <a:tc>
-                  <a:txBody>
-                    <a:bodyPr lIns="40000" rIns="40000" tIns="10000" bIns="10000" wrap="square"/>
-                    <a:lstStyle/>
-                    <a:p>
-                      <a:pPr algn="l"/>
-                      <a:r>
-                        <a:rPr sz="1200">
-                          <a:solidFill>
-                            <a:srgbClr val="202020"/>
-                          </a:solidFill>
-                          <a:latin typeface="Microsoft YaHei"/>
-                        </a:rPr>
-                        <a:t>其他 (3)</a:t>
-                      </a:r>
-                    </a:p>
-                  </a:txBody>
-                  <a:tcPr>
-                    <a:solidFill>
-                      <a:srgbClr val="FFFFFF"/>
-                    </a:solidFill>
-                  </a:tcPr>
-                </a:tc>
-                <a:tc>
-                  <a:txBody>
-                    <a:bodyPr lIns="40000" rIns="40000" tIns="10000" bIns="10000" wrap="square"/>
-                    <a:lstStyle/>
-                    <a:p>
-                      <a:pPr algn="l"/>
-                      <a:r>
-                        <a:rPr sz="1200">
-                          <a:solidFill>
-                            <a:srgbClr val="202020"/>
-                          </a:solidFill>
-                          <a:latin typeface="Microsoft YaHei"/>
-                        </a:rPr>
-                        <a:t>applyState 版本反向；senderId 不稳定</a:t>
+                        <a:t>WebSocket CONNECTING send() 静默失败 · 多协程无锁并发 · 结算公式漏算</a:t>
                       </a:r>
                     </a:p>
                   </a:txBody>
@@ -8694,13 +8773,13 @@
       </p:graphicFrame>
       <p:sp>
         <p:nvSpPr>
-          <p:cNvPr id="6" name="TextBox 5"/>
+          <p:cNvPr id="7" name="TextBox 6"/>
           <p:cNvSpPr txBox="1"/>
           <p:nvPr/>
         </p:nvSpPr>
         <p:spPr>
           <a:xfrm>
-            <a:off x="457200" y="3931920"/>
+            <a:off x="457200" y="3703320"/>
             <a:ext cx="11247120" cy="365760"/>
           </a:xfrm>
           <a:prstGeom prst="rect">
@@ -8718,25 +8797,25 @@
             <a:r>
               <a:rPr sz="1400" b="1">
                 <a:solidFill>
-                  <a:srgbClr val="1A73E8"/>
+                  <a:srgbClr val="F57C00"/>
                 </a:solidFill>
                 <a:latin typeface="Microsoft YaHei"/>
               </a:rPr>
-              <a:t>第 2-3 轮：深层审查（~8 个）</a:t>
-            </a:r>
-          </a:p>
-        </p:txBody>
-      </p:sp>
-      <p:sp>
-        <p:nvSpPr>
-          <p:cNvPr id="7" name="TextBox 6"/>
+              <a:t>🟡 AI #2：ChatGPT Codex Review Bot（3 个）</a:t>
+            </a:r>
+          </a:p>
+        </p:txBody>
+      </p:sp>
+      <p:sp>
+        <p:nvSpPr>
+          <p:cNvPr id="8" name="TextBox 7"/>
           <p:cNvSpPr txBox="1"/>
           <p:nvPr/>
         </p:nvSpPr>
         <p:spPr>
           <a:xfrm>
-            <a:off x="640080" y="4343400"/>
-            <a:ext cx="10972800" cy="411480"/>
+            <a:off x="457200" y="4069080"/>
+            <a:ext cx="11247120" cy="365760"/>
           </a:xfrm>
           <a:prstGeom prst="rect">
             <a:avLst/>
@@ -8751,118 +8830,564 @@
           <a:p>
             <a:pPr algn="l"/>
             <a:r>
-              <a:rPr sz="1200" b="0">
-                <a:solidFill>
-                  <a:srgbClr val="202020"/>
+              <a:rPr sz="1000" b="0">
+                <a:solidFill>
+                  <a:srgbClr val="606060"/>
                 </a:solidFill>
                 <a:latin typeface="Microsoft YaHei"/>
               </a:rPr>
-              <a:t>·  赢家未设为下轮首家  ·  ArrayList 并发修改  ·  AI 回退链缺失  ·  collectedScore 硬编码 0</a:t>
-            </a:r>
-          </a:p>
-        </p:txBody>
-      </p:sp>
-      <p:sp>
-        <p:nvSpPr>
-          <p:cNvPr id="8" name="TextBox 7"/>
-          <p:cNvSpPr txBox="1"/>
-          <p:nvPr/>
-        </p:nvSpPr>
-        <p:spPr>
-          <a:xfrm>
-            <a:off x="457200" y="4937760"/>
-            <a:ext cx="11247120" cy="365760"/>
-          </a:xfrm>
-          <a:prstGeom prst="rect">
+              <a:t>Agent：chatgpt-codex-connector[bot]  ·  PR 自动审查触发  ·  按 P1/P2 标注优先级</a:t>
+            </a:r>
+          </a:p>
+        </p:txBody>
+      </p:sp>
+      <p:graphicFrame>
+        <p:nvGraphicFramePr>
+          <p:cNvPr id="9" name="Table 8"/>
+          <p:cNvGraphicFramePr>
+            <a:graphicFrameLocks noGrp="1"/>
+          </p:cNvGraphicFramePr>
+          <p:nvPr/>
+        </p:nvGraphicFramePr>
+        <p:xfrm>
+          <a:off x="457200" y="4526280"/>
+          <a:ext cx="11247120" cy="1463040"/>
+        </p:xfrm>
+        <a:graphic>
+          <a:graphicData uri="http://schemas.openxmlformats.org/drawingml/2006/table">
+            <a:tbl>
+              <a:tblPr firstRow="1" bandRow="1">
+                <a:tableStyleId>{5C22544A-7EE6-4342-B048-85BDC9FD1C3A}</a:tableStyleId>
+              </a:tblPr>
+              <a:tblGrid>
+                <a:gridCol w="731520"/>
+                <a:gridCol w="822960"/>
+                <a:gridCol w="2194560"/>
+                <a:gridCol w="5029200"/>
+                <a:gridCol w="2468880"/>
+              </a:tblGrid>
+              <a:tr h="365760">
+                <a:tc>
+                  <a:txBody>
+                    <a:bodyPr lIns="40000" rIns="40000" tIns="15000" bIns="15000"/>
+                    <a:lstStyle/>
+                    <a:p>
+                      <a:pPr algn="ctr"/>
+                      <a:r>
+                        <a:rPr sz="1200" b="1">
+                          <a:solidFill>
+                            <a:srgbClr val="FFFFFF"/>
+                          </a:solidFill>
+                          <a:latin typeface="Microsoft YaHei"/>
+                        </a:rPr>
+                        <a:t>PR</a:t>
+                      </a:r>
+                    </a:p>
+                  </a:txBody>
+                  <a:tcPr>
+                    <a:solidFill>
+                      <a:srgbClr val="F57C00"/>
+                    </a:solidFill>
+                  </a:tcPr>
+                </a:tc>
+                <a:tc>
+                  <a:txBody>
+                    <a:bodyPr lIns="40000" rIns="40000" tIns="15000" bIns="15000"/>
+                    <a:lstStyle/>
+                    <a:p>
+                      <a:pPr algn="ctr"/>
+                      <a:r>
+                        <a:rPr sz="1200" b="1">
+                          <a:solidFill>
+                            <a:srgbClr val="FFFFFF"/>
+                          </a:solidFill>
+                          <a:latin typeface="Microsoft YaHei"/>
+                        </a:rPr>
+                        <a:t>优先级</a:t>
+                      </a:r>
+                    </a:p>
+                  </a:txBody>
+                  <a:tcPr>
+                    <a:solidFill>
+                      <a:srgbClr val="F57C00"/>
+                    </a:solidFill>
+                  </a:tcPr>
+                </a:tc>
+                <a:tc>
+                  <a:txBody>
+                    <a:bodyPr lIns="40000" rIns="40000" tIns="15000" bIns="15000"/>
+                    <a:lstStyle/>
+                    <a:p>
+                      <a:pPr algn="ctr"/>
+                      <a:r>
+                        <a:rPr sz="1200" b="1">
+                          <a:solidFill>
+                            <a:srgbClr val="FFFFFF"/>
+                          </a:solidFill>
+                          <a:latin typeface="Microsoft YaHei"/>
+                        </a:rPr>
+                        <a:t>位置</a:t>
+                      </a:r>
+                    </a:p>
+                  </a:txBody>
+                  <a:tcPr>
+                    <a:solidFill>
+                      <a:srgbClr val="F57C00"/>
+                    </a:solidFill>
+                  </a:tcPr>
+                </a:tc>
+                <a:tc>
+                  <a:txBody>
+                    <a:bodyPr lIns="40000" rIns="40000" tIns="15000" bIns="15000"/>
+                    <a:lstStyle/>
+                    <a:p>
+                      <a:pPr algn="ctr"/>
+                      <a:r>
+                        <a:rPr sz="1200" b="1">
+                          <a:solidFill>
+                            <a:srgbClr val="FFFFFF"/>
+                          </a:solidFill>
+                          <a:latin typeface="Microsoft YaHei"/>
+                        </a:rPr>
+                        <a:t>意见</a:t>
+                      </a:r>
+                    </a:p>
+                  </a:txBody>
+                  <a:tcPr>
+                    <a:solidFill>
+                      <a:srgbClr val="F57C00"/>
+                    </a:solidFill>
+                  </a:tcPr>
+                </a:tc>
+                <a:tc>
+                  <a:txBody>
+                    <a:bodyPr lIns="40000" rIns="40000" tIns="15000" bIns="15000"/>
+                    <a:lstStyle/>
+                    <a:p>
+                      <a:pPr algn="ctr"/>
+                      <a:r>
+                        <a:rPr sz="1200" b="1">
+                          <a:solidFill>
+                            <a:srgbClr val="FFFFFF"/>
+                          </a:solidFill>
+                          <a:latin typeface="Microsoft YaHei"/>
+                        </a:rPr>
+                        <a:t>处置</a:t>
+                      </a:r>
+                    </a:p>
+                  </a:txBody>
+                  <a:tcPr>
+                    <a:solidFill>
+                      <a:srgbClr val="F57C00"/>
+                    </a:solidFill>
+                  </a:tcPr>
+                </a:tc>
+              </a:tr>
+              <a:tr h="365760">
+                <a:tc>
+                  <a:txBody>
+                    <a:bodyPr lIns="40000" rIns="40000" tIns="10000" bIns="10000" wrap="square"/>
+                    <a:lstStyle/>
+                    <a:p>
+                      <a:pPr algn="l"/>
+                      <a:r>
+                        <a:rPr sz="1200">
+                          <a:solidFill>
+                            <a:srgbClr val="202020"/>
+                          </a:solidFill>
+                          <a:latin typeface="Microsoft YaHei"/>
+                        </a:rPr>
+                        <a:t>#29</a:t>
+                      </a:r>
+                    </a:p>
+                  </a:txBody>
+                  <a:tcPr>
+                    <a:solidFill>
+                      <a:srgbClr val="FFFFFF"/>
+                    </a:solidFill>
+                  </a:tcPr>
+                </a:tc>
+                <a:tc>
+                  <a:txBody>
+                    <a:bodyPr lIns="40000" rIns="40000" tIns="10000" bIns="10000" wrap="square"/>
+                    <a:lstStyle/>
+                    <a:p>
+                      <a:pPr algn="l"/>
+                      <a:r>
+                        <a:rPr sz="1200">
+                          <a:solidFill>
+                            <a:srgbClr val="202020"/>
+                          </a:solidFill>
+                          <a:latin typeface="Microsoft YaHei"/>
+                        </a:rPr>
+                        <a:t>P1</a:t>
+                      </a:r>
+                    </a:p>
+                  </a:txBody>
+                  <a:tcPr>
+                    <a:solidFill>
+                      <a:srgbClr val="FFFFFF"/>
+                    </a:solidFill>
+                  </a:tcPr>
+                </a:tc>
+                <a:tc>
+                  <a:txBody>
+                    <a:bodyPr lIns="40000" rIns="40000" tIns="10000" bIns="10000" wrap="square"/>
+                    <a:lstStyle/>
+                    <a:p>
+                      <a:pPr algn="l"/>
+                      <a:r>
+                        <a:rPr sz="1200">
+                          <a:solidFill>
+                            <a:srgbClr val="202020"/>
+                          </a:solidFill>
+                          <a:latin typeface="Microsoft YaHei"/>
+                        </a:rPr>
+                        <a:t>Application.kt:48</a:t>
+                      </a:r>
+                    </a:p>
+                  </a:txBody>
+                  <a:tcPr>
+                    <a:solidFill>
+                      <a:srgbClr val="FFFFFF"/>
+                    </a:solidFill>
+                  </a:tcPr>
+                </a:tc>
+                <a:tc>
+                  <a:txBody>
+                    <a:bodyPr lIns="40000" rIns="40000" tIns="10000" bIns="10000" wrap="square"/>
+                    <a:lstStyle/>
+                    <a:p>
+                      <a:pPr algn="l"/>
+                      <a:r>
+                        <a:rPr sz="1200">
+                          <a:solidFill>
+                            <a:srgbClr val="202020"/>
+                          </a:solidFill>
+                          <a:latin typeface="Microsoft YaHei"/>
+                        </a:rPr>
+                        <a:t>UUID 截断到 8 字符 → 碰撞致跨用户混乱</a:t>
+                      </a:r>
+                    </a:p>
+                  </a:txBody>
+                  <a:tcPr>
+                    <a:solidFill>
+                      <a:srgbClr val="FFFFFF"/>
+                    </a:solidFill>
+                  </a:tcPr>
+                </a:tc>
+                <a:tc>
+                  <a:txBody>
+                    <a:bodyPr lIns="40000" rIns="40000" tIns="10000" bIns="10000" wrap="square"/>
+                    <a:lstStyle/>
+                    <a:p>
+                      <a:pPr algn="l"/>
+                      <a:r>
+                        <a:rPr sz="1200">
+                          <a:solidFill>
+                            <a:srgbClr val="202020"/>
+                          </a:solidFill>
+                          <a:latin typeface="Microsoft YaHei"/>
+                        </a:rPr>
+                        <a:t>❌→✅ 本次修复</a:t>
+                      </a:r>
+                    </a:p>
+                  </a:txBody>
+                  <a:tcPr>
+                    <a:solidFill>
+                      <a:srgbClr val="FFFFFF"/>
+                    </a:solidFill>
+                  </a:tcPr>
+                </a:tc>
+              </a:tr>
+              <a:tr h="365760">
+                <a:tc>
+                  <a:txBody>
+                    <a:bodyPr lIns="40000" rIns="40000" tIns="10000" bIns="10000" wrap="square"/>
+                    <a:lstStyle/>
+                    <a:p>
+                      <a:pPr algn="l"/>
+                      <a:r>
+                        <a:rPr sz="1200">
+                          <a:solidFill>
+                            <a:srgbClr val="202020"/>
+                          </a:solidFill>
+                          <a:latin typeface="Microsoft YaHei"/>
+                        </a:rPr>
+                        <a:t>#31</a:t>
+                      </a:r>
+                    </a:p>
+                  </a:txBody>
+                  <a:tcPr>
+                    <a:solidFill>
+                      <a:srgbClr val="F0F4FF"/>
+                    </a:solidFill>
+                  </a:tcPr>
+                </a:tc>
+                <a:tc>
+                  <a:txBody>
+                    <a:bodyPr lIns="40000" rIns="40000" tIns="10000" bIns="10000" wrap="square"/>
+                    <a:lstStyle/>
+                    <a:p>
+                      <a:pPr algn="l"/>
+                      <a:r>
+                        <a:rPr sz="1200">
+                          <a:solidFill>
+                            <a:srgbClr val="202020"/>
+                          </a:solidFill>
+                          <a:latin typeface="Microsoft YaHei"/>
+                        </a:rPr>
+                        <a:t>P1</a:t>
+                      </a:r>
+                    </a:p>
+                  </a:txBody>
+                  <a:tcPr>
+                    <a:solidFill>
+                      <a:srgbClr val="F0F4FF"/>
+                    </a:solidFill>
+                  </a:tcPr>
+                </a:tc>
+                <a:tc>
+                  <a:txBody>
+                    <a:bodyPr lIns="40000" rIns="40000" tIns="10000" bIns="10000" wrap="square"/>
+                    <a:lstStyle/>
+                    <a:p>
+                      <a:pPr algn="l"/>
+                      <a:r>
+                        <a:rPr sz="1200">
+                          <a:solidFill>
+                            <a:srgbClr val="202020"/>
+                          </a:solidFill>
+                          <a:latin typeface="Microsoft YaHei"/>
+                        </a:rPr>
+                        <a:t>LobbyActivity.kt:219</a:t>
+                      </a:r>
+                    </a:p>
+                  </a:txBody>
+                  <a:tcPr>
+                    <a:solidFill>
+                      <a:srgbClr val="F0F4FF"/>
+                    </a:solidFill>
+                  </a:tcPr>
+                </a:tc>
+                <a:tc>
+                  <a:txBody>
+                    <a:bodyPr lIns="40000" rIns="40000" tIns="10000" bIns="10000" wrap="square"/>
+                    <a:lstStyle/>
+                    <a:p>
+                      <a:pPr algn="l"/>
+                      <a:r>
+                        <a:rPr sz="1200">
+                          <a:solidFill>
+                            <a:srgbClr val="202020"/>
+                          </a:solidFill>
+                          <a:latin typeface="Microsoft YaHei"/>
+                        </a:rPr>
+                        <a:t>重连后 loading 遮罩可能永久卡住</a:t>
+                      </a:r>
+                    </a:p>
+                  </a:txBody>
+                  <a:tcPr>
+                    <a:solidFill>
+                      <a:srgbClr val="F0F4FF"/>
+                    </a:solidFill>
+                  </a:tcPr>
+                </a:tc>
+                <a:tc>
+                  <a:txBody>
+                    <a:bodyPr lIns="40000" rIns="40000" tIns="10000" bIns="10000" wrap="square"/>
+                    <a:lstStyle/>
+                    <a:p>
+                      <a:pPr algn="l"/>
+                      <a:r>
+                        <a:rPr sz="1200">
+                          <a:solidFill>
+                            <a:srgbClr val="202020"/>
+                          </a:solidFill>
+                          <a:latin typeface="Microsoft YaHei"/>
+                        </a:rPr>
+                        <a:t>✅ PR #33 已修复</a:t>
+                      </a:r>
+                    </a:p>
+                  </a:txBody>
+                  <a:tcPr>
+                    <a:solidFill>
+                      <a:srgbClr val="F0F4FF"/>
+                    </a:solidFill>
+                  </a:tcPr>
+                </a:tc>
+              </a:tr>
+              <a:tr h="365760">
+                <a:tc>
+                  <a:txBody>
+                    <a:bodyPr lIns="40000" rIns="40000" tIns="10000" bIns="10000" wrap="square"/>
+                    <a:lstStyle/>
+                    <a:p>
+                      <a:pPr algn="l"/>
+                      <a:r>
+                        <a:rPr sz="1200">
+                          <a:solidFill>
+                            <a:srgbClr val="202020"/>
+                          </a:solidFill>
+                          <a:latin typeface="Microsoft YaHei"/>
+                        </a:rPr>
+                        <a:t>#33</a:t>
+                      </a:r>
+                    </a:p>
+                  </a:txBody>
+                  <a:tcPr>
+                    <a:solidFill>
+                      <a:srgbClr val="FFFFFF"/>
+                    </a:solidFill>
+                  </a:tcPr>
+                </a:tc>
+                <a:tc>
+                  <a:txBody>
+                    <a:bodyPr lIns="40000" rIns="40000" tIns="10000" bIns="10000" wrap="square"/>
+                    <a:lstStyle/>
+                    <a:p>
+                      <a:pPr algn="l"/>
+                      <a:r>
+                        <a:rPr sz="1200">
+                          <a:solidFill>
+                            <a:srgbClr val="202020"/>
+                          </a:solidFill>
+                          <a:latin typeface="Microsoft YaHei"/>
+                        </a:rPr>
+                        <a:t>P2</a:t>
+                      </a:r>
+                    </a:p>
+                  </a:txBody>
+                  <a:tcPr>
+                    <a:solidFill>
+                      <a:srgbClr val="FFFFFF"/>
+                    </a:solidFill>
+                  </a:tcPr>
+                </a:tc>
+                <a:tc>
+                  <a:txBody>
+                    <a:bodyPr lIns="40000" rIns="40000" tIns="10000" bIns="10000" wrap="square"/>
+                    <a:lstStyle/>
+                    <a:p>
+                      <a:pPr algn="l"/>
+                      <a:r>
+                        <a:rPr sz="1200">
+                          <a:solidFill>
+                            <a:srgbClr val="202020"/>
+                          </a:solidFill>
+                          <a:latin typeface="Microsoft YaHei"/>
+                        </a:rPr>
+                        <a:t>MainActivity.kt</a:t>
+                      </a:r>
+                    </a:p>
+                  </a:txBody>
+                  <a:tcPr>
+                    <a:solidFill>
+                      <a:srgbClr val="FFFFFF"/>
+                    </a:solidFill>
+                  </a:tcPr>
+                </a:tc>
+                <a:tc>
+                  <a:txBody>
+                    <a:bodyPr lIns="40000" rIns="40000" tIns="10000" bIns="10000" wrap="square"/>
+                    <a:lstStyle/>
+                    <a:p>
+                      <a:pPr algn="l"/>
+                      <a:r>
+                        <a:rPr sz="1200">
+                          <a:solidFill>
+                            <a:srgbClr val="202020"/>
+                          </a:solidFill>
+                          <a:latin typeface="Microsoft YaHei"/>
+                        </a:rPr>
+                        <a:t>UI 提示按房间名加入但服务端不支持</a:t>
+                      </a:r>
+                    </a:p>
+                  </a:txBody>
+                  <a:tcPr>
+                    <a:solidFill>
+                      <a:srgbClr val="FFFFFF"/>
+                    </a:solidFill>
+                  </a:tcPr>
+                </a:tc>
+                <a:tc>
+                  <a:txBody>
+                    <a:bodyPr lIns="40000" rIns="40000" tIns="10000" bIns="10000" wrap="square"/>
+                    <a:lstStyle/>
+                    <a:p>
+                      <a:pPr algn="l"/>
+                      <a:r>
+                        <a:rPr sz="1200">
+                          <a:solidFill>
+                            <a:srgbClr val="202020"/>
+                          </a:solidFill>
+                          <a:latin typeface="Microsoft YaHei"/>
+                        </a:rPr>
+                        <a:t>✅ UI 重构后修复</a:t>
+                      </a:r>
+                    </a:p>
+                  </a:txBody>
+                  <a:tcPr>
+                    <a:solidFill>
+                      <a:srgbClr val="FFFFFF"/>
+                    </a:solidFill>
+                  </a:tcPr>
+                </a:tc>
+              </a:tr>
+            </a:tbl>
+          </a:graphicData>
+        </a:graphic>
+      </p:graphicFrame>
+      <p:sp>
+        <p:nvSpPr>
+          <p:cNvPr id="10" name="Rounded Rectangle 9"/>
+          <p:cNvSpPr/>
+          <p:nvPr/>
+        </p:nvSpPr>
+        <p:spPr>
+          <a:xfrm>
+            <a:off x="457200" y="6126480"/>
+            <a:ext cx="11338560" cy="502920"/>
+          </a:xfrm>
+          <a:prstGeom prst="roundRect">
             <a:avLst/>
           </a:prstGeom>
-          <a:noFill/>
-        </p:spPr>
-        <p:txBody>
-          <a:bodyPr wrap="square" lIns="0" rIns="0" tIns="0" bIns="0">
-            <a:spAutoFit/>
-          </a:bodyPr>
-          <a:lstStyle/>
-          <a:p>
-            <a:pPr algn="l"/>
-            <a:r>
-              <a:rPr sz="1400" b="1">
-                <a:solidFill>
-                  <a:srgbClr val="E53935"/>
+          <a:solidFill>
+            <a:srgbClr val="F0F4FF"/>
+          </a:solidFill>
+          <a:ln>
+            <a:solidFill>
+              <a:srgbClr val="1A73E8"/>
+            </a:solidFill>
+          </a:ln>
+        </p:spPr>
+        <p:style>
+          <a:lnRef idx="1">
+            <a:schemeClr val="accent1"/>
+          </a:lnRef>
+          <a:fillRef idx="3">
+            <a:schemeClr val="accent1"/>
+          </a:fillRef>
+          <a:effectRef idx="2">
+            <a:schemeClr val="accent1"/>
+          </a:effectRef>
+          <a:fontRef idx="minor">
+            <a:schemeClr val="lt1"/>
+          </a:fontRef>
+        </p:style>
+        <p:txBody>
+          <a:bodyPr rtlCol="0" anchor="ctr" wrap="square" lIns="150000" rIns="150000"/>
+          <a:lstStyle/>
+          <a:p>
+            <a:pPr algn="ctr"/>
+            <a:r>
+              <a:rPr sz="1200" b="1">
+                <a:solidFill>
+                  <a:srgbClr val="1A73E8"/>
                 </a:solidFill>
                 <a:latin typeface="Microsoft YaHei"/>
               </a:rPr>
-              <a:t>第 4 轮：根因专项（~7 个） — 这一轮才挖到真正的卡死根因</a:t>
-            </a:r>
-          </a:p>
-        </p:txBody>
-      </p:sp>
-      <p:sp>
-        <p:nvSpPr>
-          <p:cNvPr id="9" name="TextBox 8"/>
-          <p:cNvSpPr txBox="1"/>
-          <p:nvPr/>
-        </p:nvSpPr>
-        <p:spPr>
-          <a:xfrm>
-            <a:off x="640080" y="5349240"/>
-            <a:ext cx="10972800" cy="411480"/>
-          </a:xfrm>
-          <a:prstGeom prst="rect">
-            <a:avLst/>
-          </a:prstGeom>
-          <a:noFill/>
-        </p:spPr>
-        <p:txBody>
-          <a:bodyPr wrap="square" lIns="0" rIns="0" tIns="0" bIns="0">
-            <a:spAutoFit/>
-          </a:bodyPr>
-          <a:lstStyle/>
-          <a:p>
-            <a:pPr algn="l"/>
-            <a:r>
-              <a:rPr sz="1200" b="0">
-                <a:solidFill>
-                  <a:srgbClr val="202020"/>
-                </a:solidFill>
-                <a:latin typeface="Microsoft YaHei"/>
-              </a:rPr>
-              <a:t>·  WebSocket CONNECTING 时 send() 静默失败（重连根因）</a:t>
-            </a:r>
-          </a:p>
-        </p:txBody>
-      </p:sp>
-      <p:sp>
-        <p:nvSpPr>
-          <p:cNvPr id="10" name="TextBox 9"/>
-          <p:cNvSpPr txBox="1"/>
-          <p:nvPr/>
-        </p:nvSpPr>
-        <p:spPr>
-          <a:xfrm>
-            <a:off x="640080" y="5715000"/>
-            <a:ext cx="10972800" cy="411480"/>
-          </a:xfrm>
-          <a:prstGeom prst="rect">
-            <a:avLst/>
-          </a:prstGeom>
-          <a:noFill/>
-        </p:spPr>
-        <p:txBody>
-          <a:bodyPr wrap="square" lIns="0" rIns="0" tIns="0" bIns="0">
-            <a:spAutoFit/>
-          </a:bodyPr>
-          <a:lstStyle/>
-          <a:p>
-            <a:pPr algn="l"/>
-            <a:r>
-              <a:rPr sz="1200" b="0">
-                <a:solidFill>
-                  <a:srgbClr val="202020"/>
-                </a:solidFill>
-                <a:latin typeface="Microsoft YaHei"/>
-              </a:rPr>
-              <a:t>·  多协程无锁并发写 state.hands（卡死根因）</a:t>
+              <a:t>💡 关键观察：Claude 偏向「全局逻辑链路」 vs Codex 偏向「细粒度风险点」 — 两 AI 几乎不重叠</a:t>
             </a:r>
           </a:p>
         </p:txBody>
@@ -8870,41 +9395,6 @@
       <p:sp>
         <p:nvSpPr>
           <p:cNvPr id="11" name="TextBox 10"/>
-          <p:cNvSpPr txBox="1"/>
-          <p:nvPr/>
-        </p:nvSpPr>
-        <p:spPr>
-          <a:xfrm>
-            <a:off x="640080" y="6080760"/>
-            <a:ext cx="10972800" cy="411480"/>
-          </a:xfrm>
-          <a:prstGeom prst="rect">
-            <a:avLst/>
-          </a:prstGeom>
-          <a:noFill/>
-        </p:spPr>
-        <p:txBody>
-          <a:bodyPr wrap="square" lIns="0" rIns="0" tIns="0" bIns="0">
-            <a:spAutoFit/>
-          </a:bodyPr>
-          <a:lstStyle/>
-          <a:p>
-            <a:pPr algn="l"/>
-            <a:r>
-              <a:rPr sz="1200" b="0">
-                <a:solidFill>
-                  <a:srgbClr val="202020"/>
-                </a:solidFill>
-                <a:latin typeface="Microsoft YaHei"/>
-              </a:rPr>
-              <a:t>·  playerScores 整体缺失  ·  结算公式漏算输方未走完已收分</a:t>
-            </a:r>
-          </a:p>
-        </p:txBody>
-      </p:sp>
-      <p:sp>
-        <p:nvSpPr>
-          <p:cNvPr id="12" name="TextBox 11"/>
           <p:cNvSpPr txBox="1"/>
           <p:nvPr/>
         </p:nvSpPr>

</xml_diff>

<commit_message>
docs: add chapter on AI quality improvement via multi-Claude collab
Markdown — new Chapter 8:
  · 8.1 Why AI-generated code has bugs (5 reasons) + why multi-round
        review keeps finding new issues (4 reasons)
  · 8.2 Five multi-Claude collaboration patterns (fresh-context,
        generator/reviewer split, adversarial, TDD reverse, self-consistency)
  · 8.3 Coverage ceiling: correlated blind spots within Claude family
  · 8.4 Cross-vendor strategy comparison + recommended workflow
  · 8.5 Time vs perspective vs heterogeneity for coverage

PPT — 3 new slides (now 13 total):
  · Slide 9: Why AI code has bugs (5 root causes) + why multi-round
             still finds new (4 reasons)
  · Slide 10: 3 Claude models + 5 collaboration patterns
  · Slide 11: Coverage ceiling + cross-vendor matrix + recommended
              workflow for this project

Agenda updated to 7 chapters; existing slides 12+13 renumbered.

https://claude.ai/code/session_018awhBNLzA8t49GoT2mPYxD
</commit_message>
<xml_diff>
--- a/docs/dev_summary.pptx
+++ b/docs/dev_summary.pptx
@@ -15,6 +15,9 @@
     <p:sldId id="263" r:id="rId14"/>
     <p:sldId id="264" r:id="rId15"/>
     <p:sldId id="265" r:id="rId16"/>
+    <p:sldId id="266" r:id="rId17"/>
+    <p:sldId id="267" r:id="rId18"/>
+    <p:sldId id="268" r:id="rId19"/>
   </p:sldIdLst>
   <p:sldSz cx="12191695" cy="6858000" type="screen4x3"/>
   <p:notesSz cx="6858000" cy="9144000"/>
@@ -3380,7 +3383,42 @@
                 </a:solidFill>
                 <a:latin typeface="Microsoft YaHei"/>
               </a:rPr>
-              <a:t>⑤  关键技术修复    ⑥  经验总结与后续行动</a:t>
+              <a:t>⑤  AI 质量改进路径：多 Claude 协同 + 跨 vendor</a:t>
+            </a:r>
+          </a:p>
+        </p:txBody>
+      </p:sp>
+      <p:sp>
+        <p:nvSpPr>
+          <p:cNvPr id="10" name="TextBox 9"/>
+          <p:cNvSpPr txBox="1"/>
+          <p:nvPr/>
+        </p:nvSpPr>
+        <p:spPr>
+          <a:xfrm>
+            <a:off x="914400" y="5486400"/>
+            <a:ext cx="10058400" cy="365760"/>
+          </a:xfrm>
+          <a:prstGeom prst="rect">
+            <a:avLst/>
+          </a:prstGeom>
+          <a:noFill/>
+        </p:spPr>
+        <p:txBody>
+          <a:bodyPr wrap="square" lIns="0" rIns="0" tIns="0" bIns="0">
+            <a:spAutoFit/>
+          </a:bodyPr>
+          <a:lstStyle/>
+          <a:p>
+            <a:pPr algn="l"/>
+            <a:r>
+              <a:rPr sz="1400" b="0">
+                <a:solidFill>
+                  <a:srgbClr val="202020"/>
+                </a:solidFill>
+                <a:latin typeface="Microsoft YaHei"/>
+              </a:rPr>
+              <a:t>⑥  关键技术修复    ⑦  经验总结与后续行动</a:t>
             </a:r>
           </a:p>
         </p:txBody>
@@ -3433,7 +3471,2298 @@
                 </a:solidFill>
                 <a:latin typeface="Microsoft YaHei"/>
               </a:rPr>
-              <a:t>七、经验总结 &amp; 后续行动</a:t>
+              <a:t>六、多 Claude 模型协同的 5 种模式</a:t>
+            </a:r>
+          </a:p>
+        </p:txBody>
+      </p:sp>
+      <p:sp>
+        <p:nvSpPr>
+          <p:cNvPr id="3" name="Rectangle 2"/>
+          <p:cNvSpPr/>
+          <p:nvPr/>
+        </p:nvSpPr>
+        <p:spPr>
+          <a:xfrm>
+            <a:off x="457200" y="777240"/>
+            <a:ext cx="11247120" cy="36576"/>
+          </a:xfrm>
+          <a:prstGeom prst="rect">
+            <a:avLst/>
+          </a:prstGeom>
+          <a:solidFill>
+            <a:srgbClr val="1A73E8"/>
+          </a:solidFill>
+          <a:ln>
+            <a:noFill/>
+          </a:ln>
+        </p:spPr>
+        <p:style>
+          <a:lnRef idx="1">
+            <a:schemeClr val="accent1"/>
+          </a:lnRef>
+          <a:fillRef idx="3">
+            <a:schemeClr val="accent1"/>
+          </a:fillRef>
+          <a:effectRef idx="2">
+            <a:schemeClr val="accent1"/>
+          </a:effectRef>
+          <a:fontRef idx="minor">
+            <a:schemeClr val="lt1"/>
+          </a:fontRef>
+        </p:style>
+        <p:txBody>
+          <a:bodyPr rtlCol="0" anchor="ctr"/>
+          <a:lstStyle/>
+          <a:p>
+            <a:pPr algn="ctr"/>
+          </a:p>
+        </p:txBody>
+      </p:sp>
+      <p:sp>
+        <p:nvSpPr>
+          <p:cNvPr id="4" name="TextBox 3"/>
+          <p:cNvSpPr txBox="1"/>
+          <p:nvPr/>
+        </p:nvSpPr>
+        <p:spPr>
+          <a:xfrm>
+            <a:off x="457200" y="914400"/>
+            <a:ext cx="11247120" cy="365760"/>
+          </a:xfrm>
+          <a:prstGeom prst="rect">
+            <a:avLst/>
+          </a:prstGeom>
+          <a:noFill/>
+        </p:spPr>
+        <p:txBody>
+          <a:bodyPr wrap="square" lIns="0" rIns="0" tIns="0" bIns="0">
+            <a:spAutoFit/>
+          </a:bodyPr>
+          <a:lstStyle/>
+          <a:p>
+            <a:pPr algn="l"/>
+            <a:r>
+              <a:rPr sz="1400" b="1">
+                <a:solidFill>
+                  <a:srgbClr val="1A73E8"/>
+                </a:solidFill>
+                <a:latin typeface="Microsoft YaHei"/>
+              </a:rPr>
+              <a:t>可用模型</a:t>
+            </a:r>
+          </a:p>
+        </p:txBody>
+      </p:sp>
+      <p:graphicFrame>
+        <p:nvGraphicFramePr>
+          <p:cNvPr id="5" name="Table 4"/>
+          <p:cNvGraphicFramePr>
+            <a:graphicFrameLocks noGrp="1"/>
+          </p:cNvGraphicFramePr>
+          <p:nvPr/>
+        </p:nvGraphicFramePr>
+        <p:xfrm>
+          <a:off x="457200" y="1325880"/>
+          <a:ext cx="11247120" cy="1463040"/>
+        </p:xfrm>
+        <a:graphic>
+          <a:graphicData uri="http://schemas.openxmlformats.org/drawingml/2006/table">
+            <a:tbl>
+              <a:tblPr firstRow="1" bandRow="1">
+                <a:tableStyleId>{5C22544A-7EE6-4342-B048-85BDC9FD1C3A}</a:tableStyleId>
+              </a:tblPr>
+              <a:tblGrid>
+                <a:gridCol w="2743200"/>
+                <a:gridCol w="4114800"/>
+                <a:gridCol w="4389120"/>
+              </a:tblGrid>
+              <a:tr h="365760">
+                <a:tc>
+                  <a:txBody>
+                    <a:bodyPr lIns="40000" rIns="40000" tIns="15000" bIns="15000"/>
+                    <a:lstStyle/>
+                    <a:p>
+                      <a:pPr algn="ctr"/>
+                      <a:r>
+                        <a:rPr sz="1200" b="1">
+                          <a:solidFill>
+                            <a:srgbClr val="FFFFFF"/>
+                          </a:solidFill>
+                          <a:latin typeface="Microsoft YaHei"/>
+                        </a:rPr>
+                        <a:t>模型</a:t>
+                      </a:r>
+                    </a:p>
+                  </a:txBody>
+                  <a:tcPr>
+                    <a:solidFill>
+                      <a:srgbClr val="1A73E8"/>
+                    </a:solidFill>
+                  </a:tcPr>
+                </a:tc>
+                <a:tc>
+                  <a:txBody>
+                    <a:bodyPr lIns="40000" rIns="40000" tIns="15000" bIns="15000"/>
+                    <a:lstStyle/>
+                    <a:p>
+                      <a:pPr algn="ctr"/>
+                      <a:r>
+                        <a:rPr sz="1200" b="1">
+                          <a:solidFill>
+                            <a:srgbClr val="FFFFFF"/>
+                          </a:solidFill>
+                          <a:latin typeface="Microsoft YaHei"/>
+                        </a:rPr>
+                        <a:t>特点</a:t>
+                      </a:r>
+                    </a:p>
+                  </a:txBody>
+                  <a:tcPr>
+                    <a:solidFill>
+                      <a:srgbClr val="1A73E8"/>
+                    </a:solidFill>
+                  </a:tcPr>
+                </a:tc>
+                <a:tc>
+                  <a:txBody>
+                    <a:bodyPr lIns="40000" rIns="40000" tIns="15000" bIns="15000"/>
+                    <a:lstStyle/>
+                    <a:p>
+                      <a:pPr algn="ctr"/>
+                      <a:r>
+                        <a:rPr sz="1200" b="1">
+                          <a:solidFill>
+                            <a:srgbClr val="FFFFFF"/>
+                          </a:solidFill>
+                          <a:latin typeface="Microsoft YaHei"/>
+                        </a:rPr>
+                        <a:t>适合的角色</a:t>
+                      </a:r>
+                    </a:p>
+                  </a:txBody>
+                  <a:tcPr>
+                    <a:solidFill>
+                      <a:srgbClr val="1A73E8"/>
+                    </a:solidFill>
+                  </a:tcPr>
+                </a:tc>
+              </a:tr>
+              <a:tr h="365760">
+                <a:tc>
+                  <a:txBody>
+                    <a:bodyPr lIns="40000" rIns="40000" tIns="10000" bIns="10000" wrap="square"/>
+                    <a:lstStyle/>
+                    <a:p>
+                      <a:pPr algn="l"/>
+                      <a:r>
+                        <a:rPr sz="1200">
+                          <a:solidFill>
+                            <a:srgbClr val="202020"/>
+                          </a:solidFill>
+                          <a:latin typeface="Microsoft YaHei"/>
+                        </a:rPr>
+                        <a:t>Claude Opus 4.7（1M）</a:t>
+                      </a:r>
+                    </a:p>
+                  </a:txBody>
+                  <a:tcPr>
+                    <a:solidFill>
+                      <a:srgbClr val="FFFFFF"/>
+                    </a:solidFill>
+                  </a:tcPr>
+                </a:tc>
+                <a:tc>
+                  <a:txBody>
+                    <a:bodyPr lIns="40000" rIns="40000" tIns="10000" bIns="10000" wrap="square"/>
+                    <a:lstStyle/>
+                    <a:p>
+                      <a:pPr algn="l"/>
+                      <a:r>
+                        <a:rPr sz="1200">
+                          <a:solidFill>
+                            <a:srgbClr val="202020"/>
+                          </a:solidFill>
+                          <a:latin typeface="Microsoft YaHei"/>
+                        </a:rPr>
+                        <a:t>推理深度最强，全局视角</a:t>
+                      </a:r>
+                    </a:p>
+                  </a:txBody>
+                  <a:tcPr>
+                    <a:solidFill>
+                      <a:srgbClr val="FFFFFF"/>
+                    </a:solidFill>
+                  </a:tcPr>
+                </a:tc>
+                <a:tc>
+                  <a:txBody>
+                    <a:bodyPr lIns="40000" rIns="40000" tIns="10000" bIns="10000" wrap="square"/>
+                    <a:lstStyle/>
+                    <a:p>
+                      <a:pPr algn="l"/>
+                      <a:r>
+                        <a:rPr sz="1200">
+                          <a:solidFill>
+                            <a:srgbClr val="202020"/>
+                          </a:solidFill>
+                          <a:latin typeface="Microsoft YaHei"/>
+                        </a:rPr>
+                        <a:t>架构 / 根因分析 / 深度审查</a:t>
+                      </a:r>
+                    </a:p>
+                  </a:txBody>
+                  <a:tcPr>
+                    <a:solidFill>
+                      <a:srgbClr val="FFFFFF"/>
+                    </a:solidFill>
+                  </a:tcPr>
+                </a:tc>
+              </a:tr>
+              <a:tr h="365760">
+                <a:tc>
+                  <a:txBody>
+                    <a:bodyPr lIns="40000" rIns="40000" tIns="10000" bIns="10000" wrap="square"/>
+                    <a:lstStyle/>
+                    <a:p>
+                      <a:pPr algn="l"/>
+                      <a:r>
+                        <a:rPr sz="1200">
+                          <a:solidFill>
+                            <a:srgbClr val="202020"/>
+                          </a:solidFill>
+                          <a:latin typeface="Microsoft YaHei"/>
+                        </a:rPr>
+                        <a:t>Claude Sonnet 4.6</a:t>
+                      </a:r>
+                    </a:p>
+                  </a:txBody>
+                  <a:tcPr>
+                    <a:solidFill>
+                      <a:srgbClr val="F0F4FF"/>
+                    </a:solidFill>
+                  </a:tcPr>
+                </a:tc>
+                <a:tc>
+                  <a:txBody>
+                    <a:bodyPr lIns="40000" rIns="40000" tIns="10000" bIns="10000" wrap="square"/>
+                    <a:lstStyle/>
+                    <a:p>
+                      <a:pPr algn="l"/>
+                      <a:r>
+                        <a:rPr sz="1200">
+                          <a:solidFill>
+                            <a:srgbClr val="202020"/>
+                          </a:solidFill>
+                          <a:latin typeface="Microsoft YaHei"/>
+                        </a:rPr>
+                        <a:t>平衡速度与能力</a:t>
+                      </a:r>
+                    </a:p>
+                  </a:txBody>
+                  <a:tcPr>
+                    <a:solidFill>
+                      <a:srgbClr val="F0F4FF"/>
+                    </a:solidFill>
+                  </a:tcPr>
+                </a:tc>
+                <a:tc>
+                  <a:txBody>
+                    <a:bodyPr lIns="40000" rIns="40000" tIns="10000" bIns="10000" wrap="square"/>
+                    <a:lstStyle/>
+                    <a:p>
+                      <a:pPr algn="l"/>
+                      <a:r>
+                        <a:rPr sz="1200">
+                          <a:solidFill>
+                            <a:srgbClr val="202020"/>
+                          </a:solidFill>
+                          <a:latin typeface="Microsoft YaHei"/>
+                        </a:rPr>
+                        <a:t>主要实现 / PR review</a:t>
+                      </a:r>
+                    </a:p>
+                  </a:txBody>
+                  <a:tcPr>
+                    <a:solidFill>
+                      <a:srgbClr val="F0F4FF"/>
+                    </a:solidFill>
+                  </a:tcPr>
+                </a:tc>
+              </a:tr>
+              <a:tr h="365760">
+                <a:tc>
+                  <a:txBody>
+                    <a:bodyPr lIns="40000" rIns="40000" tIns="10000" bIns="10000" wrap="square"/>
+                    <a:lstStyle/>
+                    <a:p>
+                      <a:pPr algn="l"/>
+                      <a:r>
+                        <a:rPr sz="1200">
+                          <a:solidFill>
+                            <a:srgbClr val="202020"/>
+                          </a:solidFill>
+                          <a:latin typeface="Microsoft YaHei"/>
+                        </a:rPr>
+                        <a:t>Claude Haiku 4.5</a:t>
+                      </a:r>
+                    </a:p>
+                  </a:txBody>
+                  <a:tcPr>
+                    <a:solidFill>
+                      <a:srgbClr val="FFFFFF"/>
+                    </a:solidFill>
+                  </a:tcPr>
+                </a:tc>
+                <a:tc>
+                  <a:txBody>
+                    <a:bodyPr lIns="40000" rIns="40000" tIns="10000" bIns="10000" wrap="square"/>
+                    <a:lstStyle/>
+                    <a:p>
+                      <a:pPr algn="l"/>
+                      <a:r>
+                        <a:rPr sz="1200">
+                          <a:solidFill>
+                            <a:srgbClr val="202020"/>
+                          </a:solidFill>
+                          <a:latin typeface="Microsoft YaHei"/>
+                        </a:rPr>
+                        <a:t>极快、便宜</a:t>
+                      </a:r>
+                    </a:p>
+                  </a:txBody>
+                  <a:tcPr>
+                    <a:solidFill>
+                      <a:srgbClr val="FFFFFF"/>
+                    </a:solidFill>
+                  </a:tcPr>
+                </a:tc>
+                <a:tc>
+                  <a:txBody>
+                    <a:bodyPr lIns="40000" rIns="40000" tIns="10000" bIns="10000" wrap="square"/>
+                    <a:lstStyle/>
+                    <a:p>
+                      <a:pPr algn="l"/>
+                      <a:r>
+                        <a:rPr sz="1200">
+                          <a:solidFill>
+                            <a:srgbClr val="202020"/>
+                          </a:solidFill>
+                          <a:latin typeface="Microsoft YaHei"/>
+                        </a:rPr>
+                        <a:t>静态扫描 / 测试生成 / 批量检查</a:t>
+                      </a:r>
+                    </a:p>
+                  </a:txBody>
+                  <a:tcPr>
+                    <a:solidFill>
+                      <a:srgbClr val="FFFFFF"/>
+                    </a:solidFill>
+                  </a:tcPr>
+                </a:tc>
+              </a:tr>
+            </a:tbl>
+          </a:graphicData>
+        </a:graphic>
+      </p:graphicFrame>
+      <p:sp>
+        <p:nvSpPr>
+          <p:cNvPr id="6" name="TextBox 5"/>
+          <p:cNvSpPr txBox="1"/>
+          <p:nvPr/>
+        </p:nvSpPr>
+        <p:spPr>
+          <a:xfrm>
+            <a:off x="457200" y="2971800"/>
+            <a:ext cx="11247120" cy="365760"/>
+          </a:xfrm>
+          <a:prstGeom prst="rect">
+            <a:avLst/>
+          </a:prstGeom>
+          <a:noFill/>
+        </p:spPr>
+        <p:txBody>
+          <a:bodyPr wrap="square" lIns="0" rIns="0" tIns="0" bIns="0">
+            <a:spAutoFit/>
+          </a:bodyPr>
+          <a:lstStyle/>
+          <a:p>
+            <a:pPr algn="l"/>
+            <a:r>
+              <a:rPr sz="1400" b="1">
+                <a:solidFill>
+                  <a:srgbClr val="1A73E8"/>
+                </a:solidFill>
+                <a:latin typeface="Microsoft YaHei"/>
+              </a:rPr>
+              <a:t>5 种协同模式（按可行性排序）</a:t>
+            </a:r>
+          </a:p>
+        </p:txBody>
+      </p:sp>
+      <p:graphicFrame>
+        <p:nvGraphicFramePr>
+          <p:cNvPr id="7" name="Table 6"/>
+          <p:cNvGraphicFramePr>
+            <a:graphicFrameLocks noGrp="1"/>
+          </p:cNvGraphicFramePr>
+          <p:nvPr/>
+        </p:nvGraphicFramePr>
+        <p:xfrm>
+          <a:off x="457200" y="3383280"/>
+          <a:ext cx="11247120" cy="3108960"/>
+        </p:xfrm>
+        <a:graphic>
+          <a:graphicData uri="http://schemas.openxmlformats.org/drawingml/2006/table">
+            <a:tbl>
+              <a:tblPr firstRow="1" bandRow="1">
+                <a:tableStyleId>{5C22544A-7EE6-4342-B048-85BDC9FD1C3A}</a:tableStyleId>
+              </a:tblPr>
+              <a:tblGrid>
+                <a:gridCol w="457200"/>
+                <a:gridCol w="3200400"/>
+                <a:gridCol w="7589520"/>
+              </a:tblGrid>
+              <a:tr h="518160">
+                <a:tc>
+                  <a:txBody>
+                    <a:bodyPr lIns="40000" rIns="40000" tIns="15000" bIns="15000"/>
+                    <a:lstStyle/>
+                    <a:p>
+                      <a:pPr algn="ctr"/>
+                      <a:r>
+                        <a:rPr sz="1200" b="1">
+                          <a:solidFill>
+                            <a:srgbClr val="FFFFFF"/>
+                          </a:solidFill>
+                          <a:latin typeface="Microsoft YaHei"/>
+                        </a:rPr>
+                        <a:t>#</a:t>
+                      </a:r>
+                    </a:p>
+                  </a:txBody>
+                  <a:tcPr>
+                    <a:solidFill>
+                      <a:srgbClr val="1A73E8"/>
+                    </a:solidFill>
+                  </a:tcPr>
+                </a:tc>
+                <a:tc>
+                  <a:txBody>
+                    <a:bodyPr lIns="40000" rIns="40000" tIns="15000" bIns="15000"/>
+                    <a:lstStyle/>
+                    <a:p>
+                      <a:pPr algn="ctr"/>
+                      <a:r>
+                        <a:rPr sz="1200" b="1">
+                          <a:solidFill>
+                            <a:srgbClr val="FFFFFF"/>
+                          </a:solidFill>
+                          <a:latin typeface="Microsoft YaHei"/>
+                        </a:rPr>
+                        <a:t>模式</a:t>
+                      </a:r>
+                    </a:p>
+                  </a:txBody>
+                  <a:tcPr>
+                    <a:solidFill>
+                      <a:srgbClr val="1A73E8"/>
+                    </a:solidFill>
+                  </a:tcPr>
+                </a:tc>
+                <a:tc>
+                  <a:txBody>
+                    <a:bodyPr lIns="40000" rIns="40000" tIns="15000" bIns="15000"/>
+                    <a:lstStyle/>
+                    <a:p>
+                      <a:pPr algn="ctr"/>
+                      <a:r>
+                        <a:rPr sz="1200" b="1">
+                          <a:solidFill>
+                            <a:srgbClr val="FFFFFF"/>
+                          </a:solidFill>
+                          <a:latin typeface="Microsoft YaHei"/>
+                        </a:rPr>
+                        <a:t>做法 / 适用场景</a:t>
+                      </a:r>
+                    </a:p>
+                  </a:txBody>
+                  <a:tcPr>
+                    <a:solidFill>
+                      <a:srgbClr val="1A73E8"/>
+                    </a:solidFill>
+                  </a:tcPr>
+                </a:tc>
+              </a:tr>
+              <a:tr h="518160">
+                <a:tc>
+                  <a:txBody>
+                    <a:bodyPr lIns="40000" rIns="40000" tIns="10000" bIns="10000" wrap="square"/>
+                    <a:lstStyle/>
+                    <a:p>
+                      <a:pPr algn="l"/>
+                      <a:r>
+                        <a:rPr sz="1200">
+                          <a:solidFill>
+                            <a:srgbClr val="202020"/>
+                          </a:solidFill>
+                          <a:latin typeface="Microsoft YaHei"/>
+                        </a:rPr>
+                        <a:t>①</a:t>
+                      </a:r>
+                    </a:p>
+                  </a:txBody>
+                  <a:tcPr>
+                    <a:solidFill>
+                      <a:srgbClr val="FFFFFF"/>
+                    </a:solidFill>
+                  </a:tcPr>
+                </a:tc>
+                <a:tc>
+                  <a:txBody>
+                    <a:bodyPr lIns="40000" rIns="40000" tIns="10000" bIns="10000" wrap="square"/>
+                    <a:lstStyle/>
+                    <a:p>
+                      <a:pPr algn="l"/>
+                      <a:r>
+                        <a:rPr sz="1200">
+                          <a:solidFill>
+                            <a:srgbClr val="202020"/>
+                          </a:solidFill>
+                          <a:latin typeface="Microsoft YaHei"/>
+                        </a:rPr>
+                        <a:t>开新会话 = 等价的「另一个 Claude」</a:t>
+                      </a:r>
+                    </a:p>
+                  </a:txBody>
+                  <a:tcPr>
+                    <a:solidFill>
+                      <a:srgbClr val="FFFFFF"/>
+                    </a:solidFill>
+                  </a:tcPr>
+                </a:tc>
+                <a:tc>
+                  <a:txBody>
+                    <a:bodyPr lIns="40000" rIns="40000" tIns="10000" bIns="10000" wrap="square"/>
+                    <a:lstStyle/>
+                    <a:p>
+                      <a:pPr algn="l"/>
+                      <a:r>
+                        <a:rPr sz="1200">
+                          <a:solidFill>
+                            <a:srgbClr val="202020"/>
+                          </a:solidFill>
+                          <a:latin typeface="Microsoft YaHei"/>
+                        </a:rPr>
+                        <a:t>上下文重置打破自审偏差，零成本，本项目 4 轮自查实质即此 — 推荐</a:t>
+                      </a:r>
+                    </a:p>
+                  </a:txBody>
+                  <a:tcPr>
+                    <a:solidFill>
+                      <a:srgbClr val="FFFFFF"/>
+                    </a:solidFill>
+                  </a:tcPr>
+                </a:tc>
+              </a:tr>
+              <a:tr h="518160">
+                <a:tc>
+                  <a:txBody>
+                    <a:bodyPr lIns="40000" rIns="40000" tIns="10000" bIns="10000" wrap="square"/>
+                    <a:lstStyle/>
+                    <a:p>
+                      <a:pPr algn="l"/>
+                      <a:r>
+                        <a:rPr sz="1200">
+                          <a:solidFill>
+                            <a:srgbClr val="202020"/>
+                          </a:solidFill>
+                          <a:latin typeface="Microsoft YaHei"/>
+                        </a:rPr>
+                        <a:t>②</a:t>
+                      </a:r>
+                    </a:p>
+                  </a:txBody>
+                  <a:tcPr>
+                    <a:solidFill>
+                      <a:srgbClr val="F0F4FF"/>
+                    </a:solidFill>
+                  </a:tcPr>
+                </a:tc>
+                <a:tc>
+                  <a:txBody>
+                    <a:bodyPr lIns="40000" rIns="40000" tIns="10000" bIns="10000" wrap="square"/>
+                    <a:lstStyle/>
+                    <a:p>
+                      <a:pPr algn="l"/>
+                      <a:r>
+                        <a:rPr sz="1200">
+                          <a:solidFill>
+                            <a:srgbClr val="202020"/>
+                          </a:solidFill>
+                          <a:latin typeface="Microsoft YaHei"/>
+                        </a:rPr>
+                        <a:t>Generator / Reviewer 分工</a:t>
+                      </a:r>
+                    </a:p>
+                  </a:txBody>
+                  <a:tcPr>
+                    <a:solidFill>
+                      <a:srgbClr val="F0F4FF"/>
+                    </a:solidFill>
+                  </a:tcPr>
+                </a:tc>
+                <a:tc>
+                  <a:txBody>
+                    <a:bodyPr lIns="40000" rIns="40000" tIns="10000" bIns="10000" wrap="square"/>
+                    <a:lstStyle/>
+                    <a:p>
+                      <a:pPr algn="l"/>
+                      <a:r>
+                        <a:rPr sz="1200">
+                          <a:solidFill>
+                            <a:srgbClr val="202020"/>
+                          </a:solidFill>
+                          <a:latin typeface="Microsoft YaHei"/>
+                        </a:rPr>
+                        <a:t>Opus 架构 → Sonnet 实现 → Haiku 静态扫描 → Opus（新会话）根因审查</a:t>
+                      </a:r>
+                    </a:p>
+                  </a:txBody>
+                  <a:tcPr>
+                    <a:solidFill>
+                      <a:srgbClr val="F0F4FF"/>
+                    </a:solidFill>
+                  </a:tcPr>
+                </a:tc>
+              </a:tr>
+              <a:tr h="518160">
+                <a:tc>
+                  <a:txBody>
+                    <a:bodyPr lIns="40000" rIns="40000" tIns="10000" bIns="10000" wrap="square"/>
+                    <a:lstStyle/>
+                    <a:p>
+                      <a:pPr algn="l"/>
+                      <a:r>
+                        <a:rPr sz="1200">
+                          <a:solidFill>
+                            <a:srgbClr val="202020"/>
+                          </a:solidFill>
+                          <a:latin typeface="Microsoft YaHei"/>
+                        </a:rPr>
+                        <a:t>③</a:t>
+                      </a:r>
+                    </a:p>
+                  </a:txBody>
+                  <a:tcPr>
+                    <a:solidFill>
+                      <a:srgbClr val="FFFFFF"/>
+                    </a:solidFill>
+                  </a:tcPr>
+                </a:tc>
+                <a:tc>
+                  <a:txBody>
+                    <a:bodyPr lIns="40000" rIns="40000" tIns="10000" bIns="10000" wrap="square"/>
+                    <a:lstStyle/>
+                    <a:p>
+                      <a:pPr algn="l"/>
+                      <a:r>
+                        <a:rPr sz="1200">
+                          <a:solidFill>
+                            <a:srgbClr val="202020"/>
+                          </a:solidFill>
+                          <a:latin typeface="Microsoft YaHei"/>
+                        </a:rPr>
+                        <a:t>对抗式审查（Adversarial）</a:t>
+                      </a:r>
+                    </a:p>
+                  </a:txBody>
+                  <a:tcPr>
+                    <a:solidFill>
+                      <a:srgbClr val="FFFFFF"/>
+                    </a:solidFill>
+                  </a:tcPr>
+                </a:tc>
+                <a:tc>
+                  <a:txBody>
+                    <a:bodyPr lIns="40000" rIns="40000" tIns="10000" bIns="10000" wrap="square"/>
+                    <a:lstStyle/>
+                    <a:p>
+                      <a:pPr algn="l"/>
+                      <a:r>
+                        <a:rPr sz="1200">
+                          <a:solidFill>
+                            <a:srgbClr val="202020"/>
+                          </a:solidFill>
+                          <a:latin typeface="Microsoft YaHei"/>
+                        </a:rPr>
+                        <a:t>A 实现 / B 攻击「找崩溃场景」 / C 仲裁 — 适合金钱/分数/安全代码</a:t>
+                      </a:r>
+                    </a:p>
+                  </a:txBody>
+                  <a:tcPr>
+                    <a:solidFill>
+                      <a:srgbClr val="FFFFFF"/>
+                    </a:solidFill>
+                  </a:tcPr>
+                </a:tc>
+              </a:tr>
+              <a:tr h="518160">
+                <a:tc>
+                  <a:txBody>
+                    <a:bodyPr lIns="40000" rIns="40000" tIns="10000" bIns="10000" wrap="square"/>
+                    <a:lstStyle/>
+                    <a:p>
+                      <a:pPr algn="l"/>
+                      <a:r>
+                        <a:rPr sz="1200">
+                          <a:solidFill>
+                            <a:srgbClr val="202020"/>
+                          </a:solidFill>
+                          <a:latin typeface="Microsoft YaHei"/>
+                        </a:rPr>
+                        <a:t>④</a:t>
+                      </a:r>
+                    </a:p>
+                  </a:txBody>
+                  <a:tcPr>
+                    <a:solidFill>
+                      <a:srgbClr val="F0F4FF"/>
+                    </a:solidFill>
+                  </a:tcPr>
+                </a:tc>
+                <a:tc>
+                  <a:txBody>
+                    <a:bodyPr lIns="40000" rIns="40000" tIns="10000" bIns="10000" wrap="square"/>
+                    <a:lstStyle/>
+                    <a:p>
+                      <a:pPr algn="l"/>
+                      <a:r>
+                        <a:rPr sz="1200">
+                          <a:solidFill>
+                            <a:srgbClr val="202020"/>
+                          </a:solidFill>
+                          <a:latin typeface="Microsoft YaHei"/>
+                        </a:rPr>
+                        <a:t>TDD 反向流</a:t>
+                      </a:r>
+                    </a:p>
+                  </a:txBody>
+                  <a:tcPr>
+                    <a:solidFill>
+                      <a:srgbClr val="F0F4FF"/>
+                    </a:solidFill>
+                  </a:tcPr>
+                </a:tc>
+                <a:tc>
+                  <a:txBody>
+                    <a:bodyPr lIns="40000" rIns="40000" tIns="10000" bIns="10000" wrap="square"/>
+                    <a:lstStyle/>
+                    <a:p>
+                      <a:pPr algn="l"/>
+                      <a:r>
+                        <a:rPr sz="1200">
+                          <a:solidFill>
+                            <a:srgbClr val="202020"/>
+                          </a:solidFill>
+                          <a:latin typeface="Microsoft YaHei"/>
+                        </a:rPr>
+                        <a:t>Haiku 先写边界用例 → Sonnet 实现到通过 → Opus 审查覆盖率 — 最压低 Bug</a:t>
+                      </a:r>
+                    </a:p>
+                  </a:txBody>
+                  <a:tcPr>
+                    <a:solidFill>
+                      <a:srgbClr val="F0F4FF"/>
+                    </a:solidFill>
+                  </a:tcPr>
+                </a:tc>
+              </a:tr>
+              <a:tr h="518160">
+                <a:tc>
+                  <a:txBody>
+                    <a:bodyPr lIns="40000" rIns="40000" tIns="10000" bIns="10000" wrap="square"/>
+                    <a:lstStyle/>
+                    <a:p>
+                      <a:pPr algn="l"/>
+                      <a:r>
+                        <a:rPr sz="1200">
+                          <a:solidFill>
+                            <a:srgbClr val="202020"/>
+                          </a:solidFill>
+                          <a:latin typeface="Microsoft YaHei"/>
+                        </a:rPr>
+                        <a:t>⑤</a:t>
+                      </a:r>
+                    </a:p>
+                  </a:txBody>
+                  <a:tcPr>
+                    <a:solidFill>
+                      <a:srgbClr val="FFFFFF"/>
+                    </a:solidFill>
+                  </a:tcPr>
+                </a:tc>
+                <a:tc>
+                  <a:txBody>
+                    <a:bodyPr lIns="40000" rIns="40000" tIns="10000" bIns="10000" wrap="square"/>
+                    <a:lstStyle/>
+                    <a:p>
+                      <a:pPr algn="l"/>
+                      <a:r>
+                        <a:rPr sz="1200">
+                          <a:solidFill>
+                            <a:srgbClr val="202020"/>
+                          </a:solidFill>
+                          <a:latin typeface="Microsoft YaHei"/>
+                        </a:rPr>
+                        <a:t>Self-Consistency 校验</a:t>
+                      </a:r>
+                    </a:p>
+                  </a:txBody>
+                  <a:tcPr>
+                    <a:solidFill>
+                      <a:srgbClr val="FFFFFF"/>
+                    </a:solidFill>
+                  </a:tcPr>
+                </a:tc>
+                <a:tc>
+                  <a:txBody>
+                    <a:bodyPr lIns="40000" rIns="40000" tIns="10000" bIns="10000" wrap="square"/>
+                    <a:lstStyle/>
+                    <a:p>
+                      <a:pPr algn="l"/>
+                      <a:r>
+                        <a:rPr sz="1200">
+                          <a:solidFill>
+                            <a:srgbClr val="202020"/>
+                          </a:solidFill>
+                          <a:latin typeface="Microsoft YaHei"/>
+                        </a:rPr>
+                        <a:t>同一任务 Opus 跑 3 次对比，差异处标记为「不确定区」 — 关键代码</a:t>
+                      </a:r>
+                    </a:p>
+                  </a:txBody>
+                  <a:tcPr>
+                    <a:solidFill>
+                      <a:srgbClr val="FFFFFF"/>
+                    </a:solidFill>
+                  </a:tcPr>
+                </a:tc>
+              </a:tr>
+            </a:tbl>
+          </a:graphicData>
+        </a:graphic>
+      </p:graphicFrame>
+      <p:sp>
+        <p:nvSpPr>
+          <p:cNvPr id="8" name="TextBox 7"/>
+          <p:cNvSpPr txBox="1"/>
+          <p:nvPr/>
+        </p:nvSpPr>
+        <p:spPr>
+          <a:xfrm>
+            <a:off x="10789920" y="6446520"/>
+            <a:ext cx="1188720" cy="274320"/>
+          </a:xfrm>
+          <a:prstGeom prst="rect">
+            <a:avLst/>
+          </a:prstGeom>
+          <a:noFill/>
+        </p:spPr>
+        <p:txBody>
+          <a:bodyPr wrap="square" lIns="0" rIns="0" tIns="0" bIns="0">
+            <a:spAutoFit/>
+          </a:bodyPr>
+          <a:lstStyle/>
+          <a:p>
+            <a:pPr algn="r"/>
+            <a:r>
+              <a:rPr sz="1000" b="0">
+                <a:solidFill>
+                  <a:srgbClr val="606060"/>
+                </a:solidFill>
+                <a:latin typeface="Microsoft YaHei"/>
+              </a:rPr>
+              <a:t>10 / 13</a:t>
+            </a:r>
+          </a:p>
+        </p:txBody>
+      </p:sp>
+    </p:spTree>
+  </p:cSld>
+  <p:clrMapOvr>
+    <a:masterClrMapping/>
+  </p:clrMapOvr>
+</p:sld>
+</file>
+
+<file path=ppt/slides/slide11.xml><?xml version="1.0" encoding="utf-8"?>
+<p:sld xmlns:a="http://schemas.openxmlformats.org/drawingml/2006/main" xmlns:p="http://schemas.openxmlformats.org/presentationml/2006/main" xmlns:r="http://schemas.openxmlformats.org/officeDocument/2006/relationships">
+  <p:cSld>
+    <p:spTree>
+      <p:nvGrpSpPr>
+        <p:cNvPr id="1" name=""/>
+        <p:cNvGrpSpPr/>
+        <p:nvPr/>
+      </p:nvGrpSpPr>
+      <p:grpSpPr/>
+      <p:sp>
+        <p:nvSpPr>
+          <p:cNvPr id="2" name="TextBox 1"/>
+          <p:cNvSpPr txBox="1"/>
+          <p:nvPr/>
+        </p:nvSpPr>
+        <p:spPr>
+          <a:xfrm>
+            <a:off x="457200" y="274320"/>
+            <a:ext cx="11247120" cy="457200"/>
+          </a:xfrm>
+          <a:prstGeom prst="rect">
+            <a:avLst/>
+          </a:prstGeom>
+          <a:noFill/>
+        </p:spPr>
+        <p:txBody>
+          <a:bodyPr wrap="square" lIns="0" rIns="0" tIns="0" bIns="0">
+            <a:spAutoFit/>
+          </a:bodyPr>
+          <a:lstStyle/>
+          <a:p>
+            <a:pPr algn="l"/>
+            <a:r>
+              <a:rPr sz="2400" b="1">
+                <a:solidFill>
+                  <a:srgbClr val="1A73E8"/>
+                </a:solidFill>
+                <a:latin typeface="Microsoft YaHei"/>
+              </a:rPr>
+              <a:t>六、协同天花板 &amp; 推荐工作流</a:t>
+            </a:r>
+          </a:p>
+        </p:txBody>
+      </p:sp>
+      <p:sp>
+        <p:nvSpPr>
+          <p:cNvPr id="3" name="Rectangle 2"/>
+          <p:cNvSpPr/>
+          <p:nvPr/>
+        </p:nvSpPr>
+        <p:spPr>
+          <a:xfrm>
+            <a:off x="457200" y="777240"/>
+            <a:ext cx="11247120" cy="36576"/>
+          </a:xfrm>
+          <a:prstGeom prst="rect">
+            <a:avLst/>
+          </a:prstGeom>
+          <a:solidFill>
+            <a:srgbClr val="1A73E8"/>
+          </a:solidFill>
+          <a:ln>
+            <a:noFill/>
+          </a:ln>
+        </p:spPr>
+        <p:style>
+          <a:lnRef idx="1">
+            <a:schemeClr val="accent1"/>
+          </a:lnRef>
+          <a:fillRef idx="3">
+            <a:schemeClr val="accent1"/>
+          </a:fillRef>
+          <a:effectRef idx="2">
+            <a:schemeClr val="accent1"/>
+          </a:effectRef>
+          <a:fontRef idx="minor">
+            <a:schemeClr val="lt1"/>
+          </a:fontRef>
+        </p:style>
+        <p:txBody>
+          <a:bodyPr rtlCol="0" anchor="ctr"/>
+          <a:lstStyle/>
+          <a:p>
+            <a:pPr algn="ctr"/>
+          </a:p>
+        </p:txBody>
+      </p:sp>
+      <p:sp>
+        <p:nvSpPr>
+          <p:cNvPr id="4" name="TextBox 3"/>
+          <p:cNvSpPr txBox="1"/>
+          <p:nvPr/>
+        </p:nvSpPr>
+        <p:spPr>
+          <a:xfrm>
+            <a:off x="457200" y="914400"/>
+            <a:ext cx="11247120" cy="365760"/>
+          </a:xfrm>
+          <a:prstGeom prst="rect">
+            <a:avLst/>
+          </a:prstGeom>
+          <a:noFill/>
+        </p:spPr>
+        <p:txBody>
+          <a:bodyPr wrap="square" lIns="0" rIns="0" tIns="0" bIns="0">
+            <a:spAutoFit/>
+          </a:bodyPr>
+          <a:lstStyle/>
+          <a:p>
+            <a:pPr algn="l"/>
+            <a:r>
+              <a:rPr sz="1400" b="1">
+                <a:solidFill>
+                  <a:srgbClr val="E53935"/>
+                </a:solidFill>
+                <a:latin typeface="Microsoft YaHei"/>
+              </a:rPr>
+              <a:t>⚠ 多 Claude 协同的天花板：相关性盲区</a:t>
+            </a:r>
+          </a:p>
+        </p:txBody>
+      </p:sp>
+      <p:sp>
+        <p:nvSpPr>
+          <p:cNvPr id="5" name="TextBox 4"/>
+          <p:cNvSpPr txBox="1"/>
+          <p:nvPr/>
+        </p:nvSpPr>
+        <p:spPr>
+          <a:xfrm>
+            <a:off x="640080" y="1325880"/>
+            <a:ext cx="10972800" cy="365760"/>
+          </a:xfrm>
+          <a:prstGeom prst="rect">
+            <a:avLst/>
+          </a:prstGeom>
+          <a:noFill/>
+        </p:spPr>
+        <p:txBody>
+          <a:bodyPr wrap="square" lIns="0" rIns="0" tIns="0" bIns="0">
+            <a:spAutoFit/>
+          </a:bodyPr>
+          <a:lstStyle/>
+          <a:p>
+            <a:pPr algn="l"/>
+            <a:r>
+              <a:rPr sz="1200" b="0">
+                <a:solidFill>
+                  <a:srgbClr val="202020"/>
+                </a:solidFill>
+                <a:latin typeface="Microsoft YaHei"/>
+              </a:rPr>
+              <a:t>原因：所有 Claude 共享同一训练语料 + 同一训练目标 + 同一架构</a:t>
+            </a:r>
+          </a:p>
+        </p:txBody>
+      </p:sp>
+      <p:sp>
+        <p:nvSpPr>
+          <p:cNvPr id="6" name="TextBox 5"/>
+          <p:cNvSpPr txBox="1"/>
+          <p:nvPr/>
+        </p:nvSpPr>
+        <p:spPr>
+          <a:xfrm>
+            <a:off x="640080" y="1691640"/>
+            <a:ext cx="10972800" cy="365760"/>
+          </a:xfrm>
+          <a:prstGeom prst="rect">
+            <a:avLst/>
+          </a:prstGeom>
+          <a:noFill/>
+        </p:spPr>
+        <p:txBody>
+          <a:bodyPr wrap="square" lIns="0" rIns="0" tIns="0" bIns="0">
+            <a:spAutoFit/>
+          </a:bodyPr>
+          <a:lstStyle/>
+          <a:p>
+            <a:pPr algn="l"/>
+            <a:r>
+              <a:rPr sz="1200" b="0">
+                <a:solidFill>
+                  <a:srgbClr val="606060"/>
+                </a:solidFill>
+                <a:latin typeface="Microsoft YaHei"/>
+              </a:rPr>
+              <a:t>→ Codex Bot 找到的 3 个问题（UUID 截断 / loading 卡死 / UI 不一致）多 Claude 也大概率找不出</a:t>
+            </a:r>
+          </a:p>
+        </p:txBody>
+      </p:sp>
+      <p:sp>
+        <p:nvSpPr>
+          <p:cNvPr id="7" name="TextBox 6"/>
+          <p:cNvSpPr txBox="1"/>
+          <p:nvPr/>
+        </p:nvSpPr>
+        <p:spPr>
+          <a:xfrm>
+            <a:off x="457200" y="2194560"/>
+            <a:ext cx="11247120" cy="365760"/>
+          </a:xfrm>
+          <a:prstGeom prst="rect">
+            <a:avLst/>
+          </a:prstGeom>
+          <a:noFill/>
+        </p:spPr>
+        <p:txBody>
+          <a:bodyPr wrap="square" lIns="0" rIns="0" tIns="0" bIns="0">
+            <a:spAutoFit/>
+          </a:bodyPr>
+          <a:lstStyle/>
+          <a:p>
+            <a:pPr algn="l"/>
+            <a:r>
+              <a:rPr sz="1400" b="1">
+                <a:solidFill>
+                  <a:srgbClr val="1A73E8"/>
+                </a:solidFill>
+                <a:latin typeface="Microsoft YaHei"/>
+              </a:rPr>
+              <a:t>📊 真正补盲区的策略对比</a:t>
+            </a:r>
+          </a:p>
+        </p:txBody>
+      </p:sp>
+      <p:graphicFrame>
+        <p:nvGraphicFramePr>
+          <p:cNvPr id="8" name="Table 7"/>
+          <p:cNvGraphicFramePr>
+            <a:graphicFrameLocks noGrp="1"/>
+          </p:cNvGraphicFramePr>
+          <p:nvPr/>
+        </p:nvGraphicFramePr>
+        <p:xfrm>
+          <a:off x="457200" y="2606040"/>
+          <a:ext cx="11247120" cy="1645920"/>
+        </p:xfrm>
+        <a:graphic>
+          <a:graphicData uri="http://schemas.openxmlformats.org/drawingml/2006/table">
+            <a:tbl>
+              <a:tblPr firstRow="1" bandRow="1">
+                <a:tableStyleId>{5C22544A-7EE6-4342-B048-85BDC9FD1C3A}</a:tableStyleId>
+              </a:tblPr>
+              <a:tblGrid>
+                <a:gridCol w="4114800"/>
+                <a:gridCol w="5029200"/>
+                <a:gridCol w="2103120"/>
+              </a:tblGrid>
+              <a:tr h="329184">
+                <a:tc>
+                  <a:txBody>
+                    <a:bodyPr lIns="40000" rIns="40000" tIns="15000" bIns="15000"/>
+                    <a:lstStyle/>
+                    <a:p>
+                      <a:pPr algn="ctr"/>
+                      <a:r>
+                        <a:rPr sz="1200" b="1">
+                          <a:solidFill>
+                            <a:srgbClr val="FFFFFF"/>
+                          </a:solidFill>
+                          <a:latin typeface="Microsoft YaHei"/>
+                        </a:rPr>
+                        <a:t>组合</a:t>
+                      </a:r>
+                    </a:p>
+                  </a:txBody>
+                  <a:tcPr>
+                    <a:solidFill>
+                      <a:srgbClr val="1A73E8"/>
+                    </a:solidFill>
+                  </a:tcPr>
+                </a:tc>
+                <a:tc>
+                  <a:txBody>
+                    <a:bodyPr lIns="40000" rIns="40000" tIns="15000" bIns="15000"/>
+                    <a:lstStyle/>
+                    <a:p>
+                      <a:pPr algn="ctr"/>
+                      <a:r>
+                        <a:rPr sz="1200" b="1">
+                          <a:solidFill>
+                            <a:srgbClr val="FFFFFF"/>
+                          </a:solidFill>
+                          <a:latin typeface="Microsoft YaHei"/>
+                        </a:rPr>
+                        <a:t>找到的问题类型</a:t>
+                      </a:r>
+                    </a:p>
+                  </a:txBody>
+                  <a:tcPr>
+                    <a:solidFill>
+                      <a:srgbClr val="1A73E8"/>
+                    </a:solidFill>
+                  </a:tcPr>
+                </a:tc>
+                <a:tc>
+                  <a:txBody>
+                    <a:bodyPr lIns="40000" rIns="40000" tIns="15000" bIns="15000"/>
+                    <a:lstStyle/>
+                    <a:p>
+                      <a:pPr algn="ctr"/>
+                      <a:r>
+                        <a:rPr sz="1200" b="1">
+                          <a:solidFill>
+                            <a:srgbClr val="FFFFFF"/>
+                          </a:solidFill>
+                          <a:latin typeface="Microsoft YaHei"/>
+                        </a:rPr>
+                        <a:t>互补程度</a:t>
+                      </a:r>
+                    </a:p>
+                  </a:txBody>
+                  <a:tcPr>
+                    <a:solidFill>
+                      <a:srgbClr val="1A73E8"/>
+                    </a:solidFill>
+                  </a:tcPr>
+                </a:tc>
+              </a:tr>
+              <a:tr h="329184">
+                <a:tc>
+                  <a:txBody>
+                    <a:bodyPr lIns="40000" rIns="40000" tIns="10000" bIns="10000" wrap="square"/>
+                    <a:lstStyle/>
+                    <a:p>
+                      <a:pPr algn="l"/>
+                      <a:r>
+                        <a:rPr sz="1200">
+                          <a:solidFill>
+                            <a:srgbClr val="202020"/>
+                          </a:solidFill>
+                          <a:latin typeface="Microsoft YaHei"/>
+                        </a:rPr>
+                        <a:t>多个 Claude 实例</a:t>
+                      </a:r>
+                    </a:p>
+                  </a:txBody>
+                  <a:tcPr>
+                    <a:solidFill>
+                      <a:srgbClr val="FFFFFF"/>
+                    </a:solidFill>
+                  </a:tcPr>
+                </a:tc>
+                <a:tc>
+                  <a:txBody>
+                    <a:bodyPr lIns="40000" rIns="40000" tIns="10000" bIns="10000" wrap="square"/>
+                    <a:lstStyle/>
+                    <a:p>
+                      <a:pPr algn="l"/>
+                      <a:r>
+                        <a:rPr sz="1200">
+                          <a:solidFill>
+                            <a:srgbClr val="202020"/>
+                          </a:solidFill>
+                          <a:latin typeface="Microsoft YaHei"/>
+                        </a:rPr>
+                        <a:t>全局架构 + 逻辑链路（多角度）</a:t>
+                      </a:r>
+                    </a:p>
+                  </a:txBody>
+                  <a:tcPr>
+                    <a:solidFill>
+                      <a:srgbClr val="FFFFFF"/>
+                    </a:solidFill>
+                  </a:tcPr>
+                </a:tc>
+                <a:tc>
+                  <a:txBody>
+                    <a:bodyPr lIns="40000" rIns="40000" tIns="10000" bIns="10000" wrap="square"/>
+                    <a:lstStyle/>
+                    <a:p>
+                      <a:pPr algn="l"/>
+                      <a:r>
+                        <a:rPr sz="1200">
+                          <a:solidFill>
+                            <a:srgbClr val="202020"/>
+                          </a:solidFill>
+                          <a:latin typeface="Microsoft YaHei"/>
+                        </a:rPr>
+                        <a:t>中等</a:t>
+                      </a:r>
+                    </a:p>
+                  </a:txBody>
+                  <a:tcPr>
+                    <a:solidFill>
+                      <a:srgbClr val="FFFFFF"/>
+                    </a:solidFill>
+                  </a:tcPr>
+                </a:tc>
+              </a:tr>
+              <a:tr h="329184">
+                <a:tc>
+                  <a:txBody>
+                    <a:bodyPr lIns="40000" rIns="40000" tIns="10000" bIns="10000" wrap="square"/>
+                    <a:lstStyle/>
+                    <a:p>
+                      <a:pPr algn="l"/>
+                      <a:r>
+                        <a:rPr sz="1200">
+                          <a:solidFill>
+                            <a:srgbClr val="202020"/>
+                          </a:solidFill>
+                          <a:latin typeface="Microsoft YaHei"/>
+                        </a:rPr>
+                        <a:t>Claude + Codex（OpenAI）</a:t>
+                      </a:r>
+                    </a:p>
+                  </a:txBody>
+                  <a:tcPr>
+                    <a:solidFill>
+                      <a:srgbClr val="F0F4FF"/>
+                    </a:solidFill>
+                  </a:tcPr>
+                </a:tc>
+                <a:tc>
+                  <a:txBody>
+                    <a:bodyPr lIns="40000" rIns="40000" tIns="10000" bIns="10000" wrap="square"/>
+                    <a:lstStyle/>
+                    <a:p>
+                      <a:pPr algn="l"/>
+                      <a:r>
+                        <a:rPr sz="1200">
+                          <a:solidFill>
+                            <a:srgbClr val="202020"/>
+                          </a:solidFill>
+                          <a:latin typeface="Microsoft YaHei"/>
+                        </a:rPr>
+                        <a:t>增加细粒度风险点</a:t>
+                      </a:r>
+                    </a:p>
+                  </a:txBody>
+                  <a:tcPr>
+                    <a:solidFill>
+                      <a:srgbClr val="F0F4FF"/>
+                    </a:solidFill>
+                  </a:tcPr>
+                </a:tc>
+                <a:tc>
+                  <a:txBody>
+                    <a:bodyPr lIns="40000" rIns="40000" tIns="10000" bIns="10000" wrap="square"/>
+                    <a:lstStyle/>
+                    <a:p>
+                      <a:pPr algn="l"/>
+                      <a:r>
+                        <a:rPr sz="1200">
+                          <a:solidFill>
+                            <a:srgbClr val="202020"/>
+                          </a:solidFill>
+                          <a:latin typeface="Microsoft YaHei"/>
+                        </a:rPr>
+                        <a:t>较高</a:t>
+                      </a:r>
+                    </a:p>
+                  </a:txBody>
+                  <a:tcPr>
+                    <a:solidFill>
+                      <a:srgbClr val="F0F4FF"/>
+                    </a:solidFill>
+                  </a:tcPr>
+                </a:tc>
+              </a:tr>
+              <a:tr h="329184">
+                <a:tc>
+                  <a:txBody>
+                    <a:bodyPr lIns="40000" rIns="40000" tIns="10000" bIns="10000" wrap="square"/>
+                    <a:lstStyle/>
+                    <a:p>
+                      <a:pPr algn="l"/>
+                      <a:r>
+                        <a:rPr sz="1200">
+                          <a:solidFill>
+                            <a:srgbClr val="202020"/>
+                          </a:solidFill>
+                          <a:latin typeface="Microsoft YaHei"/>
+                        </a:rPr>
+                        <a:t>Claude + Codex + Gemini</a:t>
+                      </a:r>
+                    </a:p>
+                  </a:txBody>
+                  <a:tcPr>
+                    <a:solidFill>
+                      <a:srgbClr val="FFFFFF"/>
+                    </a:solidFill>
+                  </a:tcPr>
+                </a:tc>
+                <a:tc>
+                  <a:txBody>
+                    <a:bodyPr lIns="40000" rIns="40000" tIns="10000" bIns="10000" wrap="square"/>
+                    <a:lstStyle/>
+                    <a:p>
+                      <a:pPr algn="l"/>
+                      <a:r>
+                        <a:rPr sz="1200">
+                          <a:solidFill>
+                            <a:srgbClr val="202020"/>
+                          </a:solidFill>
+                          <a:latin typeface="Microsoft YaHei"/>
+                        </a:rPr>
+                        <a:t>不同训练目标，覆盖最广</a:t>
+                      </a:r>
+                    </a:p>
+                  </a:txBody>
+                  <a:tcPr>
+                    <a:solidFill>
+                      <a:srgbClr val="FFFFFF"/>
+                    </a:solidFill>
+                  </a:tcPr>
+                </a:tc>
+                <a:tc>
+                  <a:txBody>
+                    <a:bodyPr lIns="40000" rIns="40000" tIns="10000" bIns="10000" wrap="square"/>
+                    <a:lstStyle/>
+                    <a:p>
+                      <a:pPr algn="l"/>
+                      <a:r>
+                        <a:rPr sz="1200">
+                          <a:solidFill>
+                            <a:srgbClr val="202020"/>
+                          </a:solidFill>
+                          <a:latin typeface="Microsoft YaHei"/>
+                        </a:rPr>
+                        <a:t>最高</a:t>
+                      </a:r>
+                    </a:p>
+                  </a:txBody>
+                  <a:tcPr>
+                    <a:solidFill>
+                      <a:srgbClr val="FFFFFF"/>
+                    </a:solidFill>
+                  </a:tcPr>
+                </a:tc>
+              </a:tr>
+              <a:tr h="329184">
+                <a:tc>
+                  <a:txBody>
+                    <a:bodyPr lIns="40000" rIns="40000" tIns="10000" bIns="10000" wrap="square"/>
+                    <a:lstStyle/>
+                    <a:p>
+                      <a:pPr algn="l"/>
+                      <a:r>
+                        <a:rPr sz="1200">
+                          <a:solidFill>
+                            <a:srgbClr val="202020"/>
+                          </a:solidFill>
+                          <a:latin typeface="Microsoft YaHei"/>
+                        </a:rPr>
+                        <a:t>Claude + Detekt / SpotBugs / kover</a:t>
+                      </a:r>
+                    </a:p>
+                  </a:txBody>
+                  <a:tcPr>
+                    <a:solidFill>
+                      <a:srgbClr val="F0F4FF"/>
+                    </a:solidFill>
+                  </a:tcPr>
+                </a:tc>
+                <a:tc>
+                  <a:txBody>
+                    <a:bodyPr lIns="40000" rIns="40000" tIns="10000" bIns="10000" wrap="square"/>
+                    <a:lstStyle/>
+                    <a:p>
+                      <a:pPr algn="l"/>
+                      <a:r>
+                        <a:rPr sz="1200">
+                          <a:solidFill>
+                            <a:srgbClr val="202020"/>
+                          </a:solidFill>
+                          <a:latin typeface="Microsoft YaHei"/>
+                        </a:rPr>
+                        <a:t>规则化盲区</a:t>
+                      </a:r>
+                    </a:p>
+                  </a:txBody>
+                  <a:tcPr>
+                    <a:solidFill>
+                      <a:srgbClr val="F0F4FF"/>
+                    </a:solidFill>
+                  </a:tcPr>
+                </a:tc>
+                <a:tc>
+                  <a:txBody>
+                    <a:bodyPr lIns="40000" rIns="40000" tIns="10000" bIns="10000" wrap="square"/>
+                    <a:lstStyle/>
+                    <a:p>
+                      <a:pPr algn="l"/>
+                      <a:r>
+                        <a:rPr sz="1200">
+                          <a:solidFill>
+                            <a:srgbClr val="202020"/>
+                          </a:solidFill>
+                          <a:latin typeface="Microsoft YaHei"/>
+                        </a:rPr>
+                        <a:t>必要</a:t>
+                      </a:r>
+                    </a:p>
+                  </a:txBody>
+                  <a:tcPr>
+                    <a:solidFill>
+                      <a:srgbClr val="F0F4FF"/>
+                    </a:solidFill>
+                  </a:tcPr>
+                </a:tc>
+              </a:tr>
+            </a:tbl>
+          </a:graphicData>
+        </a:graphic>
+      </p:graphicFrame>
+      <p:sp>
+        <p:nvSpPr>
+          <p:cNvPr id="9" name="TextBox 8"/>
+          <p:cNvSpPr txBox="1"/>
+          <p:nvPr/>
+        </p:nvSpPr>
+        <p:spPr>
+          <a:xfrm>
+            <a:off x="457200" y="4434840"/>
+            <a:ext cx="11247120" cy="365760"/>
+          </a:xfrm>
+          <a:prstGeom prst="rect">
+            <a:avLst/>
+          </a:prstGeom>
+          <a:noFill/>
+        </p:spPr>
+        <p:txBody>
+          <a:bodyPr wrap="square" lIns="0" rIns="0" tIns="0" bIns="0">
+            <a:spAutoFit/>
+          </a:bodyPr>
+          <a:lstStyle/>
+          <a:p>
+            <a:pPr algn="l"/>
+            <a:r>
+              <a:rPr sz="1400" b="1">
+                <a:solidFill>
+                  <a:srgbClr val="2E7D32"/>
+                </a:solidFill>
+                <a:latin typeface="Microsoft YaHei"/>
+              </a:rPr>
+              <a:t>🚀 给本项目的推荐工作流（如果重做联网模块）</a:t>
+            </a:r>
+          </a:p>
+        </p:txBody>
+      </p:sp>
+      <p:sp>
+        <p:nvSpPr>
+          <p:cNvPr id="10" name="Rectangle 9"/>
+          <p:cNvSpPr/>
+          <p:nvPr/>
+        </p:nvSpPr>
+        <p:spPr>
+          <a:xfrm>
+            <a:off x="457200" y="4846320"/>
+            <a:ext cx="11247120" cy="1463040"/>
+          </a:xfrm>
+          <a:prstGeom prst="rect">
+            <a:avLst/>
+          </a:prstGeom>
+          <a:solidFill>
+            <a:srgbClr val="F4F4F4"/>
+          </a:solidFill>
+          <a:ln>
+            <a:solidFill>
+              <a:srgbClr val="D0D0D0"/>
+            </a:solidFill>
+          </a:ln>
+        </p:spPr>
+        <p:style>
+          <a:lnRef idx="1">
+            <a:schemeClr val="accent1"/>
+          </a:lnRef>
+          <a:fillRef idx="3">
+            <a:schemeClr val="accent1"/>
+          </a:fillRef>
+          <a:effectRef idx="2">
+            <a:schemeClr val="accent1"/>
+          </a:effectRef>
+          <a:fontRef idx="minor">
+            <a:schemeClr val="lt1"/>
+          </a:fontRef>
+        </p:style>
+        <p:txBody>
+          <a:bodyPr rtlCol="0" anchor="ctr" wrap="square" lIns="120000" rIns="120000" tIns="80000" bIns="80000"/>
+          <a:lstStyle/>
+          <a:p>
+            <a:pPr algn="ctr"/>
+            <a:r>
+              <a:rPr sz="1200">
+                <a:solidFill>
+                  <a:srgbClr val="202020"/>
+                </a:solidFill>
+                <a:latin typeface="Consolas"/>
+              </a:rPr>
+              <a:t>开发：  Opus 4.7 (1M)  架构 + 协议    Sonnet 4.6  实现    Haiku 4.5  静态扫描</a:t>
+            </a:r>
+          </a:p>
+          <a:p>
+            <a:r>
+              <a:rPr sz="1200">
+                <a:solidFill>
+                  <a:srgbClr val="202020"/>
+                </a:solidFill>
+                <a:latin typeface="Consolas"/>
+              </a:rPr>
+              <a:t> </a:t>
+            </a:r>
+          </a:p>
+          <a:p>
+            <a:r>
+              <a:rPr sz="1200">
+                <a:solidFill>
+                  <a:srgbClr val="202020"/>
+                </a:solidFill>
+                <a:latin typeface="Consolas"/>
+              </a:rPr>
+              <a:t>PR 4 关：  Claude PR Review (新会话)  +  Codex Bot  +  Detekt  +  人工真机验证</a:t>
+            </a:r>
+          </a:p>
+          <a:p>
+            <a:r>
+              <a:rPr sz="1200">
+                <a:solidFill>
+                  <a:srgbClr val="202020"/>
+                </a:solidFill>
+                <a:latin typeface="Consolas"/>
+              </a:rPr>
+              <a:t> </a:t>
+            </a:r>
+          </a:p>
+          <a:p>
+            <a:r>
+              <a:rPr sz="1200">
+                <a:solidFill>
+                  <a:srgbClr val="202020"/>
+                </a:solidFill>
+                <a:latin typeface="Consolas"/>
+              </a:rPr>
+              <a:t>测试驱动：  关键路径（结算 / 协议 / 并发）必须 TDD，Haiku 4.5 批量生成边界用例</a:t>
+            </a:r>
+          </a:p>
+        </p:txBody>
+      </p:sp>
+      <p:sp>
+        <p:nvSpPr>
+          <p:cNvPr id="11" name="Rounded Rectangle 10"/>
+          <p:cNvSpPr/>
+          <p:nvPr/>
+        </p:nvSpPr>
+        <p:spPr>
+          <a:xfrm>
+            <a:off x="457200" y="6400800"/>
+            <a:ext cx="11338560" cy="365760"/>
+          </a:xfrm>
+          <a:prstGeom prst="roundRect">
+            <a:avLst/>
+          </a:prstGeom>
+          <a:solidFill>
+            <a:srgbClr val="F0F4FF"/>
+          </a:solidFill>
+          <a:ln>
+            <a:solidFill>
+              <a:srgbClr val="1A73E8"/>
+            </a:solidFill>
+          </a:ln>
+        </p:spPr>
+        <p:style>
+          <a:lnRef idx="1">
+            <a:schemeClr val="accent1"/>
+          </a:lnRef>
+          <a:fillRef idx="3">
+            <a:schemeClr val="accent1"/>
+          </a:fillRef>
+          <a:effectRef idx="2">
+            <a:schemeClr val="accent1"/>
+          </a:effectRef>
+          <a:fontRef idx="minor">
+            <a:schemeClr val="lt1"/>
+          </a:fontRef>
+        </p:style>
+        <p:txBody>
+          <a:bodyPr rtlCol="0" anchor="ctr" wrap="square" lIns="150000" rIns="150000"/>
+          <a:lstStyle/>
+          <a:p>
+            <a:pPr algn="ctr"/>
+            <a:r>
+              <a:rPr sz="1000" b="1">
+                <a:solidFill>
+                  <a:srgbClr val="1A73E8"/>
+                </a:solidFill>
+                <a:latin typeface="Microsoft YaHei"/>
+              </a:rPr>
+              <a:t>💡 单 Claude 多轮 = 时间换覆盖率  ·  多 Claude = 视角换覆盖率  ·  多 vendor + 静态 + 真机 = 异构换覆盖率（边际收益最大）</a:t>
+            </a:r>
+          </a:p>
+        </p:txBody>
+      </p:sp>
+      <p:sp>
+        <p:nvSpPr>
+          <p:cNvPr id="12" name="TextBox 11"/>
+          <p:cNvSpPr txBox="1"/>
+          <p:nvPr/>
+        </p:nvSpPr>
+        <p:spPr>
+          <a:xfrm>
+            <a:off x="10789920" y="6446520"/>
+            <a:ext cx="1188720" cy="274320"/>
+          </a:xfrm>
+          <a:prstGeom prst="rect">
+            <a:avLst/>
+          </a:prstGeom>
+          <a:noFill/>
+        </p:spPr>
+        <p:txBody>
+          <a:bodyPr wrap="square" lIns="0" rIns="0" tIns="0" bIns="0">
+            <a:spAutoFit/>
+          </a:bodyPr>
+          <a:lstStyle/>
+          <a:p>
+            <a:pPr algn="r"/>
+            <a:r>
+              <a:rPr sz="1000" b="0">
+                <a:solidFill>
+                  <a:srgbClr val="606060"/>
+                </a:solidFill>
+                <a:latin typeface="Microsoft YaHei"/>
+              </a:rPr>
+              <a:t>11 / 13</a:t>
+            </a:r>
+          </a:p>
+        </p:txBody>
+      </p:sp>
+    </p:spTree>
+  </p:cSld>
+  <p:clrMapOvr>
+    <a:masterClrMapping/>
+  </p:clrMapOvr>
+</p:sld>
+</file>
+
+<file path=ppt/slides/slide12.xml><?xml version="1.0" encoding="utf-8"?>
+<p:sld xmlns:a="http://schemas.openxmlformats.org/drawingml/2006/main" xmlns:p="http://schemas.openxmlformats.org/presentationml/2006/main" xmlns:r="http://schemas.openxmlformats.org/officeDocument/2006/relationships">
+  <p:cSld>
+    <p:spTree>
+      <p:nvGrpSpPr>
+        <p:cNvPr id="1" name=""/>
+        <p:cNvGrpSpPr/>
+        <p:nvPr/>
+      </p:nvGrpSpPr>
+      <p:grpSpPr/>
+      <p:sp>
+        <p:nvSpPr>
+          <p:cNvPr id="2" name="TextBox 1"/>
+          <p:cNvSpPr txBox="1"/>
+          <p:nvPr/>
+        </p:nvSpPr>
+        <p:spPr>
+          <a:xfrm>
+            <a:off x="457200" y="274320"/>
+            <a:ext cx="11247120" cy="457200"/>
+          </a:xfrm>
+          <a:prstGeom prst="rect">
+            <a:avLst/>
+          </a:prstGeom>
+          <a:noFill/>
+        </p:spPr>
+        <p:txBody>
+          <a:bodyPr wrap="square" lIns="0" rIns="0" tIns="0" bIns="0">
+            <a:spAutoFit/>
+          </a:bodyPr>
+          <a:lstStyle/>
+          <a:p>
+            <a:pPr algn="l"/>
+            <a:r>
+              <a:rPr sz="2400" b="1">
+                <a:solidFill>
+                  <a:srgbClr val="1A73E8"/>
+                </a:solidFill>
+                <a:latin typeface="Microsoft YaHei"/>
+              </a:rPr>
+              <a:t>七、关键技术修复（3 处核心）</a:t>
+            </a:r>
+          </a:p>
+        </p:txBody>
+      </p:sp>
+      <p:sp>
+        <p:nvSpPr>
+          <p:cNvPr id="3" name="Rectangle 2"/>
+          <p:cNvSpPr/>
+          <p:nvPr/>
+        </p:nvSpPr>
+        <p:spPr>
+          <a:xfrm>
+            <a:off x="457200" y="777240"/>
+            <a:ext cx="11247120" cy="36576"/>
+          </a:xfrm>
+          <a:prstGeom prst="rect">
+            <a:avLst/>
+          </a:prstGeom>
+          <a:solidFill>
+            <a:srgbClr val="1A73E8"/>
+          </a:solidFill>
+          <a:ln>
+            <a:noFill/>
+          </a:ln>
+        </p:spPr>
+        <p:style>
+          <a:lnRef idx="1">
+            <a:schemeClr val="accent1"/>
+          </a:lnRef>
+          <a:fillRef idx="3">
+            <a:schemeClr val="accent1"/>
+          </a:fillRef>
+          <a:effectRef idx="2">
+            <a:schemeClr val="accent1"/>
+          </a:effectRef>
+          <a:fontRef idx="minor">
+            <a:schemeClr val="lt1"/>
+          </a:fontRef>
+        </p:style>
+        <p:txBody>
+          <a:bodyPr rtlCol="0" anchor="ctr"/>
+          <a:lstStyle/>
+          <a:p>
+            <a:pPr algn="ctr"/>
+          </a:p>
+        </p:txBody>
+      </p:sp>
+      <p:sp>
+        <p:nvSpPr>
+          <p:cNvPr id="4" name="TextBox 3"/>
+          <p:cNvSpPr txBox="1"/>
+          <p:nvPr/>
+        </p:nvSpPr>
+        <p:spPr>
+          <a:xfrm>
+            <a:off x="457200" y="960120"/>
+            <a:ext cx="11247120" cy="365760"/>
+          </a:xfrm>
+          <a:prstGeom prst="rect">
+            <a:avLst/>
+          </a:prstGeom>
+          <a:noFill/>
+        </p:spPr>
+        <p:txBody>
+          <a:bodyPr wrap="square" lIns="0" rIns="0" tIns="0" bIns="0">
+            <a:spAutoFit/>
+          </a:bodyPr>
+          <a:lstStyle/>
+          <a:p>
+            <a:pPr algn="l"/>
+            <a:r>
+              <a:rPr sz="1400" b="1">
+                <a:solidFill>
+                  <a:srgbClr val="1A73E8"/>
+                </a:solidFill>
+                <a:latin typeface="Microsoft YaHei"/>
+              </a:rPr>
+              <a:t>1️⃣ 游戏卡死 — 四层防御</a:t>
+            </a:r>
+          </a:p>
+        </p:txBody>
+      </p:sp>
+      <p:sp>
+        <p:nvSpPr>
+          <p:cNvPr id="5" name="Rectangle 4"/>
+          <p:cNvSpPr/>
+          <p:nvPr/>
+        </p:nvSpPr>
+        <p:spPr>
+          <a:xfrm>
+            <a:off x="457200" y="1371600"/>
+            <a:ext cx="11247120" cy="1554480"/>
+          </a:xfrm>
+          <a:prstGeom prst="rect">
+            <a:avLst/>
+          </a:prstGeom>
+          <a:solidFill>
+            <a:srgbClr val="F4F4F4"/>
+          </a:solidFill>
+          <a:ln>
+            <a:solidFill>
+              <a:srgbClr val="D0D0D0"/>
+            </a:solidFill>
+          </a:ln>
+        </p:spPr>
+        <p:style>
+          <a:lnRef idx="1">
+            <a:schemeClr val="accent1"/>
+          </a:lnRef>
+          <a:fillRef idx="3">
+            <a:schemeClr val="accent1"/>
+          </a:fillRef>
+          <a:effectRef idx="2">
+            <a:schemeClr val="accent1"/>
+          </a:effectRef>
+          <a:fontRef idx="minor">
+            <a:schemeClr val="lt1"/>
+          </a:fontRef>
+        </p:style>
+        <p:txBody>
+          <a:bodyPr rtlCol="0" anchor="ctr" wrap="square" lIns="120000" rIns="120000" tIns="80000" bIns="80000"/>
+          <a:lstStyle/>
+          <a:p>
+            <a:pPr algn="ctr"/>
+            <a:r>
+              <a:rPr sz="1200">
+                <a:solidFill>
+                  <a:srgbClr val="202020"/>
+                </a:solidFill>
+                <a:latin typeface="Consolas"/>
+              </a:rPr>
+              <a:t>[层1] canBeat 炸弹比较错误：大张数应直接胜（修复前要求同张数）</a:t>
+            </a:r>
+          </a:p>
+          <a:p>
+            <a:r>
+              <a:rPr sz="1200">
+                <a:solidFill>
+                  <a:srgbClr val="202020"/>
+                </a:solidFill>
+                <a:latin typeface="Consolas"/>
+              </a:rPr>
+              <a:t>[层2] AI 失败无回退：增加三级回退（首选 → 过牌 → 最小单张）</a:t>
+            </a:r>
+          </a:p>
+          <a:p>
+            <a:r>
+              <a:rPr sz="1200">
+                <a:solidFill>
+                  <a:srgbClr val="202020"/>
+                </a:solidFill>
+                <a:latin typeface="Consolas"/>
+              </a:rPr>
+              <a:t>[层3] 多协程无锁并发写 state.hands：每房间一把 Mutex（改在锁内/广播在锁外）</a:t>
+            </a:r>
+          </a:p>
+          <a:p>
+            <a:r>
+              <a:rPr sz="1200">
+                <a:solidFill>
+                  <a:srgbClr val="202020"/>
+                </a:solidFill>
+                <a:latin typeface="Consolas"/>
+              </a:rPr>
+              <a:t>[层4] 三级回退仍失败：broadcastForceAdvance 强制推进兜底</a:t>
+            </a:r>
+          </a:p>
+        </p:txBody>
+      </p:sp>
+      <p:sp>
+        <p:nvSpPr>
+          <p:cNvPr id="6" name="TextBox 5"/>
+          <p:cNvSpPr txBox="1"/>
+          <p:nvPr/>
+        </p:nvSpPr>
+        <p:spPr>
+          <a:xfrm>
+            <a:off x="457200" y="3017520"/>
+            <a:ext cx="11247120" cy="365760"/>
+          </a:xfrm>
+          <a:prstGeom prst="rect">
+            <a:avLst/>
+          </a:prstGeom>
+          <a:noFill/>
+        </p:spPr>
+        <p:txBody>
+          <a:bodyPr wrap="square" lIns="0" rIns="0" tIns="0" bIns="0">
+            <a:spAutoFit/>
+          </a:bodyPr>
+          <a:lstStyle/>
+          <a:p>
+            <a:pPr algn="l"/>
+            <a:r>
+              <a:rPr sz="1400" b="1">
+                <a:solidFill>
+                  <a:srgbClr val="1A73E8"/>
+                </a:solidFill>
+                <a:latin typeface="Microsoft YaHei"/>
+              </a:rPr>
+              <a:t>2️⃣ 重连失效 — 异步时序陷阱</a:t>
+            </a:r>
+          </a:p>
+        </p:txBody>
+      </p:sp>
+      <p:sp>
+        <p:nvSpPr>
+          <p:cNvPr id="7" name="Rectangle 6"/>
+          <p:cNvSpPr/>
+          <p:nvPr/>
+        </p:nvSpPr>
+        <p:spPr>
+          <a:xfrm>
+            <a:off x="457200" y="3429000"/>
+            <a:ext cx="11247120" cy="1280160"/>
+          </a:xfrm>
+          <a:prstGeom prst="rect">
+            <a:avLst/>
+          </a:prstGeom>
+          <a:solidFill>
+            <a:srgbClr val="F4F4F4"/>
+          </a:solidFill>
+          <a:ln>
+            <a:solidFill>
+              <a:srgbClr val="D0D0D0"/>
+            </a:solidFill>
+          </a:ln>
+        </p:spPr>
+        <p:style>
+          <a:lnRef idx="1">
+            <a:schemeClr val="accent1"/>
+          </a:lnRef>
+          <a:fillRef idx="3">
+            <a:schemeClr val="accent1"/>
+          </a:fillRef>
+          <a:effectRef idx="2">
+            <a:schemeClr val="accent1"/>
+          </a:effectRef>
+          <a:fontRef idx="minor">
+            <a:schemeClr val="lt1"/>
+          </a:fontRef>
+        </p:style>
+        <p:txBody>
+          <a:bodyPr rtlCol="0" anchor="ctr" wrap="square" lIns="120000" rIns="120000" tIns="80000" bIns="80000"/>
+          <a:lstStyle/>
+          <a:p>
+            <a:pPr algn="ctr"/>
+            <a:r>
+              <a:rPr sz="1200">
+                <a:solidFill>
+                  <a:srgbClr val="202020"/>
+                </a:solidFill>
+                <a:latin typeface="Consolas"/>
+              </a:rPr>
+              <a:t>❌ 修复前：newWebSocket() 后立即 send(Reconnect)，ws 仍在 CONNECTING → 静默丢弃</a:t>
+            </a:r>
+          </a:p>
+          <a:p>
+            <a:r>
+              <a:rPr sz="1200">
+                <a:solidFill>
+                  <a:srgbClr val="202020"/>
+                </a:solidFill>
+                <a:latin typeface="Consolas"/>
+              </a:rPr>
+              <a:t>✅ 修复后：在 onOpen 回调内 send，确保 ws 已 OPEN</a:t>
+            </a:r>
+          </a:p>
+          <a:p>
+            <a:r>
+              <a:rPr sz="1200">
+                <a:solidFill>
+                  <a:srgbClr val="202020"/>
+                </a:solidFill>
+                <a:latin typeface="Consolas"/>
+              </a:rPr>
+              <a:t>教训：「创建连接」≠「连接已建立」，异步 API 必须在回调中操作</a:t>
+            </a:r>
+          </a:p>
+        </p:txBody>
+      </p:sp>
+      <p:sp>
+        <p:nvSpPr>
+          <p:cNvPr id="8" name="TextBox 7"/>
+          <p:cNvSpPr txBox="1"/>
+          <p:nvPr/>
+        </p:nvSpPr>
+        <p:spPr>
+          <a:xfrm>
+            <a:off x="457200" y="4800600"/>
+            <a:ext cx="11247120" cy="365760"/>
+          </a:xfrm>
+          <a:prstGeom prst="rect">
+            <a:avLst/>
+          </a:prstGeom>
+          <a:noFill/>
+        </p:spPr>
+        <p:txBody>
+          <a:bodyPr wrap="square" lIns="0" rIns="0" tIns="0" bIns="0">
+            <a:spAutoFit/>
+          </a:bodyPr>
+          <a:lstStyle/>
+          <a:p>
+            <a:pPr algn="l"/>
+            <a:r>
+              <a:rPr sz="1400" b="1">
+                <a:solidFill>
+                  <a:srgbClr val="1A73E8"/>
+                </a:solidFill>
+                <a:latin typeface="Microsoft YaHei"/>
+              </a:rPr>
+              <a:t>3️⃣ 两端结算不一致 — 统一公式</a:t>
+            </a:r>
+          </a:p>
+        </p:txBody>
+      </p:sp>
+      <p:sp>
+        <p:nvSpPr>
+          <p:cNvPr id="9" name="Rectangle 8"/>
+          <p:cNvSpPr/>
+          <p:nvPr/>
+        </p:nvSpPr>
+        <p:spPr>
+          <a:xfrm>
+            <a:off x="457200" y="5212080"/>
+            <a:ext cx="11247120" cy="1371600"/>
+          </a:xfrm>
+          <a:prstGeom prst="rect">
+            <a:avLst/>
+          </a:prstGeom>
+          <a:solidFill>
+            <a:srgbClr val="F4F4F4"/>
+          </a:solidFill>
+          <a:ln>
+            <a:solidFill>
+              <a:srgbClr val="D0D0D0"/>
+            </a:solidFill>
+          </a:ln>
+        </p:spPr>
+        <p:style>
+          <a:lnRef idx="1">
+            <a:schemeClr val="accent1"/>
+          </a:lnRef>
+          <a:fillRef idx="3">
+            <a:schemeClr val="accent1"/>
+          </a:fillRef>
+          <a:effectRef idx="2">
+            <a:schemeClr val="accent1"/>
+          </a:effectRef>
+          <a:fontRef idx="minor">
+            <a:schemeClr val="lt1"/>
+          </a:fontRef>
+        </p:style>
+        <p:txBody>
+          <a:bodyPr rtlCol="0" anchor="ctr" wrap="square" lIns="120000" rIns="120000" tIns="80000" bIns="80000"/>
+          <a:lstStyle/>
+          <a:p>
+            <a:pPr algn="ctr"/>
+            <a:r>
+              <a:rPr sz="1200">
+                <a:solidFill>
+                  <a:srgbClr val="202020"/>
+                </a:solidFill>
+                <a:latin typeface="Consolas"/>
+              </a:rPr>
+              <a:t>根因：collectedScore 硬编码为 0；服务端漏算「输方未走完已收分」</a:t>
+            </a:r>
+          </a:p>
+          <a:p>
+            <a:r>
+              <a:rPr sz="1200">
+                <a:solidFill>
+                  <a:srgbClr val="202020"/>
+                </a:solidFill>
+                <a:latin typeface="Consolas"/>
+              </a:rPr>
+              <a:t>统一公式：赢方 = 赢方所有已收 + 输方未走完(已收 + 手牌分)；输方 = 输方已走完已收</a:t>
+            </a:r>
+          </a:p>
+          <a:p>
+            <a:r>
+              <a:rPr sz="1200">
+                <a:solidFill>
+                  <a:srgbClr val="202020"/>
+                </a:solidFill>
+                <a:latin typeface="Consolas"/>
+              </a:rPr>
+              <a:t>新增 state.playerScores: MutableMap&lt;Int,Int&gt; 实时追踪每人已收分</a:t>
+            </a:r>
+          </a:p>
+          <a:p>
+            <a:r>
+              <a:rPr sz="1200">
+                <a:solidFill>
+                  <a:srgbClr val="202020"/>
+                </a:solidFill>
+                <a:latin typeface="Consolas"/>
+              </a:rPr>
+              <a:t>✓ 15 个验证用例全部通过（含提前结算、速度流、极端场景）</a:t>
+            </a:r>
+          </a:p>
+        </p:txBody>
+      </p:sp>
+      <p:sp>
+        <p:nvSpPr>
+          <p:cNvPr id="10" name="TextBox 9"/>
+          <p:cNvSpPr txBox="1"/>
+          <p:nvPr/>
+        </p:nvSpPr>
+        <p:spPr>
+          <a:xfrm>
+            <a:off x="10789920" y="6446520"/>
+            <a:ext cx="1188720" cy="274320"/>
+          </a:xfrm>
+          <a:prstGeom prst="rect">
+            <a:avLst/>
+          </a:prstGeom>
+          <a:noFill/>
+        </p:spPr>
+        <p:txBody>
+          <a:bodyPr wrap="square" lIns="0" rIns="0" tIns="0" bIns="0">
+            <a:spAutoFit/>
+          </a:bodyPr>
+          <a:lstStyle/>
+          <a:p>
+            <a:pPr algn="r"/>
+            <a:r>
+              <a:rPr sz="1000" b="0">
+                <a:solidFill>
+                  <a:srgbClr val="606060"/>
+                </a:solidFill>
+                <a:latin typeface="Microsoft YaHei"/>
+              </a:rPr>
+              <a:t>12 / 13</a:t>
+            </a:r>
+          </a:p>
+        </p:txBody>
+      </p:sp>
+    </p:spTree>
+  </p:cSld>
+  <p:clrMapOvr>
+    <a:masterClrMapping/>
+  </p:clrMapOvr>
+</p:sld>
+</file>
+
+<file path=ppt/slides/slide13.xml><?xml version="1.0" encoding="utf-8"?>
+<p:sld xmlns:a="http://schemas.openxmlformats.org/drawingml/2006/main" xmlns:p="http://schemas.openxmlformats.org/presentationml/2006/main" xmlns:r="http://schemas.openxmlformats.org/officeDocument/2006/relationships">
+  <p:cSld>
+    <p:spTree>
+      <p:nvGrpSpPr>
+        <p:cNvPr id="1" name=""/>
+        <p:cNvGrpSpPr/>
+        <p:nvPr/>
+      </p:nvGrpSpPr>
+      <p:grpSpPr/>
+      <p:sp>
+        <p:nvSpPr>
+          <p:cNvPr id="2" name="TextBox 1"/>
+          <p:cNvSpPr txBox="1"/>
+          <p:nvPr/>
+        </p:nvSpPr>
+        <p:spPr>
+          <a:xfrm>
+            <a:off x="457200" y="274320"/>
+            <a:ext cx="11247120" cy="457200"/>
+          </a:xfrm>
+          <a:prstGeom prst="rect">
+            <a:avLst/>
+          </a:prstGeom>
+          <a:noFill/>
+        </p:spPr>
+        <p:txBody>
+          <a:bodyPr wrap="square" lIns="0" rIns="0" tIns="0" bIns="0">
+            <a:spAutoFit/>
+          </a:bodyPr>
+          <a:lstStyle/>
+          <a:p>
+            <a:pPr algn="l"/>
+            <a:r>
+              <a:rPr sz="2400" b="1">
+                <a:solidFill>
+                  <a:srgbClr val="1A73E8"/>
+                </a:solidFill>
+                <a:latin typeface="Microsoft YaHei"/>
+              </a:rPr>
+              <a:t>八、经验总结 &amp; 后续行动</a:t>
             </a:r>
           </a:p>
         </p:txBody>
@@ -4255,7 +6584,7 @@
                 </a:solidFill>
                 <a:latin typeface="Microsoft YaHei"/>
               </a:rPr>
-              <a:t>10 / 10</a:t>
+              <a:t>13 / 13</a:t>
             </a:r>
           </a:p>
         </p:txBody>
@@ -5511,7 +7840,7 @@
                 </a:solidFill>
                 <a:latin typeface="Microsoft YaHei"/>
               </a:rPr>
-              <a:t>2 / 10</a:t>
+              <a:t>2 / 13</a:t>
             </a:r>
           </a:p>
         </p:txBody>
@@ -6557,7 +8886,7 @@
                 </a:solidFill>
                 <a:latin typeface="Microsoft YaHei"/>
               </a:rPr>
-              <a:t>3 / 10</a:t>
+              <a:t>3 / 13</a:t>
             </a:r>
           </a:p>
         </p:txBody>
@@ -7492,7 +9821,7 @@
                 </a:solidFill>
                 <a:latin typeface="Microsoft YaHei"/>
               </a:rPr>
-              <a:t>4 / 10</a:t>
+              <a:t>4 / 13</a:t>
             </a:r>
           </a:p>
         </p:txBody>
@@ -8382,7 +10711,7 @@
                 </a:solidFill>
                 <a:latin typeface="Microsoft YaHei"/>
               </a:rPr>
-              <a:t>5 / 10</a:t>
+              <a:t>5 / 13</a:t>
             </a:r>
           </a:p>
         </p:txBody>
@@ -9422,7 +11751,7 @@
                 </a:solidFill>
                 <a:latin typeface="Microsoft YaHei"/>
               </a:rPr>
-              <a:t>6 / 10</a:t>
+              <a:t>6 / 13</a:t>
             </a:r>
           </a:p>
         </p:txBody>
@@ -10763,7 +13092,7 @@
                 </a:solidFill>
                 <a:latin typeface="Microsoft YaHei"/>
               </a:rPr>
-              <a:t>7 / 10</a:t>
+              <a:t>7 / 13</a:t>
             </a:r>
           </a:p>
         </p:txBody>
@@ -11916,7 +14245,7 @@
                 </a:solidFill>
                 <a:latin typeface="Microsoft YaHei"/>
               </a:rPr>
-              <a:t>8 / 10</a:t>
+              <a:t>8 / 13</a:t>
             </a:r>
           </a:p>
         </p:txBody>
@@ -11969,7 +14298,7 @@
                 </a:solidFill>
                 <a:latin typeface="Microsoft YaHei"/>
               </a:rPr>
-              <a:t>六、关键技术修复（3 处核心）</a:t>
+              <a:t>六、反思：为什么 AI 写的代码 Bug 不少？</a:t>
             </a:r>
           </a:p>
         </p:txBody>
@@ -12025,7 +14354,7 @@
         </p:nvSpPr>
         <p:spPr>
           <a:xfrm>
-            <a:off x="457200" y="960120"/>
+            <a:off x="457200" y="914400"/>
             <a:ext cx="11247120" cy="365760"/>
           </a:xfrm>
           <a:prstGeom prst="rect">
@@ -12047,31 +14376,901 @@
                 </a:solidFill>
                 <a:latin typeface="Microsoft YaHei"/>
               </a:rPr>
-              <a:t>1️⃣ 游戏卡死 — 四层防御</a:t>
-            </a:r>
-          </a:p>
-        </p:txBody>
-      </p:sp>
-      <p:sp>
-        <p:nvSpPr>
-          <p:cNvPr id="5" name="Rectangle 4"/>
-          <p:cNvSpPr/>
-          <p:nvPr/>
-        </p:nvSpPr>
-        <p:spPr>
-          <a:xfrm>
-            <a:off x="457200" y="1371600"/>
-            <a:ext cx="11247120" cy="1554480"/>
+              <a:t>🔵 生成阶段必然有 Bug 的 5 个结构性原因</a:t>
+            </a:r>
+          </a:p>
+        </p:txBody>
+      </p:sp>
+      <p:graphicFrame>
+        <p:nvGraphicFramePr>
+          <p:cNvPr id="5" name="Table 4"/>
+          <p:cNvGraphicFramePr>
+            <a:graphicFrameLocks noGrp="1"/>
+          </p:cNvGraphicFramePr>
+          <p:nvPr/>
+        </p:nvGraphicFramePr>
+        <p:xfrm>
+          <a:off x="457200" y="1325880"/>
+          <a:ext cx="11247120" cy="2286000"/>
+        </p:xfrm>
+        <a:graphic>
+          <a:graphicData uri="http://schemas.openxmlformats.org/drawingml/2006/table">
+            <a:tbl>
+              <a:tblPr firstRow="1" bandRow="1">
+                <a:tableStyleId>{5C22544A-7EE6-4342-B048-85BDC9FD1C3A}</a:tableStyleId>
+              </a:tblPr>
+              <a:tblGrid>
+                <a:gridCol w="457200"/>
+                <a:gridCol w="4114800"/>
+                <a:gridCol w="6675120"/>
+              </a:tblGrid>
+              <a:tr h="381000">
+                <a:tc>
+                  <a:txBody>
+                    <a:bodyPr lIns="40000" rIns="40000" tIns="15000" bIns="15000"/>
+                    <a:lstStyle/>
+                    <a:p>
+                      <a:pPr algn="ctr"/>
+                      <a:r>
+                        <a:rPr sz="1200" b="1">
+                          <a:solidFill>
+                            <a:srgbClr val="FFFFFF"/>
+                          </a:solidFill>
+                          <a:latin typeface="Microsoft YaHei"/>
+                        </a:rPr>
+                        <a:t>#</a:t>
+                      </a:r>
+                    </a:p>
+                  </a:txBody>
+                  <a:tcPr>
+                    <a:solidFill>
+                      <a:srgbClr val="1A73E8"/>
+                    </a:solidFill>
+                  </a:tcPr>
+                </a:tc>
+                <a:tc>
+                  <a:txBody>
+                    <a:bodyPr lIns="40000" rIns="40000" tIns="15000" bIns="15000"/>
+                    <a:lstStyle/>
+                    <a:p>
+                      <a:pPr algn="ctr"/>
+                      <a:r>
+                        <a:rPr sz="1200" b="1">
+                          <a:solidFill>
+                            <a:srgbClr val="FFFFFF"/>
+                          </a:solidFill>
+                          <a:latin typeface="Microsoft YaHei"/>
+                        </a:rPr>
+                        <a:t>原因</a:t>
+                      </a:r>
+                    </a:p>
+                  </a:txBody>
+                  <a:tcPr>
+                    <a:solidFill>
+                      <a:srgbClr val="1A73E8"/>
+                    </a:solidFill>
+                  </a:tcPr>
+                </a:tc>
+                <a:tc>
+                  <a:txBody>
+                    <a:bodyPr lIns="40000" rIns="40000" tIns="15000" bIns="15000"/>
+                    <a:lstStyle/>
+                    <a:p>
+                      <a:pPr algn="ctr"/>
+                      <a:r>
+                        <a:rPr sz="1200" b="1">
+                          <a:solidFill>
+                            <a:srgbClr val="FFFFFF"/>
+                          </a:solidFill>
+                          <a:latin typeface="Microsoft YaHei"/>
+                        </a:rPr>
+                        <a:t>本项目例子</a:t>
+                      </a:r>
+                    </a:p>
+                  </a:txBody>
+                  <a:tcPr>
+                    <a:solidFill>
+                      <a:srgbClr val="1A73E8"/>
+                    </a:solidFill>
+                  </a:tcPr>
+                </a:tc>
+              </a:tr>
+              <a:tr h="381000">
+                <a:tc>
+                  <a:txBody>
+                    <a:bodyPr lIns="40000" rIns="40000" tIns="10000" bIns="10000" wrap="square"/>
+                    <a:lstStyle/>
+                    <a:p>
+                      <a:pPr algn="l"/>
+                      <a:r>
+                        <a:rPr sz="1200">
+                          <a:solidFill>
+                            <a:srgbClr val="202020"/>
+                          </a:solidFill>
+                          <a:latin typeface="Microsoft YaHei"/>
+                        </a:rPr>
+                        <a:t>1</a:t>
+                      </a:r>
+                    </a:p>
+                  </a:txBody>
+                  <a:tcPr>
+                    <a:solidFill>
+                      <a:srgbClr val="FFFFFF"/>
+                    </a:solidFill>
+                  </a:tcPr>
+                </a:tc>
+                <a:tc>
+                  <a:txBody>
+                    <a:bodyPr lIns="40000" rIns="40000" tIns="10000" bIns="10000" wrap="square"/>
+                    <a:lstStyle/>
+                    <a:p>
+                      <a:pPr algn="l"/>
+                      <a:r>
+                        <a:rPr sz="1200">
+                          <a:solidFill>
+                            <a:srgbClr val="202020"/>
+                          </a:solidFill>
+                          <a:latin typeface="Microsoft YaHei"/>
+                        </a:rPr>
+                        <a:t>生成 vs 验证是不同认知任务</a:t>
+                      </a:r>
+                    </a:p>
+                  </a:txBody>
+                  <a:tcPr>
+                    <a:solidFill>
+                      <a:srgbClr val="FFFFFF"/>
+                    </a:solidFill>
+                  </a:tcPr>
+                </a:tc>
+                <a:tc>
+                  <a:txBody>
+                    <a:bodyPr lIns="40000" rIns="40000" tIns="10000" bIns="10000" wrap="square"/>
+                    <a:lstStyle/>
+                    <a:p>
+                      <a:pPr algn="l"/>
+                      <a:r>
+                        <a:rPr sz="1200">
+                          <a:solidFill>
+                            <a:srgbClr val="202020"/>
+                          </a:solidFill>
+                          <a:latin typeface="Microsoft YaHei"/>
+                        </a:rPr>
+                        <a:t>canBeat 套用「同张数比大小」常用模式，忽略大炸弹直胜</a:t>
+                      </a:r>
+                    </a:p>
+                  </a:txBody>
+                  <a:tcPr>
+                    <a:solidFill>
+                      <a:srgbClr val="FFFFFF"/>
+                    </a:solidFill>
+                  </a:tcPr>
+                </a:tc>
+              </a:tr>
+              <a:tr h="381000">
+                <a:tc>
+                  <a:txBody>
+                    <a:bodyPr lIns="40000" rIns="40000" tIns="10000" bIns="10000" wrap="square"/>
+                    <a:lstStyle/>
+                    <a:p>
+                      <a:pPr algn="l"/>
+                      <a:r>
+                        <a:rPr sz="1200">
+                          <a:solidFill>
+                            <a:srgbClr val="202020"/>
+                          </a:solidFill>
+                          <a:latin typeface="Microsoft YaHei"/>
+                        </a:rPr>
+                        <a:t>2</a:t>
+                      </a:r>
+                    </a:p>
+                  </a:txBody>
+                  <a:tcPr>
+                    <a:solidFill>
+                      <a:srgbClr val="F0F4FF"/>
+                    </a:solidFill>
+                  </a:tcPr>
+                </a:tc>
+                <a:tc>
+                  <a:txBody>
+                    <a:bodyPr lIns="40000" rIns="40000" tIns="10000" bIns="10000" wrap="square"/>
+                    <a:lstStyle/>
+                    <a:p>
+                      <a:pPr algn="l"/>
+                      <a:r>
+                        <a:rPr sz="1200">
+                          <a:solidFill>
+                            <a:srgbClr val="202020"/>
+                          </a:solidFill>
+                          <a:latin typeface="Microsoft YaHei"/>
+                        </a:rPr>
+                        <a:t>生成时无执行反馈，时序/并发是盲区</a:t>
+                      </a:r>
+                    </a:p>
+                  </a:txBody>
+                  <a:tcPr>
+                    <a:solidFill>
+                      <a:srgbClr val="F0F4FF"/>
+                    </a:solidFill>
+                  </a:tcPr>
+                </a:tc>
+                <a:tc>
+                  <a:txBody>
+                    <a:bodyPr lIns="40000" rIns="40000" tIns="10000" bIns="10000" wrap="square"/>
+                    <a:lstStyle/>
+                    <a:p>
+                      <a:pPr algn="l"/>
+                      <a:r>
+                        <a:rPr sz="1200">
+                          <a:solidFill>
+                            <a:srgbClr val="202020"/>
+                          </a:solidFill>
+                          <a:latin typeface="Microsoft YaHei"/>
+                        </a:rPr>
+                        <a:t>WebSocket CONNECTING 时 send() 静默失败</a:t>
+                      </a:r>
+                    </a:p>
+                  </a:txBody>
+                  <a:tcPr>
+                    <a:solidFill>
+                      <a:srgbClr val="F0F4FF"/>
+                    </a:solidFill>
+                  </a:tcPr>
+                </a:tc>
+              </a:tr>
+              <a:tr h="381000">
+                <a:tc>
+                  <a:txBody>
+                    <a:bodyPr lIns="40000" rIns="40000" tIns="10000" bIns="10000" wrap="square"/>
+                    <a:lstStyle/>
+                    <a:p>
+                      <a:pPr algn="l"/>
+                      <a:r>
+                        <a:rPr sz="1200">
+                          <a:solidFill>
+                            <a:srgbClr val="202020"/>
+                          </a:solidFill>
+                          <a:latin typeface="Microsoft YaHei"/>
+                        </a:rPr>
+                        <a:t>3</a:t>
+                      </a:r>
+                    </a:p>
+                  </a:txBody>
+                  <a:tcPr>
+                    <a:solidFill>
+                      <a:srgbClr val="FFFFFF"/>
+                    </a:solidFill>
+                  </a:tcPr>
+                </a:tc>
+                <a:tc>
+                  <a:txBody>
+                    <a:bodyPr lIns="40000" rIns="40000" tIns="10000" bIns="10000" wrap="square"/>
+                    <a:lstStyle/>
+                    <a:p>
+                      <a:pPr algn="l"/>
+                      <a:r>
+                        <a:rPr sz="1200">
+                          <a:solidFill>
+                            <a:srgbClr val="202020"/>
+                          </a:solidFill>
+                          <a:latin typeface="Microsoft YaHei"/>
+                        </a:rPr>
+                        <a:t>自然语言规格隐式不完整</a:t>
+                      </a:r>
+                    </a:p>
+                  </a:txBody>
+                  <a:tcPr>
+                    <a:solidFill>
+                      <a:srgbClr val="FFFFFF"/>
+                    </a:solidFill>
+                  </a:tcPr>
+                </a:tc>
+                <a:tc>
+                  <a:txBody>
+                    <a:bodyPr lIns="40000" rIns="40000" tIns="10000" bIns="10000" wrap="square"/>
+                    <a:lstStyle/>
+                    <a:p>
+                      <a:pPr algn="l"/>
+                      <a:r>
+                        <a:rPr sz="1200">
+                          <a:solidFill>
+                            <a:srgbClr val="202020"/>
+                          </a:solidFill>
+                          <a:latin typeface="Microsoft YaHei"/>
+                        </a:rPr>
+                        <a:t>「重连后游戏继续」未明确秒数和保留状态</a:t>
+                      </a:r>
+                    </a:p>
+                  </a:txBody>
+                  <a:tcPr>
+                    <a:solidFill>
+                      <a:srgbClr val="FFFFFF"/>
+                    </a:solidFill>
+                  </a:tcPr>
+                </a:tc>
+              </a:tr>
+              <a:tr h="381000">
+                <a:tc>
+                  <a:txBody>
+                    <a:bodyPr lIns="40000" rIns="40000" tIns="10000" bIns="10000" wrap="square"/>
+                    <a:lstStyle/>
+                    <a:p>
+                      <a:pPr algn="l"/>
+                      <a:r>
+                        <a:rPr sz="1200">
+                          <a:solidFill>
+                            <a:srgbClr val="202020"/>
+                          </a:solidFill>
+                          <a:latin typeface="Microsoft YaHei"/>
+                        </a:rPr>
+                        <a:t>4</a:t>
+                      </a:r>
+                    </a:p>
+                  </a:txBody>
+                  <a:tcPr>
+                    <a:solidFill>
+                      <a:srgbClr val="F0F4FF"/>
+                    </a:solidFill>
+                  </a:tcPr>
+                </a:tc>
+                <a:tc>
+                  <a:txBody>
+                    <a:bodyPr lIns="40000" rIns="40000" tIns="10000" bIns="10000" wrap="square"/>
+                    <a:lstStyle/>
+                    <a:p>
+                      <a:pPr algn="l"/>
+                      <a:r>
+                        <a:rPr sz="1200">
+                          <a:solidFill>
+                            <a:srgbClr val="202020"/>
+                          </a:solidFill>
+                          <a:latin typeface="Microsoft YaHei"/>
+                        </a:rPr>
+                        <a:t>模式匹配编码「常用 ≠ 正确」</a:t>
+                      </a:r>
+                    </a:p>
+                  </a:txBody>
+                  <a:tcPr>
+                    <a:solidFill>
+                      <a:srgbClr val="F0F4FF"/>
+                    </a:solidFill>
+                  </a:tcPr>
+                </a:tc>
+                <a:tc>
+                  <a:txBody>
+                    <a:bodyPr lIns="40000" rIns="40000" tIns="10000" bIns="10000" wrap="square"/>
+                    <a:lstStyle/>
+                    <a:p>
+                      <a:pPr algn="l"/>
+                      <a:r>
+                        <a:rPr sz="1200">
+                          <a:solidFill>
+                            <a:srgbClr val="202020"/>
+                          </a:solidFill>
+                          <a:latin typeface="Microsoft YaHei"/>
+                        </a:rPr>
+                        <a:t>UUID.take(8) / ArrayList — 常用但联网场景错</a:t>
+                      </a:r>
+                    </a:p>
+                  </a:txBody>
+                  <a:tcPr>
+                    <a:solidFill>
+                      <a:srgbClr val="F0F4FF"/>
+                    </a:solidFill>
+                  </a:tcPr>
+                </a:tc>
+              </a:tr>
+              <a:tr h="381000">
+                <a:tc>
+                  <a:txBody>
+                    <a:bodyPr lIns="40000" rIns="40000" tIns="10000" bIns="10000" wrap="square"/>
+                    <a:lstStyle/>
+                    <a:p>
+                      <a:pPr algn="l"/>
+                      <a:r>
+                        <a:rPr sz="1200">
+                          <a:solidFill>
+                            <a:srgbClr val="202020"/>
+                          </a:solidFill>
+                          <a:latin typeface="Microsoft YaHei"/>
+                        </a:rPr>
+                        <a:t>5</a:t>
+                      </a:r>
+                    </a:p>
+                  </a:txBody>
+                  <a:tcPr>
+                    <a:solidFill>
+                      <a:srgbClr val="FFFFFF"/>
+                    </a:solidFill>
+                  </a:tcPr>
+                </a:tc>
+                <a:tc>
+                  <a:txBody>
+                    <a:bodyPr lIns="40000" rIns="40000" tIns="10000" bIns="10000" wrap="square"/>
+                    <a:lstStyle/>
+                    <a:p>
+                      <a:pPr algn="l"/>
+                      <a:r>
+                        <a:rPr sz="1200">
+                          <a:solidFill>
+                            <a:srgbClr val="202020"/>
+                          </a:solidFill>
+                          <a:latin typeface="Microsoft YaHei"/>
+                        </a:rPr>
+                        <a:t>跨文件一致性是结构盲区</a:t>
+                      </a:r>
+                    </a:p>
+                  </a:txBody>
+                  <a:tcPr>
+                    <a:solidFill>
+                      <a:srgbClr val="FFFFFF"/>
+                    </a:solidFill>
+                  </a:tcPr>
+                </a:tc>
+                <a:tc>
+                  <a:txBody>
+                    <a:bodyPr lIns="40000" rIns="40000" tIns="10000" bIns="10000" wrap="square"/>
+                    <a:lstStyle/>
+                    <a:p>
+                      <a:pPr algn="l"/>
+                      <a:r>
+                        <a:rPr sz="1200">
+                          <a:solidFill>
+                            <a:srgbClr val="202020"/>
+                          </a:solidFill>
+                          <a:latin typeface="Microsoft YaHei"/>
+                        </a:rPr>
+                        <a:t>单机 CardRules vs 服务端 canBeat — 双份 3 处不一致</a:t>
+                      </a:r>
+                    </a:p>
+                  </a:txBody>
+                  <a:tcPr>
+                    <a:solidFill>
+                      <a:srgbClr val="FFFFFF"/>
+                    </a:solidFill>
+                  </a:tcPr>
+                </a:tc>
+              </a:tr>
+            </a:tbl>
+          </a:graphicData>
+        </a:graphic>
+      </p:graphicFrame>
+      <p:sp>
+        <p:nvSpPr>
+          <p:cNvPr id="6" name="TextBox 5"/>
+          <p:cNvSpPr txBox="1"/>
+          <p:nvPr/>
+        </p:nvSpPr>
+        <p:spPr>
+          <a:xfrm>
+            <a:off x="457200" y="3794760"/>
+            <a:ext cx="11247120" cy="365760"/>
           </a:xfrm>
           <a:prstGeom prst="rect">
             <a:avLst/>
           </a:prstGeom>
+          <a:noFill/>
+        </p:spPr>
+        <p:txBody>
+          <a:bodyPr wrap="square" lIns="0" rIns="0" tIns="0" bIns="0">
+            <a:spAutoFit/>
+          </a:bodyPr>
+          <a:lstStyle/>
+          <a:p>
+            <a:pPr algn="l"/>
+            <a:r>
+              <a:rPr sz="1400" b="1">
+                <a:solidFill>
+                  <a:srgbClr val="F57C00"/>
+                </a:solidFill>
+                <a:latin typeface="Microsoft YaHei"/>
+              </a:rPr>
+              <a:t>🔁 多轮自审仍能发现新问题的 4 个原因</a:t>
+            </a:r>
+          </a:p>
+        </p:txBody>
+      </p:sp>
+      <p:graphicFrame>
+        <p:nvGraphicFramePr>
+          <p:cNvPr id="7" name="Table 6"/>
+          <p:cNvGraphicFramePr>
+            <a:graphicFrameLocks noGrp="1"/>
+          </p:cNvGraphicFramePr>
+          <p:nvPr/>
+        </p:nvGraphicFramePr>
+        <p:xfrm>
+          <a:off x="457200" y="4206240"/>
+          <a:ext cx="11247120" cy="1828800"/>
+        </p:xfrm>
+        <a:graphic>
+          <a:graphicData uri="http://schemas.openxmlformats.org/drawingml/2006/table">
+            <a:tbl>
+              <a:tblPr firstRow="1" bandRow="1">
+                <a:tableStyleId>{5C22544A-7EE6-4342-B048-85BDC9FD1C3A}</a:tableStyleId>
+              </a:tblPr>
+              <a:tblGrid>
+                <a:gridCol w="457200"/>
+                <a:gridCol w="4114800"/>
+                <a:gridCol w="6675120"/>
+              </a:tblGrid>
+              <a:tr h="365760">
+                <a:tc>
+                  <a:txBody>
+                    <a:bodyPr lIns="40000" rIns="40000" tIns="15000" bIns="15000"/>
+                    <a:lstStyle/>
+                    <a:p>
+                      <a:pPr algn="ctr"/>
+                      <a:r>
+                        <a:rPr sz="1200" b="1">
+                          <a:solidFill>
+                            <a:srgbClr val="FFFFFF"/>
+                          </a:solidFill>
+                          <a:latin typeface="Microsoft YaHei"/>
+                        </a:rPr>
+                        <a:t>#</a:t>
+                      </a:r>
+                    </a:p>
+                  </a:txBody>
+                  <a:tcPr>
+                    <a:solidFill>
+                      <a:srgbClr val="F57C00"/>
+                    </a:solidFill>
+                  </a:tcPr>
+                </a:tc>
+                <a:tc>
+                  <a:txBody>
+                    <a:bodyPr lIns="40000" rIns="40000" tIns="15000" bIns="15000"/>
+                    <a:lstStyle/>
+                    <a:p>
+                      <a:pPr algn="ctr"/>
+                      <a:r>
+                        <a:rPr sz="1200" b="1">
+                          <a:solidFill>
+                            <a:srgbClr val="FFFFFF"/>
+                          </a:solidFill>
+                          <a:latin typeface="Microsoft YaHei"/>
+                        </a:rPr>
+                        <a:t>原因</a:t>
+                      </a:r>
+                    </a:p>
+                  </a:txBody>
+                  <a:tcPr>
+                    <a:solidFill>
+                      <a:srgbClr val="F57C00"/>
+                    </a:solidFill>
+                  </a:tcPr>
+                </a:tc>
+                <a:tc>
+                  <a:txBody>
+                    <a:bodyPr lIns="40000" rIns="40000" tIns="15000" bIns="15000"/>
+                    <a:lstStyle/>
+                    <a:p>
+                      <a:pPr algn="ctr"/>
+                      <a:r>
+                        <a:rPr sz="1200" b="1">
+                          <a:solidFill>
+                            <a:srgbClr val="FFFFFF"/>
+                          </a:solidFill>
+                          <a:latin typeface="Microsoft YaHei"/>
+                        </a:rPr>
+                        <a:t>本项目体现</a:t>
+                      </a:r>
+                    </a:p>
+                  </a:txBody>
+                  <a:tcPr>
+                    <a:solidFill>
+                      <a:srgbClr val="F57C00"/>
+                    </a:solidFill>
+                  </a:tcPr>
+                </a:tc>
+              </a:tr>
+              <a:tr h="365760">
+                <a:tc>
+                  <a:txBody>
+                    <a:bodyPr lIns="40000" rIns="40000" tIns="10000" bIns="10000" wrap="square"/>
+                    <a:lstStyle/>
+                    <a:p>
+                      <a:pPr algn="l"/>
+                      <a:r>
+                        <a:rPr sz="1200">
+                          <a:solidFill>
+                            <a:srgbClr val="202020"/>
+                          </a:solidFill>
+                          <a:latin typeface="Microsoft YaHei"/>
+                        </a:rPr>
+                        <a:t>1</a:t>
+                      </a:r>
+                    </a:p>
+                  </a:txBody>
+                  <a:tcPr>
+                    <a:solidFill>
+                      <a:srgbClr val="FFFFFF"/>
+                    </a:solidFill>
+                  </a:tcPr>
+                </a:tc>
+                <a:tc>
+                  <a:txBody>
+                    <a:bodyPr lIns="40000" rIns="40000" tIns="10000" bIns="10000" wrap="square"/>
+                    <a:lstStyle/>
+                    <a:p>
+                      <a:pPr algn="l"/>
+                      <a:r>
+                        <a:rPr sz="1200">
+                          <a:solidFill>
+                            <a:srgbClr val="202020"/>
+                          </a:solidFill>
+                          <a:latin typeface="Microsoft YaHei"/>
+                        </a:rPr>
+                        <a:t>每轮在问不同的问题</a:t>
+                      </a:r>
+                    </a:p>
+                  </a:txBody>
+                  <a:tcPr>
+                    <a:solidFill>
+                      <a:srgbClr val="FFFFFF"/>
+                    </a:solidFill>
+                  </a:tcPr>
+                </a:tc>
+                <a:tc>
+                  <a:txBody>
+                    <a:bodyPr lIns="40000" rIns="40000" tIns="10000" bIns="10000" wrap="square"/>
+                    <a:lstStyle/>
+                    <a:p>
+                      <a:pPr algn="l"/>
+                      <a:r>
+                        <a:rPr sz="1200">
+                          <a:solidFill>
+                            <a:srgbClr val="202020"/>
+                          </a:solidFill>
+                          <a:latin typeface="Microsoft YaHei"/>
+                        </a:rPr>
+                        <a:t>R1:「代码整洁吗？」 R4:「为什么 3 次修了还卡？」</a:t>
+                      </a:r>
+                    </a:p>
+                  </a:txBody>
+                  <a:tcPr>
+                    <a:solidFill>
+                      <a:srgbClr val="FFFFFF"/>
+                    </a:solidFill>
+                  </a:tcPr>
+                </a:tc>
+              </a:tr>
+              <a:tr h="365760">
+                <a:tc>
+                  <a:txBody>
+                    <a:bodyPr lIns="40000" rIns="40000" tIns="10000" bIns="10000" wrap="square"/>
+                    <a:lstStyle/>
+                    <a:p>
+                      <a:pPr algn="l"/>
+                      <a:r>
+                        <a:rPr sz="1200">
+                          <a:solidFill>
+                            <a:srgbClr val="202020"/>
+                          </a:solidFill>
+                          <a:latin typeface="Microsoft YaHei"/>
+                        </a:rPr>
+                        <a:t>2</a:t>
+                      </a:r>
+                    </a:p>
+                  </a:txBody>
+                  <a:tcPr>
+                    <a:solidFill>
+                      <a:srgbClr val="F0F4FF"/>
+                    </a:solidFill>
+                  </a:tcPr>
+                </a:tc>
+                <a:tc>
+                  <a:txBody>
+                    <a:bodyPr lIns="40000" rIns="40000" tIns="10000" bIns="10000" wrap="square"/>
+                    <a:lstStyle/>
+                    <a:p>
+                      <a:pPr algn="l"/>
+                      <a:r>
+                        <a:rPr sz="1200">
+                          <a:solidFill>
+                            <a:srgbClr val="202020"/>
+                          </a:solidFill>
+                          <a:latin typeface="Microsoft YaHei"/>
+                        </a:rPr>
+                        <a:t>自审有确认偏差，用户「还卡住」才打破</a:t>
+                      </a:r>
+                    </a:p>
+                  </a:txBody>
+                  <a:tcPr>
+                    <a:solidFill>
+                      <a:srgbClr val="F0F4FF"/>
+                    </a:solidFill>
+                  </a:tcPr>
+                </a:tc>
+                <a:tc>
+                  <a:txBody>
+                    <a:bodyPr lIns="40000" rIns="40000" tIns="10000" bIns="10000" wrap="square"/>
+                    <a:lstStyle/>
+                    <a:p>
+                      <a:pPr algn="l"/>
+                      <a:r>
+                        <a:rPr sz="1200">
+                          <a:solidFill>
+                            <a:srgbClr val="202020"/>
+                          </a:solidFill>
+                          <a:latin typeface="Microsoft YaHei"/>
+                        </a:rPr>
+                        <a:t>4 轮逐层挖到 send() 静默失败</a:t>
+                      </a:r>
+                    </a:p>
+                  </a:txBody>
+                  <a:tcPr>
+                    <a:solidFill>
+                      <a:srgbClr val="F0F4FF"/>
+                    </a:solidFill>
+                  </a:tcPr>
+                </a:tc>
+              </a:tr>
+              <a:tr h="365760">
+                <a:tc>
+                  <a:txBody>
+                    <a:bodyPr lIns="40000" rIns="40000" tIns="10000" bIns="10000" wrap="square"/>
+                    <a:lstStyle/>
+                    <a:p>
+                      <a:pPr algn="l"/>
+                      <a:r>
+                        <a:rPr sz="1200">
+                          <a:solidFill>
+                            <a:srgbClr val="202020"/>
+                          </a:solidFill>
+                          <a:latin typeface="Microsoft YaHei"/>
+                        </a:rPr>
+                        <a:t>3</a:t>
+                      </a:r>
+                    </a:p>
+                  </a:txBody>
+                  <a:tcPr>
+                    <a:solidFill>
+                      <a:srgbClr val="FFFFFF"/>
+                    </a:solidFill>
+                  </a:tcPr>
+                </a:tc>
+                <a:tc>
+                  <a:txBody>
+                    <a:bodyPr lIns="40000" rIns="40000" tIns="10000" bIns="10000" wrap="square"/>
+                    <a:lstStyle/>
+                    <a:p>
+                      <a:pPr algn="l"/>
+                      <a:r>
+                        <a:rPr sz="1200">
+                          <a:solidFill>
+                            <a:srgbClr val="202020"/>
+                          </a:solidFill>
+                          <a:latin typeface="Microsoft YaHei"/>
+                        </a:rPr>
+                        <a:t>症状被消除后下一层根因才暴露</a:t>
+                      </a:r>
+                    </a:p>
+                  </a:txBody>
+                  <a:tcPr>
+                    <a:solidFill>
+                      <a:srgbClr val="FFFFFF"/>
+                    </a:solidFill>
+                  </a:tcPr>
+                </a:tc>
+                <a:tc>
+                  <a:txBody>
+                    <a:bodyPr lIns="40000" rIns="40000" tIns="10000" bIns="10000" wrap="square"/>
+                    <a:lstStyle/>
+                    <a:p>
+                      <a:pPr algn="l"/>
+                      <a:r>
+                        <a:rPr sz="1200">
+                          <a:solidFill>
+                            <a:srgbClr val="202020"/>
+                          </a:solidFill>
+                          <a:latin typeface="Microsoft YaHei"/>
+                        </a:rPr>
+                        <a:t>canBeat → 回退链 → Mutex → 兜底 必须按序解锁</a:t>
+                      </a:r>
+                    </a:p>
+                  </a:txBody>
+                  <a:tcPr>
+                    <a:solidFill>
+                      <a:srgbClr val="FFFFFF"/>
+                    </a:solidFill>
+                  </a:tcPr>
+                </a:tc>
+              </a:tr>
+              <a:tr h="365760">
+                <a:tc>
+                  <a:txBody>
+                    <a:bodyPr lIns="40000" rIns="40000" tIns="10000" bIns="10000" wrap="square"/>
+                    <a:lstStyle/>
+                    <a:p>
+                      <a:pPr algn="l"/>
+                      <a:r>
+                        <a:rPr sz="1200">
+                          <a:solidFill>
+                            <a:srgbClr val="202020"/>
+                          </a:solidFill>
+                          <a:latin typeface="Microsoft YaHei"/>
+                        </a:rPr>
+                        <a:t>4</a:t>
+                      </a:r>
+                    </a:p>
+                  </a:txBody>
+                  <a:tcPr>
+                    <a:solidFill>
+                      <a:srgbClr val="F0F4FF"/>
+                    </a:solidFill>
+                  </a:tcPr>
+                </a:tc>
+                <a:tc>
+                  <a:txBody>
+                    <a:bodyPr lIns="40000" rIns="40000" tIns="10000" bIns="10000" wrap="square"/>
+                    <a:lstStyle/>
+                    <a:p>
+                      <a:pPr algn="l"/>
+                      <a:r>
+                        <a:rPr sz="1200">
+                          <a:solidFill>
+                            <a:srgbClr val="202020"/>
+                          </a:solidFill>
+                          <a:latin typeface="Microsoft YaHei"/>
+                        </a:rPr>
+                        <a:t>注意力有限，单轮无法全部仔细看</a:t>
+                      </a:r>
+                    </a:p>
+                  </a:txBody>
+                  <a:tcPr>
+                    <a:solidFill>
+                      <a:srgbClr val="F0F4FF"/>
+                    </a:solidFill>
+                  </a:tcPr>
+                </a:tc>
+                <a:tc>
+                  <a:txBody>
+                    <a:bodyPr lIns="40000" rIns="40000" tIns="10000" bIns="10000" wrap="square"/>
+                    <a:lstStyle/>
+                    <a:p>
+                      <a:pPr algn="l"/>
+                      <a:r>
+                        <a:rPr sz="1200">
+                          <a:solidFill>
+                            <a:srgbClr val="202020"/>
+                          </a:solidFill>
+                          <a:latin typeface="Microsoft YaHei"/>
+                        </a:rPr>
+                        <a:t>1M 上下文 ≠ 全部能仔细分析</a:t>
+                      </a:r>
+                    </a:p>
+                  </a:txBody>
+                  <a:tcPr>
+                    <a:solidFill>
+                      <a:srgbClr val="F0F4FF"/>
+                    </a:solidFill>
+                  </a:tcPr>
+                </a:tc>
+              </a:tr>
+            </a:tbl>
+          </a:graphicData>
+        </a:graphic>
+      </p:graphicFrame>
+      <p:sp>
+        <p:nvSpPr>
+          <p:cNvPr id="8" name="Rounded Rectangle 7"/>
+          <p:cNvSpPr/>
+          <p:nvPr/>
+        </p:nvSpPr>
+        <p:spPr>
+          <a:xfrm>
+            <a:off x="457200" y="6172200"/>
+            <a:ext cx="11338560" cy="502920"/>
+          </a:xfrm>
+          <a:prstGeom prst="roundRect">
+            <a:avLst/>
+          </a:prstGeom>
           <a:solidFill>
-            <a:srgbClr val="F4F4F4"/>
+            <a:srgbClr val="F0F4FF"/>
           </a:solidFill>
           <a:ln>
             <a:solidFill>
-              <a:srgbClr val="D0D0D0"/>
+              <a:srgbClr val="1A73E8"/>
             </a:solidFill>
           </a:ln>
         </p:spPr>
@@ -12090,65 +15289,32 @@
           </a:fontRef>
         </p:style>
         <p:txBody>
-          <a:bodyPr rtlCol="0" anchor="ctr" wrap="square" lIns="120000" rIns="120000" tIns="80000" bIns="80000"/>
+          <a:bodyPr rtlCol="0" anchor="ctr" wrap="square" lIns="150000" rIns="150000"/>
           <a:lstStyle/>
           <a:p>
             <a:pPr algn="ctr"/>
             <a:r>
-              <a:rPr sz="1200">
-                <a:solidFill>
-                  <a:srgbClr val="202020"/>
-                </a:solidFill>
-                <a:latin typeface="Consolas"/>
-              </a:rPr>
-              <a:t>[层1] canBeat 炸弹比较错误：大张数应直接胜（修复前要求同张数）</a:t>
-            </a:r>
-          </a:p>
-          <a:p>
-            <a:r>
-              <a:rPr sz="1200">
-                <a:solidFill>
-                  <a:srgbClr val="202020"/>
-                </a:solidFill>
-                <a:latin typeface="Consolas"/>
-              </a:rPr>
-              <a:t>[层2] AI 失败无回退：增加三级回退（首选 → 过牌 → 最小单张）</a:t>
-            </a:r>
-          </a:p>
-          <a:p>
-            <a:r>
-              <a:rPr sz="1200">
-                <a:solidFill>
-                  <a:srgbClr val="202020"/>
-                </a:solidFill>
-                <a:latin typeface="Consolas"/>
-              </a:rPr>
-              <a:t>[层3] 多协程无锁并发写 state.hands：每房间一把 Mutex（改在锁内/广播在锁外）</a:t>
-            </a:r>
-          </a:p>
-          <a:p>
-            <a:r>
-              <a:rPr sz="1200">
-                <a:solidFill>
-                  <a:srgbClr val="202020"/>
-                </a:solidFill>
-                <a:latin typeface="Consolas"/>
-              </a:rPr>
-              <a:t>[层4] 三级回退仍失败：broadcastForceAdvance 强制推进兜底</a:t>
-            </a:r>
-          </a:p>
-        </p:txBody>
-      </p:sp>
-      <p:sp>
-        <p:nvSpPr>
-          <p:cNvPr id="6" name="TextBox 5"/>
+              <a:rPr sz="1200" b="1">
+                <a:solidFill>
+                  <a:srgbClr val="1A73E8"/>
+                </a:solidFill>
+                <a:latin typeface="Microsoft YaHei"/>
+              </a:rPr>
+              <a:t>💡 启示：AI 写代码不是「一次到位」，而是「快速迭代到位」 — 接受多轮，但用工具/流程压低轮次</a:t>
+            </a:r>
+          </a:p>
+        </p:txBody>
+      </p:sp>
+      <p:sp>
+        <p:nvSpPr>
+          <p:cNvPr id="9" name="TextBox 8"/>
           <p:cNvSpPr txBox="1"/>
           <p:nvPr/>
         </p:nvSpPr>
         <p:spPr>
           <a:xfrm>
-            <a:off x="457200" y="3017520"/>
-            <a:ext cx="11247120" cy="365760"/>
+            <a:off x="10789920" y="6446520"/>
+            <a:ext cx="1188720" cy="274320"/>
           </a:xfrm>
           <a:prstGeom prst="rect">
             <a:avLst/>
@@ -12161,248 +15327,15 @@
           </a:bodyPr>
           <a:lstStyle/>
           <a:p>
-            <a:pPr algn="l"/>
-            <a:r>
-              <a:rPr sz="1400" b="1">
-                <a:solidFill>
-                  <a:srgbClr val="1A73E8"/>
+            <a:pPr algn="r"/>
+            <a:r>
+              <a:rPr sz="1000" b="0">
+                <a:solidFill>
+                  <a:srgbClr val="606060"/>
                 </a:solidFill>
                 <a:latin typeface="Microsoft YaHei"/>
               </a:rPr>
-              <a:t>2️⃣ 重连失效 — 异步时序陷阱</a:t>
-            </a:r>
-          </a:p>
-        </p:txBody>
-      </p:sp>
-      <p:sp>
-        <p:nvSpPr>
-          <p:cNvPr id="7" name="Rectangle 6"/>
-          <p:cNvSpPr/>
-          <p:nvPr/>
-        </p:nvSpPr>
-        <p:spPr>
-          <a:xfrm>
-            <a:off x="457200" y="3429000"/>
-            <a:ext cx="11247120" cy="1280160"/>
-          </a:xfrm>
-          <a:prstGeom prst="rect">
-            <a:avLst/>
-          </a:prstGeom>
-          <a:solidFill>
-            <a:srgbClr val="F4F4F4"/>
-          </a:solidFill>
-          <a:ln>
-            <a:solidFill>
-              <a:srgbClr val="D0D0D0"/>
-            </a:solidFill>
-          </a:ln>
-        </p:spPr>
-        <p:style>
-          <a:lnRef idx="1">
-            <a:schemeClr val="accent1"/>
-          </a:lnRef>
-          <a:fillRef idx="3">
-            <a:schemeClr val="accent1"/>
-          </a:fillRef>
-          <a:effectRef idx="2">
-            <a:schemeClr val="accent1"/>
-          </a:effectRef>
-          <a:fontRef idx="minor">
-            <a:schemeClr val="lt1"/>
-          </a:fontRef>
-        </p:style>
-        <p:txBody>
-          <a:bodyPr rtlCol="0" anchor="ctr" wrap="square" lIns="120000" rIns="120000" tIns="80000" bIns="80000"/>
-          <a:lstStyle/>
-          <a:p>
-            <a:pPr algn="ctr"/>
-            <a:r>
-              <a:rPr sz="1200">
-                <a:solidFill>
-                  <a:srgbClr val="202020"/>
-                </a:solidFill>
-                <a:latin typeface="Consolas"/>
-              </a:rPr>
-              <a:t>❌ 修复前：newWebSocket() 后立即 send(Reconnect)，ws 仍在 CONNECTING → 静默丢弃</a:t>
-            </a:r>
-          </a:p>
-          <a:p>
-            <a:r>
-              <a:rPr sz="1200">
-                <a:solidFill>
-                  <a:srgbClr val="202020"/>
-                </a:solidFill>
-                <a:latin typeface="Consolas"/>
-              </a:rPr>
-              <a:t>✅ 修复后：在 onOpen 回调内 send，确保 ws 已 OPEN</a:t>
-            </a:r>
-          </a:p>
-          <a:p>
-            <a:r>
-              <a:rPr sz="1200">
-                <a:solidFill>
-                  <a:srgbClr val="202020"/>
-                </a:solidFill>
-                <a:latin typeface="Consolas"/>
-              </a:rPr>
-              <a:t>教训：「创建连接」≠「连接已建立」，异步 API 必须在回调中操作</a:t>
-            </a:r>
-          </a:p>
-        </p:txBody>
-      </p:sp>
-      <p:sp>
-        <p:nvSpPr>
-          <p:cNvPr id="8" name="TextBox 7"/>
-          <p:cNvSpPr txBox="1"/>
-          <p:nvPr/>
-        </p:nvSpPr>
-        <p:spPr>
-          <a:xfrm>
-            <a:off x="457200" y="4800600"/>
-            <a:ext cx="11247120" cy="365760"/>
-          </a:xfrm>
-          <a:prstGeom prst="rect">
-            <a:avLst/>
-          </a:prstGeom>
-          <a:noFill/>
-        </p:spPr>
-        <p:txBody>
-          <a:bodyPr wrap="square" lIns="0" rIns="0" tIns="0" bIns="0">
-            <a:spAutoFit/>
-          </a:bodyPr>
-          <a:lstStyle/>
-          <a:p>
-            <a:pPr algn="l"/>
-            <a:r>
-              <a:rPr sz="1400" b="1">
-                <a:solidFill>
-                  <a:srgbClr val="1A73E8"/>
-                </a:solidFill>
-                <a:latin typeface="Microsoft YaHei"/>
-              </a:rPr>
-              <a:t>3️⃣ 两端结算不一致 — 统一公式</a:t>
-            </a:r>
-          </a:p>
-        </p:txBody>
-      </p:sp>
-      <p:sp>
-        <p:nvSpPr>
-          <p:cNvPr id="9" name="Rectangle 8"/>
-          <p:cNvSpPr/>
-          <p:nvPr/>
-        </p:nvSpPr>
-        <p:spPr>
-          <a:xfrm>
-            <a:off x="457200" y="5212080"/>
-            <a:ext cx="11247120" cy="1371600"/>
-          </a:xfrm>
-          <a:prstGeom prst="rect">
-            <a:avLst/>
-          </a:prstGeom>
-          <a:solidFill>
-            <a:srgbClr val="F4F4F4"/>
-          </a:solidFill>
-          <a:ln>
-            <a:solidFill>
-              <a:srgbClr val="D0D0D0"/>
-            </a:solidFill>
-          </a:ln>
-        </p:spPr>
-        <p:style>
-          <a:lnRef idx="1">
-            <a:schemeClr val="accent1"/>
-          </a:lnRef>
-          <a:fillRef idx="3">
-            <a:schemeClr val="accent1"/>
-          </a:fillRef>
-          <a:effectRef idx="2">
-            <a:schemeClr val="accent1"/>
-          </a:effectRef>
-          <a:fontRef idx="minor">
-            <a:schemeClr val="lt1"/>
-          </a:fontRef>
-        </p:style>
-        <p:txBody>
-          <a:bodyPr rtlCol="0" anchor="ctr" wrap="square" lIns="120000" rIns="120000" tIns="80000" bIns="80000"/>
-          <a:lstStyle/>
-          <a:p>
-            <a:pPr algn="ctr"/>
-            <a:r>
-              <a:rPr sz="1200">
-                <a:solidFill>
-                  <a:srgbClr val="202020"/>
-                </a:solidFill>
-                <a:latin typeface="Consolas"/>
-              </a:rPr>
-              <a:t>根因：collectedScore 硬编码为 0；服务端漏算「输方未走完已收分」</a:t>
-            </a:r>
-          </a:p>
-          <a:p>
-            <a:r>
-              <a:rPr sz="1200">
-                <a:solidFill>
-                  <a:srgbClr val="202020"/>
-                </a:solidFill>
-                <a:latin typeface="Consolas"/>
-              </a:rPr>
-              <a:t>统一公式：赢方 = 赢方所有已收 + 输方未走完(已收 + 手牌分)；输方 = 输方已走完已收</a:t>
-            </a:r>
-          </a:p>
-          <a:p>
-            <a:r>
-              <a:rPr sz="1200">
-                <a:solidFill>
-                  <a:srgbClr val="202020"/>
-                </a:solidFill>
-                <a:latin typeface="Consolas"/>
-              </a:rPr>
-              <a:t>新增 state.playerScores: MutableMap&lt;Int,Int&gt; 实时追踪每人已收分</a:t>
-            </a:r>
-          </a:p>
-          <a:p>
-            <a:r>
-              <a:rPr sz="1200">
-                <a:solidFill>
-                  <a:srgbClr val="202020"/>
-                </a:solidFill>
-                <a:latin typeface="Consolas"/>
-              </a:rPr>
-              <a:t>✓ 15 个验证用例全部通过（含提前结算、速度流、极端场景）</a:t>
-            </a:r>
-          </a:p>
-        </p:txBody>
-      </p:sp>
-      <p:sp>
-        <p:nvSpPr>
-          <p:cNvPr id="10" name="TextBox 9"/>
-          <p:cNvSpPr txBox="1"/>
-          <p:nvPr/>
-        </p:nvSpPr>
-        <p:spPr>
-          <a:xfrm>
-            <a:off x="10789920" y="6446520"/>
-            <a:ext cx="1188720" cy="274320"/>
-          </a:xfrm>
-          <a:prstGeom prst="rect">
-            <a:avLst/>
-          </a:prstGeom>
-          <a:noFill/>
-        </p:spPr>
-        <p:txBody>
-          <a:bodyPr wrap="square" lIns="0" rIns="0" tIns="0" bIns="0">
-            <a:spAutoFit/>
-          </a:bodyPr>
-          <a:lstStyle/>
-          <a:p>
-            <a:pPr algn="r"/>
-            <a:r>
-              <a:rPr sz="1000" b="0">
-                <a:solidFill>
-                  <a:srgbClr val="606060"/>
-                </a:solidFill>
-                <a:latin typeface="Microsoft YaHei"/>
-              </a:rPr>
-              <a:t>9 / 10</a:t>
+              <a:t>9 / 13</a:t>
             </a:r>
           </a:p>
         </p:txBody>

</xml_diff>

<commit_message>
chore(docs): retheme dev_summary.pptx with Huawei red palette
User requested: change PPT 字体配色风格为华为红，不再用蓝色。

build_pptx.py:
- PRIMARY: RGBColor(0x1A, 0x73, 0xE8) → RGBColor(0xC7, 0x00, 0x0B)
  (Google blue → Huawei brand red #C7000B)
- LIGHT_BG: RGBColor(0xF0, 0xF4, 0xFF) → RGBColor(0xFF, 0xF1, 0xF2)
  (light blue tint → low-saturation red-pink, same hue family as PRIMARY)
- RED / GREEN / ORANGE 保留（用于强调 / 状态色，不动）

dev_summary.pptx 重新生成（16 页）。Verified: 标题"完整实践总结" 与各章
heading 现在为 #C7000B 红色，与 LIGHT_BG #FFF1F2 浅粉衬底成同色系协调。

Signed-off-by: berming <bermin@live.cn>
AI-Assisted-By: Claude Opus 4.7 (claude-opus-4-7, 1M context)

https://claude.ai/code/session_018xKWJ1yTSJYmiJvRpvBYJp
</commit_message>
<xml_diff>
--- a/docs/dev_summary.pptx
+++ b/docs/dev_summary.pptx
@@ -3118,7 +3118,7 @@
             <a:avLst/>
           </a:prstGeom>
           <a:solidFill>
-            <a:srgbClr val="1A73E8"/>
+            <a:srgbClr val="C7000B"/>
           </a:solidFill>
           <a:ln>
             <a:noFill/>
@@ -3207,7 +3207,7 @@
             <a:r>
               <a:rPr sz="4400" b="1">
                 <a:solidFill>
-                  <a:srgbClr val="1A73E8"/>
+                  <a:srgbClr val="C7000B"/>
                 </a:solidFill>
                 <a:latin typeface="Microsoft YaHei"/>
               </a:rPr>
@@ -3277,7 +3277,7 @@
             <a:r>
               <a:rPr sz="1400" b="1">
                 <a:solidFill>
-                  <a:srgbClr val="1A73E8"/>
+                  <a:srgbClr val="C7000B"/>
                 </a:solidFill>
                 <a:latin typeface="Microsoft YaHei"/>
               </a:rPr>
@@ -3470,7 +3470,7 @@
             <a:r>
               <a:rPr sz="2400" b="1">
                 <a:solidFill>
-                  <a:srgbClr val="1A73E8"/>
+                  <a:srgbClr val="C7000B"/>
                 </a:solidFill>
                 <a:latin typeface="Microsoft YaHei"/>
               </a:rPr>
@@ -3494,7 +3494,7 @@
             <a:avLst/>
           </a:prstGeom>
           <a:solidFill>
-            <a:srgbClr val="1A73E8"/>
+            <a:srgbClr val="C7000B"/>
           </a:solidFill>
           <a:ln>
             <a:noFill/>
@@ -3548,7 +3548,7 @@
             <a:r>
               <a:rPr sz="1400" b="1">
                 <a:solidFill>
-                  <a:srgbClr val="1A73E8"/>
+                  <a:srgbClr val="C7000B"/>
                 </a:solidFill>
                 <a:latin typeface="Microsoft YaHei"/>
               </a:rPr>
@@ -3600,7 +3600,7 @@
                   </a:txBody>
                   <a:tcPr>
                     <a:solidFill>
-                      <a:srgbClr val="1A73E8"/>
+                      <a:srgbClr val="C7000B"/>
                     </a:solidFill>
                   </a:tcPr>
                 </a:tc>
@@ -3623,7 +3623,7 @@
                   </a:txBody>
                   <a:tcPr>
                     <a:solidFill>
-                      <a:srgbClr val="1A73E8"/>
+                      <a:srgbClr val="C7000B"/>
                     </a:solidFill>
                   </a:tcPr>
                 </a:tc>
@@ -3646,7 +3646,7 @@
                   </a:txBody>
                   <a:tcPr>
                     <a:solidFill>
-                      <a:srgbClr val="1A73E8"/>
+                      <a:srgbClr val="C7000B"/>
                     </a:solidFill>
                   </a:tcPr>
                 </a:tc>
@@ -3742,7 +3742,7 @@
                   </a:txBody>
                   <a:tcPr>
                     <a:solidFill>
-                      <a:srgbClr val="F0F4FF"/>
+                      <a:srgbClr val="FFF1F2"/>
                     </a:solidFill>
                   </a:tcPr>
                 </a:tc>
@@ -3765,7 +3765,7 @@
                   </a:txBody>
                   <a:tcPr>
                     <a:solidFill>
-                      <a:srgbClr val="F0F4FF"/>
+                      <a:srgbClr val="FFF1F2"/>
                     </a:solidFill>
                   </a:tcPr>
                 </a:tc>
@@ -3788,7 +3788,7 @@
                   </a:txBody>
                   <a:tcPr>
                     <a:solidFill>
-                      <a:srgbClr val="F0F4FF"/>
+                      <a:srgbClr val="FFF1F2"/>
                     </a:solidFill>
                   </a:tcPr>
                 </a:tc>
@@ -3894,7 +3894,7 @@
             <a:r>
               <a:rPr sz="1400" b="1">
                 <a:solidFill>
-                  <a:srgbClr val="1A73E8"/>
+                  <a:srgbClr val="C7000B"/>
                 </a:solidFill>
                 <a:latin typeface="Microsoft YaHei"/>
               </a:rPr>
@@ -3946,7 +3946,7 @@
                   </a:txBody>
                   <a:tcPr>
                     <a:solidFill>
-                      <a:srgbClr val="1A73E8"/>
+                      <a:srgbClr val="C7000B"/>
                     </a:solidFill>
                   </a:tcPr>
                 </a:tc>
@@ -3969,7 +3969,7 @@
                   </a:txBody>
                   <a:tcPr>
                     <a:solidFill>
-                      <a:srgbClr val="1A73E8"/>
+                      <a:srgbClr val="C7000B"/>
                     </a:solidFill>
                   </a:tcPr>
                 </a:tc>
@@ -3992,7 +3992,7 @@
                   </a:txBody>
                   <a:tcPr>
                     <a:solidFill>
-                      <a:srgbClr val="1A73E8"/>
+                      <a:srgbClr val="C7000B"/>
                     </a:solidFill>
                   </a:tcPr>
                 </a:tc>
@@ -4088,7 +4088,7 @@
                   </a:txBody>
                   <a:tcPr>
                     <a:solidFill>
-                      <a:srgbClr val="F0F4FF"/>
+                      <a:srgbClr val="FFF1F2"/>
                     </a:solidFill>
                   </a:tcPr>
                 </a:tc>
@@ -4111,7 +4111,7 @@
                   </a:txBody>
                   <a:tcPr>
                     <a:solidFill>
-                      <a:srgbClr val="F0F4FF"/>
+                      <a:srgbClr val="FFF1F2"/>
                     </a:solidFill>
                   </a:tcPr>
                 </a:tc>
@@ -4134,7 +4134,7 @@
                   </a:txBody>
                   <a:tcPr>
                     <a:solidFill>
-                      <a:srgbClr val="F0F4FF"/>
+                      <a:srgbClr val="FFF1F2"/>
                     </a:solidFill>
                   </a:tcPr>
                 </a:tc>
@@ -4230,7 +4230,7 @@
                   </a:txBody>
                   <a:tcPr>
                     <a:solidFill>
-                      <a:srgbClr val="F0F4FF"/>
+                      <a:srgbClr val="FFF1F2"/>
                     </a:solidFill>
                   </a:tcPr>
                 </a:tc>
@@ -4253,7 +4253,7 @@
                   </a:txBody>
                   <a:tcPr>
                     <a:solidFill>
-                      <a:srgbClr val="F0F4FF"/>
+                      <a:srgbClr val="FFF1F2"/>
                     </a:solidFill>
                   </a:tcPr>
                 </a:tc>
@@ -4276,7 +4276,7 @@
                   </a:txBody>
                   <a:tcPr>
                     <a:solidFill>
-                      <a:srgbClr val="F0F4FF"/>
+                      <a:srgbClr val="FFF1F2"/>
                     </a:solidFill>
                   </a:tcPr>
                 </a:tc>
@@ -4435,7 +4435,7 @@
             <a:r>
               <a:rPr sz="2400" b="1">
                 <a:solidFill>
-                  <a:srgbClr val="1A73E8"/>
+                  <a:srgbClr val="C7000B"/>
                 </a:solidFill>
                 <a:latin typeface="Microsoft YaHei"/>
               </a:rPr>
@@ -4459,7 +4459,7 @@
             <a:avLst/>
           </a:prstGeom>
           <a:solidFill>
-            <a:srgbClr val="1A73E8"/>
+            <a:srgbClr val="C7000B"/>
           </a:solidFill>
           <a:ln>
             <a:noFill/>
@@ -4618,7 +4618,7 @@
             <a:r>
               <a:rPr sz="1400" b="1">
                 <a:solidFill>
-                  <a:srgbClr val="1A73E8"/>
+                  <a:srgbClr val="C7000B"/>
                 </a:solidFill>
                 <a:latin typeface="Microsoft YaHei"/>
               </a:rPr>
@@ -4670,7 +4670,7 @@
                   </a:txBody>
                   <a:tcPr>
                     <a:solidFill>
-                      <a:srgbClr val="1A73E8"/>
+                      <a:srgbClr val="C7000B"/>
                     </a:solidFill>
                   </a:tcPr>
                 </a:tc>
@@ -4693,7 +4693,7 @@
                   </a:txBody>
                   <a:tcPr>
                     <a:solidFill>
-                      <a:srgbClr val="1A73E8"/>
+                      <a:srgbClr val="C7000B"/>
                     </a:solidFill>
                   </a:tcPr>
                 </a:tc>
@@ -4716,7 +4716,7 @@
                   </a:txBody>
                   <a:tcPr>
                     <a:solidFill>
-                      <a:srgbClr val="1A73E8"/>
+                      <a:srgbClr val="C7000B"/>
                     </a:solidFill>
                   </a:tcPr>
                 </a:tc>
@@ -4812,7 +4812,7 @@
                   </a:txBody>
                   <a:tcPr>
                     <a:solidFill>
-                      <a:srgbClr val="F0F4FF"/>
+                      <a:srgbClr val="FFF1F2"/>
                     </a:solidFill>
                   </a:tcPr>
                 </a:tc>
@@ -4835,7 +4835,7 @@
                   </a:txBody>
                   <a:tcPr>
                     <a:solidFill>
-                      <a:srgbClr val="F0F4FF"/>
+                      <a:srgbClr val="FFF1F2"/>
                     </a:solidFill>
                   </a:tcPr>
                 </a:tc>
@@ -4858,7 +4858,7 @@
                   </a:txBody>
                   <a:tcPr>
                     <a:solidFill>
-                      <a:srgbClr val="F0F4FF"/>
+                      <a:srgbClr val="FFF1F2"/>
                     </a:solidFill>
                   </a:tcPr>
                 </a:tc>
@@ -4954,7 +4954,7 @@
                   </a:txBody>
                   <a:tcPr>
                     <a:solidFill>
-                      <a:srgbClr val="F0F4FF"/>
+                      <a:srgbClr val="FFF1F2"/>
                     </a:solidFill>
                   </a:tcPr>
                 </a:tc>
@@ -4977,7 +4977,7 @@
                   </a:txBody>
                   <a:tcPr>
                     <a:solidFill>
-                      <a:srgbClr val="F0F4FF"/>
+                      <a:srgbClr val="FFF1F2"/>
                     </a:solidFill>
                   </a:tcPr>
                 </a:tc>
@@ -5000,7 +5000,7 @@
                   </a:txBody>
                   <a:tcPr>
                     <a:solidFill>
-                      <a:srgbClr val="F0F4FF"/>
+                      <a:srgbClr val="FFF1F2"/>
                     </a:solidFill>
                   </a:tcPr>
                 </a:tc>
@@ -5157,11 +5157,11 @@
             <a:avLst/>
           </a:prstGeom>
           <a:solidFill>
-            <a:srgbClr val="F0F4FF"/>
+            <a:srgbClr val="FFF1F2"/>
           </a:solidFill>
           <a:ln>
             <a:solidFill>
-              <a:srgbClr val="1A73E8"/>
+              <a:srgbClr val="C7000B"/>
             </a:solidFill>
           </a:ln>
         </p:spPr>
@@ -5187,7 +5187,7 @@
             <a:r>
               <a:rPr sz="1000" b="1">
                 <a:solidFill>
-                  <a:srgbClr val="1A73E8"/>
+                  <a:srgbClr val="C7000B"/>
                 </a:solidFill>
                 <a:latin typeface="Microsoft YaHei"/>
               </a:rPr>
@@ -5275,7 +5275,7 @@
             <a:r>
               <a:rPr sz="2400" b="1">
                 <a:solidFill>
-                  <a:srgbClr val="1A73E8"/>
+                  <a:srgbClr val="C7000B"/>
                 </a:solidFill>
                 <a:latin typeface="Microsoft YaHei"/>
               </a:rPr>
@@ -5299,7 +5299,7 @@
             <a:avLst/>
           </a:prstGeom>
           <a:solidFill>
-            <a:srgbClr val="1A73E8"/>
+            <a:srgbClr val="C7000B"/>
           </a:solidFill>
           <a:ln>
             <a:noFill/>
@@ -5353,7 +5353,7 @@
             <a:r>
               <a:rPr sz="1600" b="1">
                 <a:solidFill>
-                  <a:srgbClr val="1A73E8"/>
+                  <a:srgbClr val="C7000B"/>
                 </a:solidFill>
                 <a:latin typeface="Microsoft YaHei"/>
               </a:rPr>
@@ -6067,11 +6067,11 @@
             <a:avLst/>
           </a:prstGeom>
           <a:solidFill>
-            <a:srgbClr val="F0F4FF"/>
+            <a:srgbClr val="FFF1F2"/>
           </a:solidFill>
           <a:ln>
             <a:solidFill>
-              <a:srgbClr val="1A73E8"/>
+              <a:srgbClr val="C7000B"/>
             </a:solidFill>
           </a:ln>
         </p:spPr>
@@ -6123,7 +6123,7 @@
             <a:r>
               <a:rPr sz="1400" b="1">
                 <a:solidFill>
-                  <a:srgbClr val="1A73E8"/>
+                  <a:srgbClr val="C7000B"/>
                 </a:solidFill>
                 <a:latin typeface="Microsoft YaHei"/>
               </a:rPr>
@@ -6246,7 +6246,7 @@
             <a:r>
               <a:rPr sz="2400" b="1">
                 <a:solidFill>
-                  <a:srgbClr val="1A73E8"/>
+                  <a:srgbClr val="C7000B"/>
                 </a:solidFill>
                 <a:latin typeface="Microsoft YaHei"/>
               </a:rPr>
@@ -6270,7 +6270,7 @@
             <a:avLst/>
           </a:prstGeom>
           <a:solidFill>
-            <a:srgbClr val="1A73E8"/>
+            <a:srgbClr val="C7000B"/>
           </a:solidFill>
           <a:ln>
             <a:noFill/>
@@ -6324,7 +6324,7 @@
             <a:r>
               <a:rPr sz="1600" b="1">
                 <a:solidFill>
-                  <a:srgbClr val="1A73E8"/>
+                  <a:srgbClr val="C7000B"/>
                 </a:solidFill>
                 <a:latin typeface="Microsoft YaHei"/>
               </a:rPr>
@@ -6569,7 +6569,7 @@
             <a:r>
               <a:rPr sz="1600" b="1">
                 <a:solidFill>
-                  <a:srgbClr val="1A73E8"/>
+                  <a:srgbClr val="C7000B"/>
                 </a:solidFill>
                 <a:latin typeface="Microsoft YaHei"/>
               </a:rPr>
@@ -6620,7 +6620,7 @@
                   </a:txBody>
                   <a:tcPr>
                     <a:solidFill>
-                      <a:srgbClr val="1A73E8"/>
+                      <a:srgbClr val="C7000B"/>
                     </a:solidFill>
                   </a:tcPr>
                 </a:tc>
@@ -6643,7 +6643,7 @@
                   </a:txBody>
                   <a:tcPr>
                     <a:solidFill>
-                      <a:srgbClr val="1A73E8"/>
+                      <a:srgbClr val="C7000B"/>
                     </a:solidFill>
                   </a:tcPr>
                 </a:tc>
@@ -6716,7 +6716,7 @@
                   </a:txBody>
                   <a:tcPr>
                     <a:solidFill>
-                      <a:srgbClr val="F0F4FF"/>
+                      <a:srgbClr val="FFF1F2"/>
                     </a:solidFill>
                   </a:tcPr>
                 </a:tc>
@@ -6739,7 +6739,7 @@
                   </a:txBody>
                   <a:tcPr>
                     <a:solidFill>
-                      <a:srgbClr val="F0F4FF"/>
+                      <a:srgbClr val="FFF1F2"/>
                     </a:solidFill>
                   </a:tcPr>
                 </a:tc>
@@ -6812,7 +6812,7 @@
                   </a:txBody>
                   <a:tcPr>
                     <a:solidFill>
-                      <a:srgbClr val="F0F4FF"/>
+                      <a:srgbClr val="FFF1F2"/>
                     </a:solidFill>
                   </a:tcPr>
                 </a:tc>
@@ -6835,7 +6835,7 @@
                   </a:txBody>
                   <a:tcPr>
                     <a:solidFill>
-                      <a:srgbClr val="F0F4FF"/>
+                      <a:srgbClr val="FFF1F2"/>
                     </a:solidFill>
                   </a:tcPr>
                 </a:tc>
@@ -6908,7 +6908,7 @@
                   </a:txBody>
                   <a:tcPr>
                     <a:solidFill>
-                      <a:srgbClr val="F0F4FF"/>
+                      <a:srgbClr val="FFF1F2"/>
                     </a:solidFill>
                   </a:tcPr>
                 </a:tc>
@@ -6931,7 +6931,7 @@
                   </a:txBody>
                   <a:tcPr>
                     <a:solidFill>
-                      <a:srgbClr val="F0F4FF"/>
+                      <a:srgbClr val="FFF1F2"/>
                     </a:solidFill>
                   </a:tcPr>
                 </a:tc>
@@ -6955,11 +6955,11 @@
             <a:avLst/>
           </a:prstGeom>
           <a:solidFill>
-            <a:srgbClr val="F0F4FF"/>
+            <a:srgbClr val="FFF1F2"/>
           </a:solidFill>
           <a:ln>
             <a:solidFill>
-              <a:srgbClr val="1A73E8"/>
+              <a:srgbClr val="C7000B"/>
             </a:solidFill>
           </a:ln>
         </p:spPr>
@@ -7011,7 +7011,7 @@
             <a:r>
               <a:rPr sz="1600" b="1">
                 <a:solidFill>
-                  <a:srgbClr val="1A73E8"/>
+                  <a:srgbClr val="C7000B"/>
                 </a:solidFill>
                 <a:latin typeface="Microsoft YaHei"/>
               </a:rPr>
@@ -7151,7 +7151,7 @@
             <a:r>
               <a:rPr sz="1400" b="1">
                 <a:solidFill>
-                  <a:srgbClr val="1A73E8"/>
+                  <a:srgbClr val="C7000B"/>
                 </a:solidFill>
                 <a:latin typeface="Microsoft YaHei"/>
               </a:rPr>
@@ -7274,7 +7274,7 @@
             <a:r>
               <a:rPr sz="2400" b="1">
                 <a:solidFill>
-                  <a:srgbClr val="1A73E8"/>
+                  <a:srgbClr val="C7000B"/>
                 </a:solidFill>
                 <a:latin typeface="Microsoft YaHei"/>
               </a:rPr>
@@ -7298,7 +7298,7 @@
             <a:avLst/>
           </a:prstGeom>
           <a:solidFill>
-            <a:srgbClr val="1A73E8"/>
+            <a:srgbClr val="C7000B"/>
           </a:solidFill>
           <a:ln>
             <a:noFill/>
@@ -7352,7 +7352,7 @@
             <a:r>
               <a:rPr sz="1600" b="1">
                 <a:solidFill>
-                  <a:srgbClr val="1A73E8"/>
+                  <a:srgbClr val="C7000B"/>
                 </a:solidFill>
                 <a:latin typeface="Microsoft YaHei"/>
               </a:rPr>
@@ -7404,7 +7404,7 @@
                   </a:txBody>
                   <a:tcPr>
                     <a:solidFill>
-                      <a:srgbClr val="1A73E8"/>
+                      <a:srgbClr val="C7000B"/>
                     </a:solidFill>
                   </a:tcPr>
                 </a:tc>
@@ -7427,7 +7427,7 @@
                   </a:txBody>
                   <a:tcPr>
                     <a:solidFill>
-                      <a:srgbClr val="1A73E8"/>
+                      <a:srgbClr val="C7000B"/>
                     </a:solidFill>
                   </a:tcPr>
                 </a:tc>
@@ -7450,7 +7450,7 @@
                   </a:txBody>
                   <a:tcPr>
                     <a:solidFill>
-                      <a:srgbClr val="1A73E8"/>
+                      <a:srgbClr val="C7000B"/>
                     </a:solidFill>
                   </a:tcPr>
                 </a:tc>
@@ -7546,7 +7546,7 @@
                   </a:txBody>
                   <a:tcPr>
                     <a:solidFill>
-                      <a:srgbClr val="F0F4FF"/>
+                      <a:srgbClr val="FFF1F2"/>
                     </a:solidFill>
                   </a:tcPr>
                 </a:tc>
@@ -7569,7 +7569,7 @@
                   </a:txBody>
                   <a:tcPr>
                     <a:solidFill>
-                      <a:srgbClr val="F0F4FF"/>
+                      <a:srgbClr val="FFF1F2"/>
                     </a:solidFill>
                   </a:tcPr>
                 </a:tc>
@@ -7592,7 +7592,7 @@
                   </a:txBody>
                   <a:tcPr>
                     <a:solidFill>
-                      <a:srgbClr val="F0F4FF"/>
+                      <a:srgbClr val="FFF1F2"/>
                     </a:solidFill>
                   </a:tcPr>
                 </a:tc>
@@ -7875,11 +7875,11 @@
             <a:avLst/>
           </a:prstGeom>
           <a:solidFill>
-            <a:srgbClr val="F0F4FF"/>
+            <a:srgbClr val="FFF1F2"/>
           </a:solidFill>
           <a:ln>
             <a:solidFill>
-              <a:srgbClr val="1A73E8"/>
+              <a:srgbClr val="C7000B"/>
             </a:solidFill>
           </a:ln>
         </p:spPr>
@@ -7931,7 +7931,7 @@
             <a:r>
               <a:rPr sz="1400" b="1">
                 <a:solidFill>
-                  <a:srgbClr val="1A73E8"/>
+                  <a:srgbClr val="C7000B"/>
                 </a:solidFill>
                 <a:latin typeface="Microsoft YaHei"/>
               </a:rPr>
@@ -8056,7 +8056,7 @@
             <a:r>
               <a:rPr sz="2400" b="1">
                 <a:solidFill>
-                  <a:srgbClr val="1A73E8"/>
+                  <a:srgbClr val="C7000B"/>
                 </a:solidFill>
                 <a:latin typeface="Microsoft YaHei"/>
               </a:rPr>
@@ -8080,7 +8080,7 @@
             <a:avLst/>
           </a:prstGeom>
           <a:solidFill>
-            <a:srgbClr val="1A73E8"/>
+            <a:srgbClr val="C7000B"/>
           </a:solidFill>
           <a:ln>
             <a:noFill/>
@@ -8134,7 +8134,7 @@
             <a:r>
               <a:rPr sz="1600" b="1">
                 <a:solidFill>
-                  <a:srgbClr val="1A73E8"/>
+                  <a:srgbClr val="C7000B"/>
                 </a:solidFill>
                 <a:latin typeface="Microsoft YaHei"/>
               </a:rPr>
@@ -8186,7 +8186,7 @@
                   </a:txBody>
                   <a:tcPr>
                     <a:solidFill>
-                      <a:srgbClr val="1A73E8"/>
+                      <a:srgbClr val="C7000B"/>
                     </a:solidFill>
                   </a:tcPr>
                 </a:tc>
@@ -8209,7 +8209,7 @@
                   </a:txBody>
                   <a:tcPr>
                     <a:solidFill>
-                      <a:srgbClr val="1A73E8"/>
+                      <a:srgbClr val="C7000B"/>
                     </a:solidFill>
                   </a:tcPr>
                 </a:tc>
@@ -8232,7 +8232,7 @@
                   </a:txBody>
                   <a:tcPr>
                     <a:solidFill>
-                      <a:srgbClr val="1A73E8"/>
+                      <a:srgbClr val="C7000B"/>
                     </a:solidFill>
                   </a:tcPr>
                 </a:tc>
@@ -8328,7 +8328,7 @@
                   </a:txBody>
                   <a:tcPr>
                     <a:solidFill>
-                      <a:srgbClr val="F0F4FF"/>
+                      <a:srgbClr val="FFF1F2"/>
                     </a:solidFill>
                   </a:tcPr>
                 </a:tc>
@@ -8351,7 +8351,7 @@
                   </a:txBody>
                   <a:tcPr>
                     <a:solidFill>
-                      <a:srgbClr val="F0F4FF"/>
+                      <a:srgbClr val="FFF1F2"/>
                     </a:solidFill>
                   </a:tcPr>
                 </a:tc>
@@ -8374,7 +8374,7 @@
                   </a:txBody>
                   <a:tcPr>
                     <a:solidFill>
-                      <a:srgbClr val="F0F4FF"/>
+                      <a:srgbClr val="FFF1F2"/>
                     </a:solidFill>
                   </a:tcPr>
                 </a:tc>
@@ -8398,11 +8398,11 @@
             <a:avLst/>
           </a:prstGeom>
           <a:solidFill>
-            <a:srgbClr val="F0F4FF"/>
+            <a:srgbClr val="FFF1F2"/>
           </a:solidFill>
           <a:ln>
             <a:solidFill>
-              <a:srgbClr val="1A73E8"/>
+              <a:srgbClr val="C7000B"/>
             </a:solidFill>
           </a:ln>
         </p:spPr>
@@ -8711,7 +8711,7 @@
             <a:r>
               <a:rPr sz="2400" b="1">
                 <a:solidFill>
-                  <a:srgbClr val="1A73E8"/>
+                  <a:srgbClr val="C7000B"/>
                 </a:solidFill>
                 <a:latin typeface="Microsoft YaHei"/>
               </a:rPr>
@@ -8735,7 +8735,7 @@
             <a:avLst/>
           </a:prstGeom>
           <a:solidFill>
-            <a:srgbClr val="1A73E8"/>
+            <a:srgbClr val="C7000B"/>
           </a:solidFill>
           <a:ln>
             <a:noFill/>
@@ -8789,7 +8789,7 @@
             <a:r>
               <a:rPr sz="1600" b="1">
                 <a:solidFill>
-                  <a:srgbClr val="1A73E8"/>
+                  <a:srgbClr val="C7000B"/>
                 </a:solidFill>
                 <a:latin typeface="Microsoft YaHei"/>
               </a:rPr>
@@ -8841,7 +8841,7 @@
                   </a:txBody>
                   <a:tcPr>
                     <a:solidFill>
-                      <a:srgbClr val="1A73E8"/>
+                      <a:srgbClr val="C7000B"/>
                     </a:solidFill>
                   </a:tcPr>
                 </a:tc>
@@ -8864,7 +8864,7 @@
                   </a:txBody>
                   <a:tcPr>
                     <a:solidFill>
-                      <a:srgbClr val="1A73E8"/>
+                      <a:srgbClr val="C7000B"/>
                     </a:solidFill>
                   </a:tcPr>
                 </a:tc>
@@ -8887,7 +8887,7 @@
                   </a:txBody>
                   <a:tcPr>
                     <a:solidFill>
-                      <a:srgbClr val="1A73E8"/>
+                      <a:srgbClr val="C7000B"/>
                     </a:solidFill>
                   </a:tcPr>
                 </a:tc>
@@ -8983,7 +8983,7 @@
                   </a:txBody>
                   <a:tcPr>
                     <a:solidFill>
-                      <a:srgbClr val="F0F4FF"/>
+                      <a:srgbClr val="FFF1F2"/>
                     </a:solidFill>
                   </a:tcPr>
                 </a:tc>
@@ -9006,7 +9006,7 @@
                   </a:txBody>
                   <a:tcPr>
                     <a:solidFill>
-                      <a:srgbClr val="F0F4FF"/>
+                      <a:srgbClr val="FFF1F2"/>
                     </a:solidFill>
                   </a:tcPr>
                 </a:tc>
@@ -9029,7 +9029,7 @@
                   </a:txBody>
                   <a:tcPr>
                     <a:solidFill>
-                      <a:srgbClr val="F0F4FF"/>
+                      <a:srgbClr val="FFF1F2"/>
                     </a:solidFill>
                   </a:tcPr>
                 </a:tc>
@@ -9125,7 +9125,7 @@
                   </a:txBody>
                   <a:tcPr>
                     <a:solidFill>
-                      <a:srgbClr val="F0F4FF"/>
+                      <a:srgbClr val="FFF1F2"/>
                     </a:solidFill>
                   </a:tcPr>
                 </a:tc>
@@ -9148,7 +9148,7 @@
                   </a:txBody>
                   <a:tcPr>
                     <a:solidFill>
-                      <a:srgbClr val="F0F4FF"/>
+                      <a:srgbClr val="FFF1F2"/>
                     </a:solidFill>
                   </a:tcPr>
                 </a:tc>
@@ -9171,7 +9171,7 @@
                   </a:txBody>
                   <a:tcPr>
                     <a:solidFill>
-                      <a:srgbClr val="F0F4FF"/>
+                      <a:srgbClr val="FFF1F2"/>
                     </a:solidFill>
                   </a:tcPr>
                 </a:tc>
@@ -9328,7 +9328,7 @@
                   </a:txBody>
                   <a:tcPr>
                     <a:solidFill>
-                      <a:srgbClr val="1A73E8"/>
+                      <a:srgbClr val="C7000B"/>
                     </a:solidFill>
                   </a:tcPr>
                 </a:tc>
@@ -9351,7 +9351,7 @@
                   </a:txBody>
                   <a:tcPr>
                     <a:solidFill>
-                      <a:srgbClr val="1A73E8"/>
+                      <a:srgbClr val="C7000B"/>
                     </a:solidFill>
                   </a:tcPr>
                 </a:tc>
@@ -9424,7 +9424,7 @@
                   </a:txBody>
                   <a:tcPr>
                     <a:solidFill>
-                      <a:srgbClr val="F0F4FF"/>
+                      <a:srgbClr val="FFF1F2"/>
                     </a:solidFill>
                   </a:tcPr>
                 </a:tc>
@@ -9447,7 +9447,7 @@
                   </a:txBody>
                   <a:tcPr>
                     <a:solidFill>
-                      <a:srgbClr val="F0F4FF"/>
+                      <a:srgbClr val="FFF1F2"/>
                     </a:solidFill>
                   </a:tcPr>
                 </a:tc>
@@ -9520,7 +9520,7 @@
                   </a:txBody>
                   <a:tcPr>
                     <a:solidFill>
-                      <a:srgbClr val="F0F4FF"/>
+                      <a:srgbClr val="FFF1F2"/>
                     </a:solidFill>
                   </a:tcPr>
                 </a:tc>
@@ -9543,7 +9543,7 @@
                   </a:txBody>
                   <a:tcPr>
                     <a:solidFill>
-                      <a:srgbClr val="F0F4FF"/>
+                      <a:srgbClr val="FFF1F2"/>
                     </a:solidFill>
                   </a:tcPr>
                 </a:tc>
@@ -9567,11 +9567,11 @@
             <a:avLst/>
           </a:prstGeom>
           <a:solidFill>
-            <a:srgbClr val="1A73E8"/>
+            <a:srgbClr val="C7000B"/>
           </a:solidFill>
           <a:ln>
             <a:solidFill>
-              <a:srgbClr val="1A73E8"/>
+              <a:srgbClr val="C7000B"/>
             </a:solidFill>
           </a:ln>
         </p:spPr>
@@ -9685,7 +9685,7 @@
             <a:r>
               <a:rPr sz="2400" b="1">
                 <a:solidFill>
-                  <a:srgbClr val="1A73E8"/>
+                  <a:srgbClr val="C7000B"/>
                 </a:solidFill>
                 <a:latin typeface="Microsoft YaHei"/>
               </a:rPr>
@@ -9709,7 +9709,7 @@
             <a:avLst/>
           </a:prstGeom>
           <a:solidFill>
-            <a:srgbClr val="1A73E8"/>
+            <a:srgbClr val="C7000B"/>
           </a:solidFill>
           <a:ln>
             <a:noFill/>
@@ -9798,7 +9798,7 @@
             <a:r>
               <a:rPr sz="1600" b="1">
                 <a:solidFill>
-                  <a:srgbClr val="1A73E8"/>
+                  <a:srgbClr val="C7000B"/>
                 </a:solidFill>
                 <a:latin typeface="Microsoft YaHei"/>
               </a:rPr>
@@ -9849,7 +9849,7 @@
                   </a:txBody>
                   <a:tcPr>
                     <a:solidFill>
-                      <a:srgbClr val="1A73E8"/>
+                      <a:srgbClr val="C7000B"/>
                     </a:solidFill>
                   </a:tcPr>
                 </a:tc>
@@ -9872,7 +9872,7 @@
                   </a:txBody>
                   <a:tcPr>
                     <a:solidFill>
-                      <a:srgbClr val="1A73E8"/>
+                      <a:srgbClr val="C7000B"/>
                     </a:solidFill>
                   </a:tcPr>
                 </a:tc>
@@ -9945,7 +9945,7 @@
                   </a:txBody>
                   <a:tcPr>
                     <a:solidFill>
-                      <a:srgbClr val="F0F4FF"/>
+                      <a:srgbClr val="FFF1F2"/>
                     </a:solidFill>
                   </a:tcPr>
                 </a:tc>
@@ -9968,7 +9968,7 @@
                   </a:txBody>
                   <a:tcPr>
                     <a:solidFill>
-                      <a:srgbClr val="F0F4FF"/>
+                      <a:srgbClr val="FFF1F2"/>
                     </a:solidFill>
                   </a:tcPr>
                 </a:tc>
@@ -10041,7 +10041,7 @@
                   </a:txBody>
                   <a:tcPr>
                     <a:solidFill>
-                      <a:srgbClr val="F0F4FF"/>
+                      <a:srgbClr val="FFF1F2"/>
                     </a:solidFill>
                   </a:tcPr>
                 </a:tc>
@@ -10064,7 +10064,7 @@
                   </a:txBody>
                   <a:tcPr>
                     <a:solidFill>
-                      <a:srgbClr val="F0F4FF"/>
+                      <a:srgbClr val="FFF1F2"/>
                     </a:solidFill>
                   </a:tcPr>
                 </a:tc>
@@ -10147,7 +10147,7 @@
             <a:r>
               <a:rPr sz="1600" b="1">
                 <a:solidFill>
-                  <a:srgbClr val="1A73E8"/>
+                  <a:srgbClr val="C7000B"/>
                 </a:solidFill>
                 <a:latin typeface="Microsoft YaHei"/>
               </a:rPr>
@@ -10198,7 +10198,7 @@
                   </a:txBody>
                   <a:tcPr>
                     <a:solidFill>
-                      <a:srgbClr val="1A73E8"/>
+                      <a:srgbClr val="C7000B"/>
                     </a:solidFill>
                   </a:tcPr>
                 </a:tc>
@@ -10221,7 +10221,7 @@
                   </a:txBody>
                   <a:tcPr>
                     <a:solidFill>
-                      <a:srgbClr val="1A73E8"/>
+                      <a:srgbClr val="C7000B"/>
                     </a:solidFill>
                   </a:tcPr>
                 </a:tc>
@@ -10294,7 +10294,7 @@
                   </a:txBody>
                   <a:tcPr>
                     <a:solidFill>
-                      <a:srgbClr val="F0F4FF"/>
+                      <a:srgbClr val="FFF1F2"/>
                     </a:solidFill>
                   </a:tcPr>
                 </a:tc>
@@ -10317,7 +10317,7 @@
                   </a:txBody>
                   <a:tcPr>
                     <a:solidFill>
-                      <a:srgbClr val="F0F4FF"/>
+                      <a:srgbClr val="FFF1F2"/>
                     </a:solidFill>
                   </a:tcPr>
                 </a:tc>
@@ -10390,7 +10390,7 @@
                   </a:txBody>
                   <a:tcPr>
                     <a:solidFill>
-                      <a:srgbClr val="F0F4FF"/>
+                      <a:srgbClr val="FFF1F2"/>
                     </a:solidFill>
                   </a:tcPr>
                 </a:tc>
@@ -10413,7 +10413,7 @@
                   </a:txBody>
                   <a:tcPr>
                     <a:solidFill>
-                      <a:srgbClr val="F0F4FF"/>
+                      <a:srgbClr val="FFF1F2"/>
                     </a:solidFill>
                   </a:tcPr>
                 </a:tc>
@@ -10496,7 +10496,7 @@
             <a:r>
               <a:rPr sz="1600" b="1">
                 <a:solidFill>
-                  <a:srgbClr val="1A73E8"/>
+                  <a:srgbClr val="C7000B"/>
                 </a:solidFill>
                 <a:latin typeface="Microsoft YaHei"/>
               </a:rPr>
@@ -10548,7 +10548,7 @@
                   </a:txBody>
                   <a:tcPr>
                     <a:solidFill>
-                      <a:srgbClr val="1A73E8"/>
+                      <a:srgbClr val="C7000B"/>
                     </a:solidFill>
                   </a:tcPr>
                 </a:tc>
@@ -10571,7 +10571,7 @@
                   </a:txBody>
                   <a:tcPr>
                     <a:solidFill>
-                      <a:srgbClr val="1A73E8"/>
+                      <a:srgbClr val="C7000B"/>
                     </a:solidFill>
                   </a:tcPr>
                 </a:tc>
@@ -10594,7 +10594,7 @@
                   </a:txBody>
                   <a:tcPr>
                     <a:solidFill>
-                      <a:srgbClr val="1A73E8"/>
+                      <a:srgbClr val="C7000B"/>
                     </a:solidFill>
                   </a:tcPr>
                 </a:tc>
@@ -10690,7 +10690,7 @@
                   </a:txBody>
                   <a:tcPr>
                     <a:solidFill>
-                      <a:srgbClr val="F0F4FF"/>
+                      <a:srgbClr val="FFF1F2"/>
                     </a:solidFill>
                   </a:tcPr>
                 </a:tc>
@@ -10713,7 +10713,7 @@
                   </a:txBody>
                   <a:tcPr>
                     <a:solidFill>
-                      <a:srgbClr val="F0F4FF"/>
+                      <a:srgbClr val="FFF1F2"/>
                     </a:solidFill>
                   </a:tcPr>
                 </a:tc>
@@ -10736,7 +10736,7 @@
                   </a:txBody>
                   <a:tcPr>
                     <a:solidFill>
-                      <a:srgbClr val="F0F4FF"/>
+                      <a:srgbClr val="FFF1F2"/>
                     </a:solidFill>
                   </a:tcPr>
                 </a:tc>
@@ -10832,7 +10832,7 @@
                   </a:txBody>
                   <a:tcPr>
                     <a:solidFill>
-                      <a:srgbClr val="F0F4FF"/>
+                      <a:srgbClr val="FFF1F2"/>
                     </a:solidFill>
                   </a:tcPr>
                 </a:tc>
@@ -10855,7 +10855,7 @@
                   </a:txBody>
                   <a:tcPr>
                     <a:solidFill>
-                      <a:srgbClr val="F0F4FF"/>
+                      <a:srgbClr val="FFF1F2"/>
                     </a:solidFill>
                   </a:tcPr>
                 </a:tc>
@@ -10878,7 +10878,7 @@
                   </a:txBody>
                   <a:tcPr>
                     <a:solidFill>
-                      <a:srgbClr val="F0F4FF"/>
+                      <a:srgbClr val="FFF1F2"/>
                     </a:solidFill>
                   </a:tcPr>
                 </a:tc>
@@ -10974,7 +10974,7 @@
                   </a:txBody>
                   <a:tcPr>
                     <a:solidFill>
-                      <a:srgbClr val="F0F4FF"/>
+                      <a:srgbClr val="FFF1F2"/>
                     </a:solidFill>
                   </a:tcPr>
                 </a:tc>
@@ -10997,7 +10997,7 @@
                   </a:txBody>
                   <a:tcPr>
                     <a:solidFill>
-                      <a:srgbClr val="F0F4FF"/>
+                      <a:srgbClr val="FFF1F2"/>
                     </a:solidFill>
                   </a:tcPr>
                 </a:tc>
@@ -11020,7 +11020,7 @@
                   </a:txBody>
                   <a:tcPr>
                     <a:solidFill>
-                      <a:srgbClr val="F0F4FF"/>
+                      <a:srgbClr val="FFF1F2"/>
                     </a:solidFill>
                   </a:tcPr>
                 </a:tc>
@@ -11116,7 +11116,7 @@
                   </a:txBody>
                   <a:tcPr>
                     <a:solidFill>
-                      <a:srgbClr val="F0F4FF"/>
+                      <a:srgbClr val="FFF1F2"/>
                     </a:solidFill>
                   </a:tcPr>
                 </a:tc>
@@ -11139,7 +11139,7 @@
                   </a:txBody>
                   <a:tcPr>
                     <a:solidFill>
-                      <a:srgbClr val="F0F4FF"/>
+                      <a:srgbClr val="FFF1F2"/>
                     </a:solidFill>
                   </a:tcPr>
                 </a:tc>
@@ -11162,7 +11162,7 @@
                   </a:txBody>
                   <a:tcPr>
                     <a:solidFill>
-                      <a:srgbClr val="F0F4FF"/>
+                      <a:srgbClr val="FFF1F2"/>
                     </a:solidFill>
                   </a:tcPr>
                 </a:tc>
@@ -11250,7 +11250,7 @@
             <a:r>
               <a:rPr sz="2400" b="1">
                 <a:solidFill>
-                  <a:srgbClr val="1A73E8"/>
+                  <a:srgbClr val="C7000B"/>
                 </a:solidFill>
                 <a:latin typeface="Microsoft YaHei"/>
               </a:rPr>
@@ -11274,7 +11274,7 @@
             <a:avLst/>
           </a:prstGeom>
           <a:solidFill>
-            <a:srgbClr val="1A73E8"/>
+            <a:srgbClr val="C7000B"/>
           </a:solidFill>
           <a:ln>
             <a:noFill/>
@@ -11679,7 +11679,7 @@
             <a:r>
               <a:rPr sz="1600" b="1">
                 <a:solidFill>
-                  <a:srgbClr val="1A73E8"/>
+                  <a:srgbClr val="C7000B"/>
                 </a:solidFill>
                 <a:latin typeface="Microsoft YaHei"/>
               </a:rPr>
@@ -11730,7 +11730,7 @@
                   </a:txBody>
                   <a:tcPr>
                     <a:solidFill>
-                      <a:srgbClr val="1A73E8"/>
+                      <a:srgbClr val="C7000B"/>
                     </a:solidFill>
                   </a:tcPr>
                 </a:tc>
@@ -11753,7 +11753,7 @@
                   </a:txBody>
                   <a:tcPr>
                     <a:solidFill>
-                      <a:srgbClr val="1A73E8"/>
+                      <a:srgbClr val="C7000B"/>
                     </a:solidFill>
                   </a:tcPr>
                 </a:tc>
@@ -11826,7 +11826,7 @@
                   </a:txBody>
                   <a:tcPr>
                     <a:solidFill>
-                      <a:srgbClr val="F0F4FF"/>
+                      <a:srgbClr val="FFF1F2"/>
                     </a:solidFill>
                   </a:tcPr>
                 </a:tc>
@@ -11849,7 +11849,7 @@
                   </a:txBody>
                   <a:tcPr>
                     <a:solidFill>
-                      <a:srgbClr val="F0F4FF"/>
+                      <a:srgbClr val="FFF1F2"/>
                     </a:solidFill>
                   </a:tcPr>
                 </a:tc>
@@ -11922,7 +11922,7 @@
                   </a:txBody>
                   <a:tcPr>
                     <a:solidFill>
-                      <a:srgbClr val="F0F4FF"/>
+                      <a:srgbClr val="FFF1F2"/>
                     </a:solidFill>
                   </a:tcPr>
                 </a:tc>
@@ -11945,7 +11945,7 @@
                   </a:txBody>
                   <a:tcPr>
                     <a:solidFill>
-                      <a:srgbClr val="F0F4FF"/>
+                      <a:srgbClr val="FFF1F2"/>
                     </a:solidFill>
                   </a:tcPr>
                 </a:tc>
@@ -12018,7 +12018,7 @@
                   </a:txBody>
                   <a:tcPr>
                     <a:solidFill>
-                      <a:srgbClr val="F0F4FF"/>
+                      <a:srgbClr val="FFF1F2"/>
                     </a:solidFill>
                   </a:tcPr>
                 </a:tc>
@@ -12041,7 +12041,7 @@
                   </a:txBody>
                   <a:tcPr>
                     <a:solidFill>
-                      <a:srgbClr val="F0F4FF"/>
+                      <a:srgbClr val="FFF1F2"/>
                     </a:solidFill>
                   </a:tcPr>
                 </a:tc>
@@ -12223,7 +12223,7 @@
                   </a:txBody>
                   <a:tcPr>
                     <a:solidFill>
-                      <a:srgbClr val="F0F4FF"/>
+                      <a:srgbClr val="FFF1F2"/>
                     </a:solidFill>
                   </a:tcPr>
                 </a:tc>
@@ -12246,7 +12246,7 @@
                   </a:txBody>
                   <a:tcPr>
                     <a:solidFill>
-                      <a:srgbClr val="F0F4FF"/>
+                      <a:srgbClr val="FFF1F2"/>
                     </a:solidFill>
                   </a:tcPr>
                 </a:tc>
@@ -12318,11 +12318,11 @@
             <a:avLst/>
           </a:prstGeom>
           <a:solidFill>
-            <a:srgbClr val="1A73E8"/>
+            <a:srgbClr val="C7000B"/>
           </a:solidFill>
           <a:ln>
             <a:solidFill>
-              <a:srgbClr val="1A73E8"/>
+              <a:srgbClr val="C7000B"/>
             </a:solidFill>
           </a:ln>
         </p:spPr>
@@ -12436,7 +12436,7 @@
             <a:r>
               <a:rPr sz="2400" b="1">
                 <a:solidFill>
-                  <a:srgbClr val="1A73E8"/>
+                  <a:srgbClr val="C7000B"/>
                 </a:solidFill>
                 <a:latin typeface="Microsoft YaHei"/>
               </a:rPr>
@@ -12460,7 +12460,7 @@
             <a:avLst/>
           </a:prstGeom>
           <a:solidFill>
-            <a:srgbClr val="1A73E8"/>
+            <a:srgbClr val="C7000B"/>
           </a:solidFill>
           <a:ln>
             <a:noFill/>
@@ -12721,7 +12721,7 @@
             <a:avLst/>
           </a:prstGeom>
           <a:solidFill>
-            <a:srgbClr val="1A73E8"/>
+            <a:srgbClr val="C7000B"/>
           </a:solidFill>
           <a:ln>
             <a:noFill/>
@@ -13375,11 +13375,11 @@
             <a:avLst/>
           </a:prstGeom>
           <a:solidFill>
-            <a:srgbClr val="F0F4FF"/>
+            <a:srgbClr val="FFF1F2"/>
           </a:solidFill>
           <a:ln>
             <a:solidFill>
-              <a:srgbClr val="1A73E8"/>
+              <a:srgbClr val="C7000B"/>
             </a:solidFill>
           </a:ln>
         </p:spPr>
@@ -13431,7 +13431,7 @@
             <a:r>
               <a:rPr sz="1600" b="1">
                 <a:solidFill>
-                  <a:srgbClr val="1A73E8"/>
+                  <a:srgbClr val="C7000B"/>
                 </a:solidFill>
                 <a:latin typeface="Microsoft YaHei"/>
               </a:rPr>
@@ -13606,7 +13606,7 @@
             <a:r>
               <a:rPr sz="1400" b="1">
                 <a:solidFill>
-                  <a:srgbClr val="1A73E8"/>
+                  <a:srgbClr val="C7000B"/>
                 </a:solidFill>
                 <a:latin typeface="Microsoft YaHei"/>
               </a:rPr>
@@ -13694,7 +13694,7 @@
             <a:r>
               <a:rPr sz="2400" b="1">
                 <a:solidFill>
-                  <a:srgbClr val="1A73E8"/>
+                  <a:srgbClr val="C7000B"/>
                 </a:solidFill>
                 <a:latin typeface="Microsoft YaHei"/>
               </a:rPr>
@@ -13718,7 +13718,7 @@
             <a:avLst/>
           </a:prstGeom>
           <a:solidFill>
-            <a:srgbClr val="1A73E8"/>
+            <a:srgbClr val="C7000B"/>
           </a:solidFill>
           <a:ln>
             <a:noFill/>
@@ -13772,7 +13772,7 @@
             <a:r>
               <a:rPr sz="1400" b="1">
                 <a:solidFill>
-                  <a:srgbClr val="1A73E8"/>
+                  <a:srgbClr val="C7000B"/>
                 </a:solidFill>
                 <a:latin typeface="Microsoft YaHei"/>
               </a:rPr>
@@ -13823,7 +13823,7 @@
                   </a:txBody>
                   <a:tcPr>
                     <a:solidFill>
-                      <a:srgbClr val="1A73E8"/>
+                      <a:srgbClr val="C7000B"/>
                     </a:solidFill>
                   </a:tcPr>
                 </a:tc>
@@ -13846,7 +13846,7 @@
                   </a:txBody>
                   <a:tcPr>
                     <a:solidFill>
-                      <a:srgbClr val="1A73E8"/>
+                      <a:srgbClr val="C7000B"/>
                     </a:solidFill>
                   </a:tcPr>
                 </a:tc>
@@ -13919,7 +13919,7 @@
                   </a:txBody>
                   <a:tcPr>
                     <a:solidFill>
-                      <a:srgbClr val="F0F4FF"/>
+                      <a:srgbClr val="FFF1F2"/>
                     </a:solidFill>
                   </a:tcPr>
                 </a:tc>
@@ -13942,7 +13942,7 @@
                   </a:txBody>
                   <a:tcPr>
                     <a:solidFill>
-                      <a:srgbClr val="F0F4FF"/>
+                      <a:srgbClr val="FFF1F2"/>
                     </a:solidFill>
                   </a:tcPr>
                 </a:tc>
@@ -14025,7 +14025,7 @@
             <a:r>
               <a:rPr sz="1400" b="1">
                 <a:solidFill>
-                  <a:srgbClr val="1A73E8"/>
+                  <a:srgbClr val="C7000B"/>
                 </a:solidFill>
                 <a:latin typeface="Microsoft YaHei"/>
               </a:rPr>
@@ -14076,7 +14076,7 @@
                   </a:txBody>
                   <a:tcPr>
                     <a:solidFill>
-                      <a:srgbClr val="1A73E8"/>
+                      <a:srgbClr val="C7000B"/>
                     </a:solidFill>
                   </a:tcPr>
                 </a:tc>
@@ -14099,7 +14099,7 @@
                   </a:txBody>
                   <a:tcPr>
                     <a:solidFill>
-                      <a:srgbClr val="1A73E8"/>
+                      <a:srgbClr val="C7000B"/>
                     </a:solidFill>
                   </a:tcPr>
                 </a:tc>
@@ -14172,7 +14172,7 @@
                   </a:txBody>
                   <a:tcPr>
                     <a:solidFill>
-                      <a:srgbClr val="F0F4FF"/>
+                      <a:srgbClr val="FFF1F2"/>
                     </a:solidFill>
                   </a:tcPr>
                 </a:tc>
@@ -14195,7 +14195,7 @@
                   </a:txBody>
                   <a:tcPr>
                     <a:solidFill>
-                      <a:srgbClr val="F0F4FF"/>
+                      <a:srgbClr val="FFF1F2"/>
                     </a:solidFill>
                   </a:tcPr>
                 </a:tc>
@@ -14329,7 +14329,7 @@
                   </a:txBody>
                   <a:tcPr>
                     <a:solidFill>
-                      <a:srgbClr val="1A73E8"/>
+                      <a:srgbClr val="C7000B"/>
                     </a:solidFill>
                   </a:tcPr>
                 </a:tc>
@@ -14352,7 +14352,7 @@
                   </a:txBody>
                   <a:tcPr>
                     <a:solidFill>
-                      <a:srgbClr val="1A73E8"/>
+                      <a:srgbClr val="C7000B"/>
                     </a:solidFill>
                   </a:tcPr>
                 </a:tc>
@@ -14425,7 +14425,7 @@
                   </a:txBody>
                   <a:tcPr>
                     <a:solidFill>
-                      <a:srgbClr val="F0F4FF"/>
+                      <a:srgbClr val="FFF1F2"/>
                     </a:solidFill>
                   </a:tcPr>
                 </a:tc>
@@ -14448,7 +14448,7 @@
                   </a:txBody>
                   <a:tcPr>
                     <a:solidFill>
-                      <a:srgbClr val="F0F4FF"/>
+                      <a:srgbClr val="FFF1F2"/>
                     </a:solidFill>
                   </a:tcPr>
                 </a:tc>
@@ -14584,7 +14584,7 @@
             <a:r>
               <a:rPr sz="2400" b="1">
                 <a:solidFill>
-                  <a:srgbClr val="1A73E8"/>
+                  <a:srgbClr val="C7000B"/>
                 </a:solidFill>
                 <a:latin typeface="Microsoft YaHei"/>
               </a:rPr>
@@ -14608,7 +14608,7 @@
             <a:avLst/>
           </a:prstGeom>
           <a:solidFill>
-            <a:srgbClr val="1A73E8"/>
+            <a:srgbClr val="C7000B"/>
           </a:solidFill>
           <a:ln>
             <a:noFill/>
@@ -14662,7 +14662,7 @@
             <a:r>
               <a:rPr sz="1400" b="1">
                 <a:solidFill>
-                  <a:srgbClr val="1A73E8"/>
+                  <a:srgbClr val="C7000B"/>
                 </a:solidFill>
                 <a:latin typeface="Microsoft YaHei"/>
               </a:rPr>
@@ -14748,7 +14748,7 @@
                   </a:txBody>
                   <a:tcPr>
                     <a:solidFill>
-                      <a:srgbClr val="1A73E8"/>
+                      <a:srgbClr val="C7000B"/>
                     </a:solidFill>
                   </a:tcPr>
                 </a:tc>
@@ -14771,7 +14771,7 @@
                   </a:txBody>
                   <a:tcPr>
                     <a:solidFill>
-                      <a:srgbClr val="1A73E8"/>
+                      <a:srgbClr val="C7000B"/>
                     </a:solidFill>
                   </a:tcPr>
                 </a:tc>
@@ -14844,7 +14844,7 @@
                   </a:txBody>
                   <a:tcPr>
                     <a:solidFill>
-                      <a:srgbClr val="F0F4FF"/>
+                      <a:srgbClr val="FFF1F2"/>
                     </a:solidFill>
                   </a:tcPr>
                 </a:tc>
@@ -14867,7 +14867,7 @@
                   </a:txBody>
                   <a:tcPr>
                     <a:solidFill>
-                      <a:srgbClr val="F0F4FF"/>
+                      <a:srgbClr val="FFF1F2"/>
                     </a:solidFill>
                   </a:tcPr>
                 </a:tc>
@@ -15273,7 +15273,7 @@
                   </a:txBody>
                   <a:tcPr>
                     <a:solidFill>
-                      <a:srgbClr val="F0F4FF"/>
+                      <a:srgbClr val="FFF1F2"/>
                     </a:solidFill>
                   </a:tcPr>
                 </a:tc>
@@ -15296,7 +15296,7 @@
                   </a:txBody>
                   <a:tcPr>
                     <a:solidFill>
-                      <a:srgbClr val="F0F4FF"/>
+                      <a:srgbClr val="FFF1F2"/>
                     </a:solidFill>
                   </a:tcPr>
                 </a:tc>
@@ -15319,7 +15319,7 @@
                   </a:txBody>
                   <a:tcPr>
                     <a:solidFill>
-                      <a:srgbClr val="F0F4FF"/>
+                      <a:srgbClr val="FFF1F2"/>
                     </a:solidFill>
                   </a:tcPr>
                 </a:tc>
@@ -15342,7 +15342,7 @@
                   </a:txBody>
                   <a:tcPr>
                     <a:solidFill>
-                      <a:srgbClr val="F0F4FF"/>
+                      <a:srgbClr val="FFF1F2"/>
                     </a:solidFill>
                   </a:tcPr>
                 </a:tc>
@@ -15365,7 +15365,7 @@
                   </a:txBody>
                   <a:tcPr>
                     <a:solidFill>
-                      <a:srgbClr val="F0F4FF"/>
+                      <a:srgbClr val="FFF1F2"/>
                     </a:solidFill>
                   </a:tcPr>
                 </a:tc>
@@ -15506,11 +15506,11 @@
             <a:avLst/>
           </a:prstGeom>
           <a:solidFill>
-            <a:srgbClr val="F0F4FF"/>
+            <a:srgbClr val="FFF1F2"/>
           </a:solidFill>
           <a:ln>
             <a:solidFill>
-              <a:srgbClr val="1A73E8"/>
+              <a:srgbClr val="C7000B"/>
             </a:solidFill>
           </a:ln>
         </p:spPr>
@@ -15536,7 +15536,7 @@
             <a:r>
               <a:rPr sz="1200" b="1">
                 <a:solidFill>
-                  <a:srgbClr val="1A73E8"/>
+                  <a:srgbClr val="C7000B"/>
                 </a:solidFill>
                 <a:latin typeface="Microsoft YaHei"/>
               </a:rPr>
@@ -15624,7 +15624,7 @@
             <a:r>
               <a:rPr sz="2400" b="1">
                 <a:solidFill>
-                  <a:srgbClr val="1A73E8"/>
+                  <a:srgbClr val="C7000B"/>
                 </a:solidFill>
                 <a:latin typeface="Microsoft YaHei"/>
               </a:rPr>
@@ -15648,7 +15648,7 @@
             <a:avLst/>
           </a:prstGeom>
           <a:solidFill>
-            <a:srgbClr val="1A73E8"/>
+            <a:srgbClr val="C7000B"/>
           </a:solidFill>
           <a:ln>
             <a:noFill/>
@@ -15702,7 +15702,7 @@
             <a:r>
               <a:rPr sz="1600" b="1">
                 <a:solidFill>
-                  <a:srgbClr val="1A73E8"/>
+                  <a:srgbClr val="C7000B"/>
                 </a:solidFill>
                 <a:latin typeface="Microsoft YaHei"/>
               </a:rPr>
@@ -15947,7 +15947,7 @@
             <a:r>
               <a:rPr sz="1400" b="1">
                 <a:solidFill>
-                  <a:srgbClr val="1A73E8"/>
+                  <a:srgbClr val="C7000B"/>
                 </a:solidFill>
                 <a:latin typeface="Microsoft YaHei"/>
               </a:rPr>
@@ -16017,7 +16017,7 @@
             <a:r>
               <a:rPr sz="1200" b="0">
                 <a:solidFill>
-                  <a:srgbClr val="1A73E8"/>
+                  <a:srgbClr val="C7000B"/>
                 </a:solidFill>
                 <a:latin typeface="Microsoft YaHei"/>
               </a:rPr>
@@ -16052,7 +16052,7 @@
             <a:r>
               <a:rPr sz="1400" b="1">
                 <a:solidFill>
-                  <a:srgbClr val="1A73E8"/>
+                  <a:srgbClr val="C7000B"/>
                 </a:solidFill>
                 <a:latin typeface="Microsoft YaHei"/>
               </a:rPr>
@@ -16122,7 +16122,7 @@
             <a:r>
               <a:rPr sz="1200" b="0">
                 <a:solidFill>
-                  <a:srgbClr val="1A73E8"/>
+                  <a:srgbClr val="C7000B"/>
                 </a:solidFill>
                 <a:latin typeface="Microsoft YaHei"/>
               </a:rPr>
@@ -16157,7 +16157,7 @@
             <a:r>
               <a:rPr sz="1600" b="1">
                 <a:solidFill>
-                  <a:srgbClr val="1A73E8"/>
+                  <a:srgbClr val="C7000B"/>
                 </a:solidFill>
                 <a:latin typeface="Microsoft YaHei"/>
               </a:rPr>
@@ -16209,7 +16209,7 @@
                   </a:txBody>
                   <a:tcPr>
                     <a:solidFill>
-                      <a:srgbClr val="1A73E8"/>
+                      <a:srgbClr val="C7000B"/>
                     </a:solidFill>
                   </a:tcPr>
                 </a:tc>
@@ -16232,7 +16232,7 @@
                   </a:txBody>
                   <a:tcPr>
                     <a:solidFill>
-                      <a:srgbClr val="1A73E8"/>
+                      <a:srgbClr val="C7000B"/>
                     </a:solidFill>
                   </a:tcPr>
                 </a:tc>
@@ -16255,7 +16255,7 @@
                   </a:txBody>
                   <a:tcPr>
                     <a:solidFill>
-                      <a:srgbClr val="1A73E8"/>
+                      <a:srgbClr val="C7000B"/>
                     </a:solidFill>
                   </a:tcPr>
                 </a:tc>
@@ -16351,7 +16351,7 @@
                   </a:txBody>
                   <a:tcPr>
                     <a:solidFill>
-                      <a:srgbClr val="F0F4FF"/>
+                      <a:srgbClr val="FFF1F2"/>
                     </a:solidFill>
                   </a:tcPr>
                 </a:tc>
@@ -16374,7 +16374,7 @@
                   </a:txBody>
                   <a:tcPr>
                     <a:solidFill>
-                      <a:srgbClr val="F0F4FF"/>
+                      <a:srgbClr val="FFF1F2"/>
                     </a:solidFill>
                   </a:tcPr>
                 </a:tc>
@@ -16397,7 +16397,7 @@
                   </a:txBody>
                   <a:tcPr>
                     <a:solidFill>
-                      <a:srgbClr val="F0F4FF"/>
+                      <a:srgbClr val="FFF1F2"/>
                     </a:solidFill>
                   </a:tcPr>
                 </a:tc>
@@ -16493,7 +16493,7 @@
                   </a:txBody>
                   <a:tcPr>
                     <a:solidFill>
-                      <a:srgbClr val="F0F4FF"/>
+                      <a:srgbClr val="FFF1F2"/>
                     </a:solidFill>
                   </a:tcPr>
                 </a:tc>
@@ -16516,7 +16516,7 @@
                   </a:txBody>
                   <a:tcPr>
                     <a:solidFill>
-                      <a:srgbClr val="F0F4FF"/>
+                      <a:srgbClr val="FFF1F2"/>
                     </a:solidFill>
                   </a:tcPr>
                 </a:tc>
@@ -16539,7 +16539,7 @@
                   </a:txBody>
                   <a:tcPr>
                     <a:solidFill>
-                      <a:srgbClr val="F0F4FF"/>
+                      <a:srgbClr val="FFF1F2"/>
                     </a:solidFill>
                   </a:tcPr>
                 </a:tc>
@@ -16635,7 +16635,7 @@
                   </a:txBody>
                   <a:tcPr>
                     <a:solidFill>
-                      <a:srgbClr val="F0F4FF"/>
+                      <a:srgbClr val="FFF1F2"/>
                     </a:solidFill>
                   </a:tcPr>
                 </a:tc>
@@ -16658,7 +16658,7 @@
                   </a:txBody>
                   <a:tcPr>
                     <a:solidFill>
-                      <a:srgbClr val="F0F4FF"/>
+                      <a:srgbClr val="FFF1F2"/>
                     </a:solidFill>
                   </a:tcPr>
                 </a:tc>
@@ -16681,7 +16681,7 @@
                   </a:txBody>
                   <a:tcPr>
                     <a:solidFill>
-                      <a:srgbClr val="F0F4FF"/>
+                      <a:srgbClr val="FFF1F2"/>
                     </a:solidFill>
                   </a:tcPr>
                 </a:tc>
@@ -16777,7 +16777,7 @@
                   </a:txBody>
                   <a:tcPr>
                     <a:solidFill>
-                      <a:srgbClr val="F0F4FF"/>
+                      <a:srgbClr val="FFF1F2"/>
                     </a:solidFill>
                   </a:tcPr>
                 </a:tc>
@@ -16800,7 +16800,7 @@
                   </a:txBody>
                   <a:tcPr>
                     <a:solidFill>
-                      <a:srgbClr val="F0F4FF"/>
+                      <a:srgbClr val="FFF1F2"/>
                     </a:solidFill>
                   </a:tcPr>
                 </a:tc>
@@ -16823,7 +16823,7 @@
                   </a:txBody>
                   <a:tcPr>
                     <a:solidFill>
-                      <a:srgbClr val="F0F4FF"/>
+                      <a:srgbClr val="FFF1F2"/>
                     </a:solidFill>
                   </a:tcPr>
                 </a:tc>
@@ -16847,11 +16847,11 @@
             <a:avLst/>
           </a:prstGeom>
           <a:solidFill>
-            <a:srgbClr val="F0F4FF"/>
+            <a:srgbClr val="FFF1F2"/>
           </a:solidFill>
           <a:ln>
             <a:solidFill>
-              <a:srgbClr val="1A73E8"/>
+              <a:srgbClr val="C7000B"/>
             </a:solidFill>
           </a:ln>
         </p:spPr>
@@ -16877,7 +16877,7 @@
             <a:r>
               <a:rPr sz="1400" b="1">
                 <a:solidFill>
-                  <a:srgbClr val="1A73E8"/>
+                  <a:srgbClr val="C7000B"/>
                 </a:solidFill>
                 <a:latin typeface="Microsoft YaHei"/>
               </a:rPr>
@@ -16965,7 +16965,7 @@
             <a:r>
               <a:rPr sz="2400" b="1">
                 <a:solidFill>
-                  <a:srgbClr val="1A73E8"/>
+                  <a:srgbClr val="C7000B"/>
                 </a:solidFill>
                 <a:latin typeface="Microsoft YaHei"/>
               </a:rPr>
@@ -16989,7 +16989,7 @@
             <a:avLst/>
           </a:prstGeom>
           <a:solidFill>
-            <a:srgbClr val="1A73E8"/>
+            <a:srgbClr val="C7000B"/>
           </a:solidFill>
           <a:ln>
             <a:noFill/>
@@ -17540,7 +17540,7 @@
                   </a:txBody>
                   <a:tcPr>
                     <a:solidFill>
-                      <a:srgbClr val="F0F4FF"/>
+                      <a:srgbClr val="FFF1F2"/>
                     </a:solidFill>
                   </a:tcPr>
                 </a:tc>
@@ -17563,7 +17563,7 @@
                   </a:txBody>
                   <a:tcPr>
                     <a:solidFill>
-                      <a:srgbClr val="F0F4FF"/>
+                      <a:srgbClr val="FFF1F2"/>
                     </a:solidFill>
                   </a:tcPr>
                 </a:tc>
@@ -17636,7 +17636,7 @@
                   </a:txBody>
                   <a:tcPr>
                     <a:solidFill>
-                      <a:srgbClr val="F0F4FF"/>
+                      <a:srgbClr val="FFF1F2"/>
                     </a:solidFill>
                   </a:tcPr>
                 </a:tc>
@@ -17659,7 +17659,7 @@
                   </a:txBody>
                   <a:tcPr>
                     <a:solidFill>
-                      <a:srgbClr val="F0F4FF"/>
+                      <a:srgbClr val="FFF1F2"/>
                     </a:solidFill>
                   </a:tcPr>
                 </a:tc>
@@ -17694,7 +17694,7 @@
             <a:r>
               <a:rPr sz="1400" b="1">
                 <a:solidFill>
-                  <a:srgbClr val="1A73E8"/>
+                  <a:srgbClr val="C7000B"/>
                 </a:solidFill>
                 <a:latin typeface="Microsoft YaHei"/>
               </a:rPr>
@@ -17745,7 +17745,7 @@
                   </a:txBody>
                   <a:tcPr>
                     <a:solidFill>
-                      <a:srgbClr val="1A73E8"/>
+                      <a:srgbClr val="C7000B"/>
                     </a:solidFill>
                   </a:tcPr>
                 </a:tc>
@@ -17768,7 +17768,7 @@
                   </a:txBody>
                   <a:tcPr>
                     <a:solidFill>
-                      <a:srgbClr val="1A73E8"/>
+                      <a:srgbClr val="C7000B"/>
                     </a:solidFill>
                   </a:tcPr>
                 </a:tc>
@@ -17841,7 +17841,7 @@
                   </a:txBody>
                   <a:tcPr>
                     <a:solidFill>
-                      <a:srgbClr val="F0F4FF"/>
+                      <a:srgbClr val="FFF1F2"/>
                     </a:solidFill>
                   </a:tcPr>
                 </a:tc>
@@ -17864,7 +17864,7 @@
                   </a:txBody>
                   <a:tcPr>
                     <a:solidFill>
-                      <a:srgbClr val="F0F4FF"/>
+                      <a:srgbClr val="FFF1F2"/>
                     </a:solidFill>
                   </a:tcPr>
                 </a:tc>
@@ -17937,7 +17937,7 @@
                   </a:txBody>
                   <a:tcPr>
                     <a:solidFill>
-                      <a:srgbClr val="F0F4FF"/>
+                      <a:srgbClr val="FFF1F2"/>
                     </a:solidFill>
                   </a:tcPr>
                 </a:tc>
@@ -17960,7 +17960,7 @@
                   </a:txBody>
                   <a:tcPr>
                     <a:solidFill>
-                      <a:srgbClr val="F0F4FF"/>
+                      <a:srgbClr val="FFF1F2"/>
                     </a:solidFill>
                   </a:tcPr>
                 </a:tc>
@@ -17995,7 +17995,7 @@
             <a:r>
               <a:rPr sz="1400" b="1">
                 <a:solidFill>
-                  <a:srgbClr val="1A73E8"/>
+                  <a:srgbClr val="C7000B"/>
                 </a:solidFill>
                 <a:latin typeface="Microsoft YaHei"/>
               </a:rPr>
@@ -18118,7 +18118,7 @@
             <a:r>
               <a:rPr sz="2400" b="1">
                 <a:solidFill>
-                  <a:srgbClr val="1A73E8"/>
+                  <a:srgbClr val="C7000B"/>
                 </a:solidFill>
                 <a:latin typeface="Microsoft YaHei"/>
               </a:rPr>
@@ -18142,7 +18142,7 @@
             <a:avLst/>
           </a:prstGeom>
           <a:solidFill>
-            <a:srgbClr val="1A73E8"/>
+            <a:srgbClr val="C7000B"/>
           </a:solidFill>
           <a:ln>
             <a:noFill/>
@@ -18196,7 +18196,7 @@
             <a:r>
               <a:rPr sz="1400" b="1">
                 <a:solidFill>
-                  <a:srgbClr val="1A73E8"/>
+                  <a:srgbClr val="C7000B"/>
                 </a:solidFill>
                 <a:latin typeface="Microsoft YaHei"/>
               </a:rPr>
@@ -18248,7 +18248,7 @@
                   </a:txBody>
                   <a:tcPr>
                     <a:solidFill>
-                      <a:srgbClr val="1A73E8"/>
+                      <a:srgbClr val="C7000B"/>
                     </a:solidFill>
                   </a:tcPr>
                 </a:tc>
@@ -18271,7 +18271,7 @@
                   </a:txBody>
                   <a:tcPr>
                     <a:solidFill>
-                      <a:srgbClr val="1A73E8"/>
+                      <a:srgbClr val="C7000B"/>
                     </a:solidFill>
                   </a:tcPr>
                 </a:tc>
@@ -18294,7 +18294,7 @@
                   </a:txBody>
                   <a:tcPr>
                     <a:solidFill>
-                      <a:srgbClr val="1A73E8"/>
+                      <a:srgbClr val="C7000B"/>
                     </a:solidFill>
                   </a:tcPr>
                 </a:tc>
@@ -18390,7 +18390,7 @@
                   </a:txBody>
                   <a:tcPr>
                     <a:solidFill>
-                      <a:srgbClr val="F0F4FF"/>
+                      <a:srgbClr val="FFF1F2"/>
                     </a:solidFill>
                   </a:tcPr>
                 </a:tc>
@@ -18413,7 +18413,7 @@
                   </a:txBody>
                   <a:tcPr>
                     <a:solidFill>
-                      <a:srgbClr val="F0F4FF"/>
+                      <a:srgbClr val="FFF1F2"/>
                     </a:solidFill>
                   </a:tcPr>
                 </a:tc>
@@ -18436,7 +18436,7 @@
                   </a:txBody>
                   <a:tcPr>
                     <a:solidFill>
-                      <a:srgbClr val="F0F4FF"/>
+                      <a:srgbClr val="FFF1F2"/>
                     </a:solidFill>
                   </a:tcPr>
                 </a:tc>
@@ -18532,7 +18532,7 @@
                   </a:txBody>
                   <a:tcPr>
                     <a:solidFill>
-                      <a:srgbClr val="F0F4FF"/>
+                      <a:srgbClr val="FFF1F2"/>
                     </a:solidFill>
                   </a:tcPr>
                 </a:tc>
@@ -18555,7 +18555,7 @@
                   </a:txBody>
                   <a:tcPr>
                     <a:solidFill>
-                      <a:srgbClr val="F0F4FF"/>
+                      <a:srgbClr val="FFF1F2"/>
                     </a:solidFill>
                   </a:tcPr>
                 </a:tc>
@@ -18578,7 +18578,7 @@
                   </a:txBody>
                   <a:tcPr>
                     <a:solidFill>
-                      <a:srgbClr val="F0F4FF"/>
+                      <a:srgbClr val="FFF1F2"/>
                     </a:solidFill>
                   </a:tcPr>
                 </a:tc>
@@ -18878,7 +18878,7 @@
                   </a:txBody>
                   <a:tcPr>
                     <a:solidFill>
-                      <a:srgbClr val="F0F4FF"/>
+                      <a:srgbClr val="FFF1F2"/>
                     </a:solidFill>
                   </a:tcPr>
                 </a:tc>
@@ -18901,7 +18901,7 @@
                   </a:txBody>
                   <a:tcPr>
                     <a:solidFill>
-                      <a:srgbClr val="F0F4FF"/>
+                      <a:srgbClr val="FFF1F2"/>
                     </a:solidFill>
                   </a:tcPr>
                 </a:tc>
@@ -18924,7 +18924,7 @@
                   </a:txBody>
                   <a:tcPr>
                     <a:solidFill>
-                      <a:srgbClr val="F0F4FF"/>
+                      <a:srgbClr val="FFF1F2"/>
                     </a:solidFill>
                   </a:tcPr>
                 </a:tc>
@@ -19020,7 +19020,7 @@
                   </a:txBody>
                   <a:tcPr>
                     <a:solidFill>
-                      <a:srgbClr val="F0F4FF"/>
+                      <a:srgbClr val="FFF1F2"/>
                     </a:solidFill>
                   </a:tcPr>
                 </a:tc>
@@ -19043,7 +19043,7 @@
                   </a:txBody>
                   <a:tcPr>
                     <a:solidFill>
-                      <a:srgbClr val="F0F4FF"/>
+                      <a:srgbClr val="FFF1F2"/>
                     </a:solidFill>
                   </a:tcPr>
                 </a:tc>
@@ -19066,7 +19066,7 @@
                   </a:txBody>
                   <a:tcPr>
                     <a:solidFill>
-                      <a:srgbClr val="F0F4FF"/>
+                      <a:srgbClr val="FFF1F2"/>
                     </a:solidFill>
                   </a:tcPr>
                 </a:tc>
@@ -19090,11 +19090,11 @@
             <a:avLst/>
           </a:prstGeom>
           <a:solidFill>
-            <a:srgbClr val="F0F4FF"/>
+            <a:srgbClr val="FFF1F2"/>
           </a:solidFill>
           <a:ln>
             <a:solidFill>
-              <a:srgbClr val="1A73E8"/>
+              <a:srgbClr val="C7000B"/>
             </a:solidFill>
           </a:ln>
         </p:spPr>
@@ -19120,7 +19120,7 @@
             <a:r>
               <a:rPr sz="1200" b="1">
                 <a:solidFill>
-                  <a:srgbClr val="1A73E8"/>
+                  <a:srgbClr val="C7000B"/>
                 </a:solidFill>
                 <a:latin typeface="Microsoft YaHei"/>
               </a:rPr>

</xml_diff>

<commit_message>
docs: 同步 slides + pptx 至 PR #62 状态
- dev_summary_slides.md：62 PR / 19 天 / Vue+SQLite+SSE / 5 层审查 /
  Admin 9 段 / 质量金字塔 / Token 用量 3 张新幻灯
- build_pptx.py：9 处过时数字（54 PR → 62 PR、~128 → 162、4 视角 → 5
  层等）同步至 dev_summary.html / .md 当前态
- dev_summary.pptx：重新生成的二进制产物

Signed-off-by: berming <bermin@live.cn>
AI-Assisted-By: Claude Opus 4.7 (claude-opus-4-7)
</commit_message>
<xml_diff>
--- a/docs/dev_summary.pptx
+++ b/docs/dev_summary.pptx
@@ -3240,7 +3240,7 @@
                 </a:solidFill>
                 <a:latin typeface="Microsoft YaHei"/>
               </a:rPr>
-              <a:t>沟通牌  ×  Claude Code  ×  54 PR · 有效开发 18 天</a:t>
+              <a:t>沟通牌  ×  Claude Code  ×  62 PR · 有效开发 19 天</a:t>
             </a:r>
           </a:p>
         </p:txBody>
@@ -5859,7 +5859,7 @@
                 </a:solidFill>
                 <a:latin typeface="Microsoft YaHei"/>
               </a:rPr>
-              <a:t>代码规模 (PR #54 后)  ·  约 19,250 行</a:t>
+              <a:t>代码规模 (PR #62 后)  ·  约 23,360 行 / 98 文件</a:t>
             </a:r>
           </a:p>
         </p:txBody>
@@ -5886,7 +5886,7 @@
                 <a:gridCol w="2194560"/>
                 <a:gridCol w="3291840"/>
               </a:tblGrid>
-              <a:tr h="350520">
+              <a:tr h="300445">
                 <a:tc>
                   <a:txBody>
                     <a:bodyPr lIns="40000" rIns="40000" tIns="15000" bIns="15000"/>
@@ -5974,7 +5974,7 @@
                   </a:tcPr>
                 </a:tc>
               </a:tr>
-              <a:tr h="350520">
+              <a:tr h="300445">
                 <a:tc>
                   <a:txBody>
                     <a:bodyPr lIns="40000" rIns="40000" tIns="10000" bIns="10000" wrap="square"/>
@@ -6031,7 +6031,7 @@
                           </a:solidFill>
                           <a:latin typeface="Microsoft YaHei"/>
                         </a:rPr>
-                        <a:t>19 文件 · ~6,300 行</a:t>
+                        <a:t>20 文件 · ~6,440 行</a:t>
                       </a:r>
                     </a:p>
                   </a:txBody>
@@ -6062,7 +6062,7 @@
                   </a:tcPr>
                 </a:tc>
               </a:tr>
-              <a:tr h="350520">
+              <a:tr h="300445">
                 <a:tc>
                   <a:txBody>
                     <a:bodyPr lIns="40000" rIns="40000" tIns="10000" bIns="10000" wrap="square"/>
@@ -6119,7 +6119,7 @@
                           </a:solidFill>
                           <a:latin typeface="Microsoft YaHei"/>
                         </a:rPr>
-                        <a:t>23 文件 · ~3,470 行</a:t>
+                        <a:t>25 文件 · ~4,320 行</a:t>
                       </a:r>
                     </a:p>
                   </a:txBody>
@@ -6150,7 +6150,7 @@
                   </a:tcPr>
                 </a:tc>
               </a:tr>
-              <a:tr h="350520">
+              <a:tr h="300445">
                 <a:tc>
                   <a:txBody>
                     <a:bodyPr lIns="40000" rIns="40000" tIns="10000" bIns="10000" wrap="square"/>
@@ -6238,7 +6238,7 @@
                   </a:tcPr>
                 </a:tc>
               </a:tr>
-              <a:tr h="350520">
+              <a:tr h="300445">
                 <a:tc>
                   <a:txBody>
                     <a:bodyPr lIns="40000" rIns="40000" tIns="10000" bIns="10000" wrap="square"/>
@@ -6252,7 +6252,7 @@
                           </a:solidFill>
                           <a:latin typeface="Microsoft YaHei"/>
                         </a:rPr>
-                        <a:t>:server (Ktor)</a:t>
+                        <a:t>:server (Ktor + admin)</a:t>
                       </a:r>
                     </a:p>
                   </a:txBody>
@@ -6295,7 +6295,7 @@
                           </a:solidFill>
                           <a:latin typeface="Microsoft YaHei"/>
                         </a:rPr>
-                        <a:t>4 文件 · ~1,960 行</a:t>
+                        <a:t>25 文件 · ~4,840 行</a:t>
                       </a:r>
                     </a:p>
                   </a:txBody>
@@ -6326,7 +6326,7 @@
                   </a:tcPr>
                 </a:tc>
               </a:tr>
-              <a:tr h="350520">
+              <a:tr h="300445">
                 <a:tc>
                   <a:txBody>
                     <a:bodyPr lIns="40000" rIns="40000" tIns="10000" bIns="10000" wrap="square"/>
@@ -6340,7 +6340,7 @@
                           </a:solidFill>
                           <a:latin typeface="Microsoft YaHei"/>
                         </a:rPr>
-                        <a:t>测试 + Android XML</a:t>
+                        <a:t>apps/admin (Vue 3 SPA)</a:t>
                       </a:r>
                     </a:p>
                   </a:txBody>
@@ -6383,7 +6383,95 @@
                           </a:solidFill>
                           <a:latin typeface="Microsoft YaHei"/>
                         </a:rPr>
-                        <a:t>24 文件 · ~4,850 行</a:t>
+                        <a:t>19 文件 · ~1,470 行</a:t>
+                      </a:r>
+                    </a:p>
+                  </a:txBody>
+                  <a:tcPr anchor="ctr">
+                    <a:solidFill>
+                      <a:srgbClr val="FFFFFF"/>
+                    </a:solidFill>
+                    <a:lnL w="6350" cap="flat" cmpd="sng" algn="ctr">
+                      <a:solidFill>
+                        <a:srgbClr val="808080"/>
+                      </a:solidFill>
+                    </a:lnL>
+                    <a:lnR w="6350" cap="flat" cmpd="sng" algn="ctr">
+                      <a:solidFill>
+                        <a:srgbClr val="808080"/>
+                      </a:solidFill>
+                    </a:lnR>
+                    <a:lnT w="6350" cap="flat" cmpd="sng" algn="ctr">
+                      <a:solidFill>
+                        <a:srgbClr val="808080"/>
+                      </a:solidFill>
+                    </a:lnT>
+                    <a:lnB w="6350" cap="flat" cmpd="sng" algn="ctr">
+                      <a:solidFill>
+                        <a:srgbClr val="808080"/>
+                      </a:solidFill>
+                    </a:lnB>
+                  </a:tcPr>
+                </a:tc>
+              </a:tr>
+              <a:tr h="300450">
+                <a:tc>
+                  <a:txBody>
+                    <a:bodyPr lIns="40000" rIns="40000" tIns="10000" bIns="10000" wrap="square"/>
+                    <a:lstStyle/>
+                    <a:p>
+                      <a:pPr algn="l"/>
+                      <a:r>
+                        <a:rPr sz="1200">
+                          <a:solidFill>
+                            <a:srgbClr val="202020"/>
+                          </a:solidFill>
+                          <a:latin typeface="Microsoft YaHei"/>
+                        </a:rPr>
+                        <a:t>测试 (server + shared)</a:t>
+                      </a:r>
+                    </a:p>
+                  </a:txBody>
+                  <a:tcPr anchor="ctr">
+                    <a:solidFill>
+                      <a:srgbClr val="FFFFFF"/>
+                    </a:solidFill>
+                    <a:lnL w="6350" cap="flat" cmpd="sng" algn="ctr">
+                      <a:solidFill>
+                        <a:srgbClr val="808080"/>
+                      </a:solidFill>
+                    </a:lnL>
+                    <a:lnR w="6350" cap="flat" cmpd="sng" algn="ctr">
+                      <a:solidFill>
+                        <a:srgbClr val="808080"/>
+                      </a:solidFill>
+                    </a:lnR>
+                    <a:lnT w="6350" cap="flat" cmpd="sng" algn="ctr">
+                      <a:solidFill>
+                        <a:srgbClr val="808080"/>
+                      </a:solidFill>
+                    </a:lnT>
+                    <a:lnB w="6350" cap="flat" cmpd="sng" algn="ctr">
+                      <a:solidFill>
+                        <a:srgbClr val="808080"/>
+                      </a:solidFill>
+                    </a:lnB>
+                  </a:tcPr>
+                </a:tc>
+                <a:tc>
+                  <a:txBody>
+                    <a:bodyPr lIns="40000" rIns="40000" tIns="10000" bIns="10000" wrap="square"/>
+                    <a:lstStyle/>
+                    <a:p>
+                      <a:pPr algn="l"/>
+                      <a:r>
+                        <a:rPr sz="1200">
+                          <a:solidFill>
+                            <a:srgbClr val="202020"/>
+                          </a:solidFill>
+                          <a:latin typeface="Microsoft YaHei"/>
+                        </a:rPr>
+                        <a:t>14 文件 · 186 用例 · ~3,620 行</a:t>
                       </a:r>
                     </a:p>
                   </a:txBody>
@@ -6448,7 +6536,7 @@
                 </a:solidFill>
                 <a:latin typeface="Microsoft YaHei"/>
               </a:rPr>
-              <a:t>12 阶段时间线  ·  54 PR  ·  ~170 commit  ·  有效开发 18 天</a:t>
+              <a:t>13 阶段时间线  ·  62 PR  ·  ~250 commit  ·  有效开发 19 天</a:t>
             </a:r>
           </a:p>
         </p:txBody>
@@ -6476,7 +6564,7 @@
                 <a:gridCol w="3383280"/>
                 <a:gridCol w="5486400"/>
               </a:tblGrid>
-              <a:tr h="203200">
+              <a:tr h="140676">
                 <a:tc>
                   <a:txBody>
                     <a:bodyPr lIns="40000" rIns="40000" tIns="15000" bIns="15000"/>
@@ -6607,7 +6695,7 @@
                   </a:tcPr>
                 </a:tc>
               </a:tr>
-              <a:tr h="203200">
+              <a:tr h="140676">
                 <a:tc>
                   <a:txBody>
                     <a:bodyPr lIns="40000" rIns="40000" tIns="10000" bIns="10000" wrap="square"/>
@@ -6738,7 +6826,7 @@
                   </a:tcPr>
                 </a:tc>
               </a:tr>
-              <a:tr h="203200">
+              <a:tr h="140676">
                 <a:tc>
                   <a:txBody>
                     <a:bodyPr lIns="40000" rIns="40000" tIns="10000" bIns="10000" wrap="square"/>
@@ -6869,7 +6957,7 @@
                   </a:tcPr>
                 </a:tc>
               </a:tr>
-              <a:tr h="203200">
+              <a:tr h="140676">
                 <a:tc>
                   <a:txBody>
                     <a:bodyPr lIns="40000" rIns="40000" tIns="10000" bIns="10000" wrap="square"/>
@@ -7000,7 +7088,7 @@
                   </a:tcPr>
                 </a:tc>
               </a:tr>
-              <a:tr h="203200">
+              <a:tr h="140676">
                 <a:tc>
                   <a:txBody>
                     <a:bodyPr lIns="40000" rIns="40000" tIns="10000" bIns="10000" wrap="square"/>
@@ -7131,7 +7219,7 @@
                   </a:tcPr>
                 </a:tc>
               </a:tr>
-              <a:tr h="203200">
+              <a:tr h="140676">
                 <a:tc>
                   <a:txBody>
                     <a:bodyPr lIns="40000" rIns="40000" tIns="10000" bIns="10000" wrap="square"/>
@@ -7262,7 +7350,7 @@
                   </a:tcPr>
                 </a:tc>
               </a:tr>
-              <a:tr h="203200">
+              <a:tr h="140676">
                 <a:tc>
                   <a:txBody>
                     <a:bodyPr lIns="40000" rIns="40000" tIns="10000" bIns="10000" wrap="square"/>
@@ -7393,7 +7481,7 @@
                   </a:tcPr>
                 </a:tc>
               </a:tr>
-              <a:tr h="203200">
+              <a:tr h="140676">
                 <a:tc>
                   <a:txBody>
                     <a:bodyPr lIns="40000" rIns="40000" tIns="10000" bIns="10000" wrap="square"/>
@@ -7524,7 +7612,7 @@
                   </a:tcPr>
                 </a:tc>
               </a:tr>
-              <a:tr h="203200">
+              <a:tr h="140676">
                 <a:tc>
                   <a:txBody>
                     <a:bodyPr lIns="40000" rIns="40000" tIns="10000" bIns="10000" wrap="square"/>
@@ -7581,7 +7669,7 @@
                           </a:solidFill>
                           <a:latin typeface="Microsoft YaHei"/>
                         </a:rPr>
-                        <a:t>AI 接管 + 单机修复 (#51–54)</a:t>
+                        <a:t>AI 接管 + 约束 6/7/8 (#51-58)</a:t>
                       </a:r>
                     </a:p>
                   </a:txBody>
@@ -7624,7 +7712,531 @@
                           </a:solidFill>
                           <a:latin typeface="Microsoft YaHei"/>
                         </a:rPr>
-                        <a:t>G34-G38 · PROTOCOL_VERSION 3</a:t>
+                        <a:t>G34-G38 · PROTOCOL=3 · UI 基线</a:t>
+                      </a:r>
+                    </a:p>
+                  </a:txBody>
+                  <a:tcPr anchor="ctr">
+                    <a:solidFill>
+                      <a:srgbClr val="FFFFFF"/>
+                    </a:solidFill>
+                    <a:lnL w="6350" cap="flat" cmpd="sng" algn="ctr">
+                      <a:solidFill>
+                        <a:srgbClr val="808080"/>
+                      </a:solidFill>
+                    </a:lnL>
+                    <a:lnR w="6350" cap="flat" cmpd="sng" algn="ctr">
+                      <a:solidFill>
+                        <a:srgbClr val="808080"/>
+                      </a:solidFill>
+                    </a:lnR>
+                    <a:lnT w="6350" cap="flat" cmpd="sng" algn="ctr">
+                      <a:solidFill>
+                        <a:srgbClr val="808080"/>
+                      </a:solidFill>
+                    </a:lnT>
+                    <a:lnB w="6350" cap="flat" cmpd="sng" algn="ctr">
+                      <a:solidFill>
+                        <a:srgbClr val="808080"/>
+                      </a:solidFill>
+                    </a:lnB>
+                  </a:tcPr>
+                </a:tc>
+              </a:tr>
+              <a:tr h="140676">
+                <a:tc>
+                  <a:txBody>
+                    <a:bodyPr lIns="40000" rIns="40000" tIns="10000" bIns="10000" wrap="square"/>
+                    <a:lstStyle/>
+                    <a:p>
+                      <a:pPr algn="l"/>
+                      <a:r>
+                        <a:rPr sz="1200">
+                          <a:solidFill>
+                            <a:srgbClr val="202020"/>
+                          </a:solidFill>
+                          <a:latin typeface="Microsoft YaHei"/>
+                        </a:rPr>
+                        <a:t>2026-05-11</a:t>
+                      </a:r>
+                    </a:p>
+                  </a:txBody>
+                  <a:tcPr anchor="ctr">
+                    <a:solidFill>
+                      <a:srgbClr val="FFFFFF"/>
+                    </a:solidFill>
+                    <a:lnL w="6350" cap="flat" cmpd="sng" algn="ctr">
+                      <a:solidFill>
+                        <a:srgbClr val="808080"/>
+                      </a:solidFill>
+                    </a:lnL>
+                    <a:lnR w="6350" cap="flat" cmpd="sng" algn="ctr">
+                      <a:solidFill>
+                        <a:srgbClr val="808080"/>
+                      </a:solidFill>
+                    </a:lnR>
+                    <a:lnT w="6350" cap="flat" cmpd="sng" algn="ctr">
+                      <a:solidFill>
+                        <a:srgbClr val="808080"/>
+                      </a:solidFill>
+                    </a:lnT>
+                    <a:lnB w="6350" cap="flat" cmpd="sng" algn="ctr">
+                      <a:solidFill>
+                        <a:srgbClr val="808080"/>
+                      </a:solidFill>
+                    </a:lnB>
+                  </a:tcPr>
+                </a:tc>
+                <a:tc>
+                  <a:txBody>
+                    <a:bodyPr lIns="40000" rIns="40000" tIns="10000" bIns="10000" wrap="square"/>
+                    <a:lstStyle/>
+                    <a:p>
+                      <a:pPr algn="l"/>
+                      <a:r>
+                        <a:rPr sz="1200">
+                          <a:solidFill>
+                            <a:srgbClr val="202020"/>
+                          </a:solidFill>
+                          <a:latin typeface="Microsoft YaHei"/>
+                        </a:rPr>
+                        <a:t>bermin.cn HTTPS (#60)</a:t>
+                      </a:r>
+                    </a:p>
+                  </a:txBody>
+                  <a:tcPr anchor="ctr">
+                    <a:solidFill>
+                      <a:srgbClr val="FFFFFF"/>
+                    </a:solidFill>
+                    <a:lnL w="6350" cap="flat" cmpd="sng" algn="ctr">
+                      <a:solidFill>
+                        <a:srgbClr val="808080"/>
+                      </a:solidFill>
+                    </a:lnL>
+                    <a:lnR w="6350" cap="flat" cmpd="sng" algn="ctr">
+                      <a:solidFill>
+                        <a:srgbClr val="808080"/>
+                      </a:solidFill>
+                    </a:lnR>
+                    <a:lnT w="6350" cap="flat" cmpd="sng" algn="ctr">
+                      <a:solidFill>
+                        <a:srgbClr val="808080"/>
+                      </a:solidFill>
+                    </a:lnT>
+                    <a:lnB w="6350" cap="flat" cmpd="sng" algn="ctr">
+                      <a:solidFill>
+                        <a:srgbClr val="808080"/>
+                      </a:solidFill>
+                    </a:lnB>
+                  </a:tcPr>
+                </a:tc>
+                <a:tc>
+                  <a:txBody>
+                    <a:bodyPr lIns="40000" rIns="40000" tIns="10000" bIns="10000" wrap="square"/>
+                    <a:lstStyle/>
+                    <a:p>
+                      <a:pPr algn="l"/>
+                      <a:r>
+                        <a:rPr sz="1200">
+                          <a:solidFill>
+                            <a:srgbClr val="202020"/>
+                          </a:solidFill>
+                          <a:latin typeface="Microsoft YaHei"/>
+                        </a:rPr>
+                        <a:t>Caddy ACME · :80 fallback</a:t>
+                      </a:r>
+                    </a:p>
+                  </a:txBody>
+                  <a:tcPr anchor="ctr">
+                    <a:solidFill>
+                      <a:srgbClr val="FFFFFF"/>
+                    </a:solidFill>
+                    <a:lnL w="6350" cap="flat" cmpd="sng" algn="ctr">
+                      <a:solidFill>
+                        <a:srgbClr val="808080"/>
+                      </a:solidFill>
+                    </a:lnL>
+                    <a:lnR w="6350" cap="flat" cmpd="sng" algn="ctr">
+                      <a:solidFill>
+                        <a:srgbClr val="808080"/>
+                      </a:solidFill>
+                    </a:lnR>
+                    <a:lnT w="6350" cap="flat" cmpd="sng" algn="ctr">
+                      <a:solidFill>
+                        <a:srgbClr val="808080"/>
+                      </a:solidFill>
+                    </a:lnT>
+                    <a:lnB w="6350" cap="flat" cmpd="sng" algn="ctr">
+                      <a:solidFill>
+                        <a:srgbClr val="808080"/>
+                      </a:solidFill>
+                    </a:lnB>
+                  </a:tcPr>
+                </a:tc>
+              </a:tr>
+              <a:tr h="140676">
+                <a:tc>
+                  <a:txBody>
+                    <a:bodyPr lIns="40000" rIns="40000" tIns="10000" bIns="10000" wrap="square"/>
+                    <a:lstStyle/>
+                    <a:p>
+                      <a:pPr algn="l"/>
+                      <a:r>
+                        <a:rPr sz="1200">
+                          <a:solidFill>
+                            <a:srgbClr val="202020"/>
+                          </a:solidFill>
+                          <a:latin typeface="Microsoft YaHei"/>
+                        </a:rPr>
+                        <a:t>2026-05-12</a:t>
+                      </a:r>
+                    </a:p>
+                  </a:txBody>
+                  <a:tcPr anchor="ctr">
+                    <a:solidFill>
+                      <a:srgbClr val="FFFFFF"/>
+                    </a:solidFill>
+                    <a:lnL w="6350" cap="flat" cmpd="sng" algn="ctr">
+                      <a:solidFill>
+                        <a:srgbClr val="808080"/>
+                      </a:solidFill>
+                    </a:lnL>
+                    <a:lnR w="6350" cap="flat" cmpd="sng" algn="ctr">
+                      <a:solidFill>
+                        <a:srgbClr val="808080"/>
+                      </a:solidFill>
+                    </a:lnR>
+                    <a:lnT w="6350" cap="flat" cmpd="sng" algn="ctr">
+                      <a:solidFill>
+                        <a:srgbClr val="808080"/>
+                      </a:solidFill>
+                    </a:lnT>
+                    <a:lnB w="6350" cap="flat" cmpd="sng" algn="ctr">
+                      <a:solidFill>
+                        <a:srgbClr val="808080"/>
+                      </a:solidFill>
+                    </a:lnB>
+                  </a:tcPr>
+                </a:tc>
+                <a:tc>
+                  <a:txBody>
+                    <a:bodyPr lIns="40000" rIns="40000" tIns="10000" bIns="10000" wrap="square"/>
+                    <a:lstStyle/>
+                    <a:p>
+                      <a:pPr algn="l"/>
+                      <a:r>
+                        <a:rPr sz="1200">
+                          <a:solidFill>
+                            <a:srgbClr val="202020"/>
+                          </a:solidFill>
+                          <a:latin typeface="Microsoft YaHei"/>
+                        </a:rPr>
+                        <a:t>WS 重连 + HTML docs (#59)</a:t>
+                      </a:r>
+                    </a:p>
+                  </a:txBody>
+                  <a:tcPr anchor="ctr">
+                    <a:solidFill>
+                      <a:srgbClr val="FFFFFF"/>
+                    </a:solidFill>
+                    <a:lnL w="6350" cap="flat" cmpd="sng" algn="ctr">
+                      <a:solidFill>
+                        <a:srgbClr val="808080"/>
+                      </a:solidFill>
+                    </a:lnL>
+                    <a:lnR w="6350" cap="flat" cmpd="sng" algn="ctr">
+                      <a:solidFill>
+                        <a:srgbClr val="808080"/>
+                      </a:solidFill>
+                    </a:lnR>
+                    <a:lnT w="6350" cap="flat" cmpd="sng" algn="ctr">
+                      <a:solidFill>
+                        <a:srgbClr val="808080"/>
+                      </a:solidFill>
+                    </a:lnT>
+                    <a:lnB w="6350" cap="flat" cmpd="sng" algn="ctr">
+                      <a:solidFill>
+                        <a:srgbClr val="808080"/>
+                      </a:solidFill>
+                    </a:lnB>
+                  </a:tcPr>
+                </a:tc>
+                <a:tc>
+                  <a:txBody>
+                    <a:bodyPr lIns="40000" rIns="40000" tIns="10000" bIns="10000" wrap="square"/>
+                    <a:lstStyle/>
+                    <a:p>
+                      <a:pPr algn="l"/>
+                      <a:r>
+                        <a:rPr sz="1200">
+                          <a:solidFill>
+                            <a:srgbClr val="202020"/>
+                          </a:solidFill>
+                          <a:latin typeface="Microsoft YaHei"/>
+                        </a:rPr>
+                        <a:t>指数退避 ×5 · dev_summary.html</a:t>
+                      </a:r>
+                    </a:p>
+                  </a:txBody>
+                  <a:tcPr anchor="ctr">
+                    <a:solidFill>
+                      <a:srgbClr val="FFFFFF"/>
+                    </a:solidFill>
+                    <a:lnL w="6350" cap="flat" cmpd="sng" algn="ctr">
+                      <a:solidFill>
+                        <a:srgbClr val="808080"/>
+                      </a:solidFill>
+                    </a:lnL>
+                    <a:lnR w="6350" cap="flat" cmpd="sng" algn="ctr">
+                      <a:solidFill>
+                        <a:srgbClr val="808080"/>
+                      </a:solidFill>
+                    </a:lnR>
+                    <a:lnT w="6350" cap="flat" cmpd="sng" algn="ctr">
+                      <a:solidFill>
+                        <a:srgbClr val="808080"/>
+                      </a:solidFill>
+                    </a:lnT>
+                    <a:lnB w="6350" cap="flat" cmpd="sng" algn="ctr">
+                      <a:solidFill>
+                        <a:srgbClr val="808080"/>
+                      </a:solidFill>
+                    </a:lnB>
+                  </a:tcPr>
+                </a:tc>
+              </a:tr>
+              <a:tr h="140676">
+                <a:tc>
+                  <a:txBody>
+                    <a:bodyPr lIns="40000" rIns="40000" tIns="10000" bIns="10000" wrap="square"/>
+                    <a:lstStyle/>
+                    <a:p>
+                      <a:pPr algn="l"/>
+                      <a:r>
+                        <a:rPr sz="1200">
+                          <a:solidFill>
+                            <a:srgbClr val="202020"/>
+                          </a:solidFill>
+                          <a:latin typeface="Microsoft YaHei"/>
+                        </a:rPr>
+                        <a:t>2026-05-13</a:t>
+                      </a:r>
+                    </a:p>
+                  </a:txBody>
+                  <a:tcPr anchor="ctr">
+                    <a:solidFill>
+                      <a:srgbClr val="FFFFFF"/>
+                    </a:solidFill>
+                    <a:lnL w="6350" cap="flat" cmpd="sng" algn="ctr">
+                      <a:solidFill>
+                        <a:srgbClr val="808080"/>
+                      </a:solidFill>
+                    </a:lnL>
+                    <a:lnR w="6350" cap="flat" cmpd="sng" algn="ctr">
+                      <a:solidFill>
+                        <a:srgbClr val="808080"/>
+                      </a:solidFill>
+                    </a:lnR>
+                    <a:lnT w="6350" cap="flat" cmpd="sng" algn="ctr">
+                      <a:solidFill>
+                        <a:srgbClr val="808080"/>
+                      </a:solidFill>
+                    </a:lnT>
+                    <a:lnB w="6350" cap="flat" cmpd="sng" algn="ctr">
+                      <a:solidFill>
+                        <a:srgbClr val="808080"/>
+                      </a:solidFill>
+                    </a:lnB>
+                  </a:tcPr>
+                </a:tc>
+                <a:tc>
+                  <a:txBody>
+                    <a:bodyPr lIns="40000" rIns="40000" tIns="10000" bIns="10000" wrap="square"/>
+                    <a:lstStyle/>
+                    <a:p>
+                      <a:pPr algn="l"/>
+                      <a:r>
+                        <a:rPr sz="1200">
+                          <a:solidFill>
+                            <a:srgbClr val="202020"/>
+                          </a:solidFill>
+                          <a:latin typeface="Microsoft YaHei"/>
+                        </a:rPr>
+                        <a:t>Admin MVP (#61) PR 0-4</a:t>
+                      </a:r>
+                    </a:p>
+                  </a:txBody>
+                  <a:tcPr anchor="ctr">
+                    <a:solidFill>
+                      <a:srgbClr val="FFFFFF"/>
+                    </a:solidFill>
+                    <a:lnL w="6350" cap="flat" cmpd="sng" algn="ctr">
+                      <a:solidFill>
+                        <a:srgbClr val="808080"/>
+                      </a:solidFill>
+                    </a:lnL>
+                    <a:lnR w="6350" cap="flat" cmpd="sng" algn="ctr">
+                      <a:solidFill>
+                        <a:srgbClr val="808080"/>
+                      </a:solidFill>
+                    </a:lnR>
+                    <a:lnT w="6350" cap="flat" cmpd="sng" algn="ctr">
+                      <a:solidFill>
+                        <a:srgbClr val="808080"/>
+                      </a:solidFill>
+                    </a:lnT>
+                    <a:lnB w="6350" cap="flat" cmpd="sng" algn="ctr">
+                      <a:solidFill>
+                        <a:srgbClr val="808080"/>
+                      </a:solidFill>
+                    </a:lnB>
+                  </a:tcPr>
+                </a:tc>
+                <a:tc>
+                  <a:txBody>
+                    <a:bodyPr lIns="40000" rIns="40000" tIns="10000" bIns="10000" wrap="square"/>
+                    <a:lstStyle/>
+                    <a:p>
+                      <a:pPr algn="l"/>
+                      <a:r>
+                        <a:rPr sz="1200">
+                          <a:solidFill>
+                            <a:srgbClr val="202020"/>
+                          </a:solidFill>
+                          <a:latin typeface="Microsoft YaHei"/>
+                        </a:rPr>
+                        <a:t>SQLite/bcrypt/监控/告警/Vue SPA</a:t>
+                      </a:r>
+                    </a:p>
+                  </a:txBody>
+                  <a:tcPr anchor="ctr">
+                    <a:solidFill>
+                      <a:srgbClr val="FFFFFF"/>
+                    </a:solidFill>
+                    <a:lnL w="6350" cap="flat" cmpd="sng" algn="ctr">
+                      <a:solidFill>
+                        <a:srgbClr val="808080"/>
+                      </a:solidFill>
+                    </a:lnL>
+                    <a:lnR w="6350" cap="flat" cmpd="sng" algn="ctr">
+                      <a:solidFill>
+                        <a:srgbClr val="808080"/>
+                      </a:solidFill>
+                    </a:lnR>
+                    <a:lnT w="6350" cap="flat" cmpd="sng" algn="ctr">
+                      <a:solidFill>
+                        <a:srgbClr val="808080"/>
+                      </a:solidFill>
+                    </a:lnT>
+                    <a:lnB w="6350" cap="flat" cmpd="sng" algn="ctr">
+                      <a:solidFill>
+                        <a:srgbClr val="808080"/>
+                      </a:solidFill>
+                    </a:lnB>
+                  </a:tcPr>
+                </a:tc>
+              </a:tr>
+              <a:tr h="140688">
+                <a:tc>
+                  <a:txBody>
+                    <a:bodyPr lIns="40000" rIns="40000" tIns="10000" bIns="10000" wrap="square"/>
+                    <a:lstStyle/>
+                    <a:p>
+                      <a:pPr algn="l"/>
+                      <a:r>
+                        <a:rPr sz="1200">
+                          <a:solidFill>
+                            <a:srgbClr val="202020"/>
+                          </a:solidFill>
+                          <a:latin typeface="Microsoft YaHei"/>
+                        </a:rPr>
+                        <a:t>2026-05-13</a:t>
+                      </a:r>
+                    </a:p>
+                  </a:txBody>
+                  <a:tcPr anchor="ctr">
+                    <a:solidFill>
+                      <a:srgbClr val="FFFFFF"/>
+                    </a:solidFill>
+                    <a:lnL w="6350" cap="flat" cmpd="sng" algn="ctr">
+                      <a:solidFill>
+                        <a:srgbClr val="808080"/>
+                      </a:solidFill>
+                    </a:lnL>
+                    <a:lnR w="6350" cap="flat" cmpd="sng" algn="ctr">
+                      <a:solidFill>
+                        <a:srgbClr val="808080"/>
+                      </a:solidFill>
+                    </a:lnR>
+                    <a:lnT w="6350" cap="flat" cmpd="sng" algn="ctr">
+                      <a:solidFill>
+                        <a:srgbClr val="808080"/>
+                      </a:solidFill>
+                    </a:lnT>
+                    <a:lnB w="6350" cap="flat" cmpd="sng" algn="ctr">
+                      <a:solidFill>
+                        <a:srgbClr val="808080"/>
+                      </a:solidFill>
+                    </a:lnB>
+                  </a:tcPr>
+                </a:tc>
+                <a:tc>
+                  <a:txBody>
+                    <a:bodyPr lIns="40000" rIns="40000" tIns="10000" bIns="10000" wrap="square"/>
+                    <a:lstStyle/>
+                    <a:p>
+                      <a:pPr algn="l"/>
+                      <a:r>
+                        <a:rPr sz="1200">
+                          <a:solidFill>
+                            <a:srgbClr val="202020"/>
+                          </a:solidFill>
+                          <a:latin typeface="Microsoft YaHei"/>
+                        </a:rPr>
+                        <a:t>Admin 优化 (#62) PR 5a-d</a:t>
+                      </a:r>
+                    </a:p>
+                  </a:txBody>
+                  <a:tcPr anchor="ctr">
+                    <a:solidFill>
+                      <a:srgbClr val="FFFFFF"/>
+                    </a:solidFill>
+                    <a:lnL w="6350" cap="flat" cmpd="sng" algn="ctr">
+                      <a:solidFill>
+                        <a:srgbClr val="808080"/>
+                      </a:solidFill>
+                    </a:lnL>
+                    <a:lnR w="6350" cap="flat" cmpd="sng" algn="ctr">
+                      <a:solidFill>
+                        <a:srgbClr val="808080"/>
+                      </a:solidFill>
+                    </a:lnR>
+                    <a:lnT w="6350" cap="flat" cmpd="sng" algn="ctr">
+                      <a:solidFill>
+                        <a:srgbClr val="808080"/>
+                      </a:solidFill>
+                    </a:lnT>
+                    <a:lnB w="6350" cap="flat" cmpd="sng" algn="ctr">
+                      <a:solidFill>
+                        <a:srgbClr val="808080"/>
+                      </a:solidFill>
+                    </a:lnB>
+                  </a:tcPr>
+                </a:tc>
+                <a:tc>
+                  <a:txBody>
+                    <a:bodyPr lIns="40000" rIns="40000" tIns="10000" bIns="10000" wrap="square"/>
+                    <a:lstStyle/>
+                    <a:p>
+                      <a:pPr algn="l"/>
+                      <a:r>
+                        <a:rPr sz="1200">
+                          <a:solidFill>
+                            <a:srgbClr val="202020"/>
+                          </a:solidFill>
+                          <a:latin typeface="Microsoft YaHei"/>
+                        </a:rPr>
+                        <a:t>SSE / 趋势图 / JSON / 事件回放</a:t>
                       </a:r>
                     </a:p>
                   </a:txBody>
@@ -9773,7 +10385,7 @@
                 </a:solidFill>
                 <a:latin typeface="Microsoft YaHei"/>
               </a:rPr>
-              <a:t>三、问题发现：人工 + AI（~128 个，4 视角不重叠）</a:t>
+              <a:t>三、问题发现：5 层审查（~162 个；PR #1-#62 全程）</a:t>
             </a:r>
           </a:p>
         </p:txBody>
@@ -9896,7 +10508,7 @@
                 </a:solidFill>
                 <a:latin typeface="Microsoft YaHei"/>
               </a:rPr>
-              <a:t>🔴 人工测试 / 反馈</a:t>
+              <a:t>🔴 人工 + 真机</a:t>
             </a:r>
           </a:p>
         </p:txBody>
@@ -9931,7 +10543,7 @@
                 </a:solidFill>
                 <a:latin typeface="Microsoft YaHei"/>
               </a:rPr>
-              <a:t>~35  (27%)</a:t>
+              <a:t>~38  (23%)</a:t>
             </a:r>
           </a:p>
         </p:txBody>
@@ -9966,7 +10578,7 @@
                 </a:solidFill>
                 <a:latin typeface="Microsoft YaHei"/>
               </a:rPr>
-              <a:t>UI · 部署 · 真机崩溃</a:t>
+              <a:t>UI · 部署 · UI race (Web 连点 3 次)</a:t>
             </a:r>
           </a:p>
         </p:txBody>
@@ -10081,7 +10693,7 @@
                 </a:solidFill>
                 <a:latin typeface="Microsoft YaHei"/>
               </a:rPr>
-              <a:t>~55  (43%)</a:t>
+              <a:t>~65  (40%)</a:t>
             </a:r>
           </a:p>
         </p:txBody>
@@ -10116,7 +10728,7 @@
                 </a:solidFill>
                 <a:latin typeface="Microsoft YaHei"/>
               </a:rPr>
-              <a:t>全量扫描 · 跨文件 · 并发</a:t>
+              <a:t>全量扫描 + CI 修复 (4 次 quirks)</a:t>
             </a:r>
           </a:p>
         </p:txBody>
@@ -10231,7 +10843,7 @@
                 </a:solidFill>
                 <a:latin typeface="Microsoft YaHei"/>
               </a:rPr>
-              <a:t>~15  (12%)</a:t>
+              <a:t>~22  (14%)</a:t>
             </a:r>
           </a:p>
         </p:txBody>
@@ -10266,7 +10878,7 @@
                 </a:solidFill>
                 <a:latin typeface="Microsoft YaHei"/>
               </a:rPr>
-              <a:t>独立 context · 跨文件契约</a:t>
+              <a:t>PR #61 一次审 1 P0 + 4 P1</a:t>
             </a:r>
           </a:p>
         </p:txBody>
@@ -10381,7 +10993,7 @@
                 </a:solidFill>
                 <a:latin typeface="Microsoft YaHei"/>
               </a:rPr>
-              <a:t>~13  (10%)</a:t>
+              <a:t>25 精确  (15%)</a:t>
             </a:r>
           </a:p>
         </p:txBody>
@@ -10416,7 +11028,7 @@
                 </a:solidFill>
                 <a:latin typeface="Microsoft YaHei"/>
               </a:rPr>
-              <a:t>语句级边界 · entropy · 文案</a:t>
+              <a:t>全量审计 · 0 误报 · P1×7/P2×18</a:t>
             </a:r>
           </a:p>
         </p:txBody>
@@ -10451,7 +11063,7 @@
                 </a:solidFill>
                 <a:latin typeface="Microsoft YaHei"/>
               </a:rPr>
-              <a:t>🔴 人工发现（~35，3 阶段）</a:t>
+              <a:t>🔴 人工 + 真机（~38；含 Web 连点 3 次 race）</a:t>
             </a:r>
           </a:p>
         </p:txBody>
@@ -10864,7 +11476,7 @@
                 </a:solidFill>
                 <a:latin typeface="Microsoft YaHei"/>
               </a:rPr>
-              <a:t>🔵 AI 发现（Claude ~55 · pr-reviewer ~15 · Codex ~13）</a:t>
+              <a:t>🔵 AI 发现（Claude ~65 · pr-reviewer ~22 · Codex 25 精确）</a:t>
             </a:r>
           </a:p>
         </p:txBody>
@@ -19994,7 +20606,7 @@
                 </a:solidFill>
                 <a:latin typeface="Microsoft YaHei"/>
               </a:rPr>
-              <a:t>·  全程 54 PR / ~170 commit  ·  有效开发 18 天  ·  发现 ~128 个问题</a:t>
+              <a:t>·  全程 62 PR / ~250 commit  ·  有效开发 19 天  ·  发现 ~162 个问题</a:t>
             </a:r>
           </a:p>
         </p:txBody>

</xml_diff>

<commit_message>
docs(html+pptx): regenerate to match dev_summary metric refresh
- build_pptx.py: 23k LOC / 98 files / 186 tests / 62 PR / 19 days
  -> 25k LOC / 102 files / 195+ tests / 86 PR / 22 days; Codex tally 25 -> 34
- dev_summary_slides.md: same numeric refresh + 后续行动 table now lists
  PR #74 fuzz, v1.27 + 6 tooling plugins, PR #86 N6 web debug log
- dev_summary.html: regenerated via build_html.py (inline SVG, single file)
- dev_summary.pptx: regenerated via build_pptx.py

Signed-off-by: berming <bermin@live.cn>
AI-Assisted-By: Claude Opus 4.7 (claude-opus-4-7, 1M context)
</commit_message>
<xml_diff>
--- a/docs/dev_summary.pptx
+++ b/docs/dev_summary.pptx
@@ -3240,7 +3240,7 @@
                 </a:solidFill>
                 <a:latin typeface="Microsoft YaHei"/>
               </a:rPr>
-              <a:t>沟通牌  ×  Claude Code  ×  62 PR · 有效开发 19 天</a:t>
+              <a:t>沟通牌  ×  Claude Code  ×  86 PR · 有效开发 22 天</a:t>
             </a:r>
           </a:p>
         </p:txBody>
@@ -5859,7 +5859,7 @@
                 </a:solidFill>
                 <a:latin typeface="Microsoft YaHei"/>
               </a:rPr>
-              <a:t>代码规模 (PR #62 后)  ·  约 23,360 行 / 98 文件</a:t>
+              <a:t>代码规模 (PR #85 后)  ·  约 25,000 行 / 102 文件</a:t>
             </a:r>
           </a:p>
         </p:txBody>
@@ -6119,7 +6119,7 @@
                           </a:solidFill>
                           <a:latin typeface="Microsoft YaHei"/>
                         </a:rPr>
-                        <a:t>25 文件 · ~4,320 行</a:t>
+                        <a:t>27 文件 · ~4,800 行</a:t>
                       </a:r>
                     </a:p>
                   </a:txBody>
@@ -6295,7 +6295,7 @@
                           </a:solidFill>
                           <a:latin typeface="Microsoft YaHei"/>
                         </a:rPr>
-                        <a:t>25 文件 · ~4,840 行</a:t>
+                        <a:t>25 文件 · ~5,040 行</a:t>
                       </a:r>
                     </a:p>
                   </a:txBody>
@@ -6383,7 +6383,7 @@
                           </a:solidFill>
                           <a:latin typeface="Microsoft YaHei"/>
                         </a:rPr>
-                        <a:t>19 文件 · ~1,470 行</a:t>
+                        <a:t>19 文件 · ~1,490 行</a:t>
                       </a:r>
                     </a:p>
                   </a:txBody>
@@ -6428,7 +6428,7 @@
                           </a:solidFill>
                           <a:latin typeface="Microsoft YaHei"/>
                         </a:rPr>
-                        <a:t>测试 (server + shared)</a:t>
+                        <a:t>测试 (含 PR #74 fuzz)</a:t>
                       </a:r>
                     </a:p>
                   </a:txBody>
@@ -6471,7 +6471,7 @@
                           </a:solidFill>
                           <a:latin typeface="Microsoft YaHei"/>
                         </a:rPr>
-                        <a:t>14 文件 · 186 用例 · ~3,620 行</a:t>
+                        <a:t>17 文件 · 195+ 用例 · ~4,560 行</a:t>
                       </a:r>
                     </a:p>
                   </a:txBody>
@@ -6536,7 +6536,7 @@
                 </a:solidFill>
                 <a:latin typeface="Microsoft YaHei"/>
               </a:rPr>
-              <a:t>13 阶段时间线  ·  62 PR  ·  ~250 commit  ·  有效开发 19 天</a:t>
+              <a:t>13 阶段时间线  ·  86 PR  ·  ~280 commit  ·  有效开发 22 天</a:t>
             </a:r>
           </a:p>
         </p:txBody>
@@ -10385,7 +10385,7 @@
                 </a:solidFill>
                 <a:latin typeface="Microsoft YaHei"/>
               </a:rPr>
-              <a:t>三、问题发现：5 层审查（~162 个；PR #1-#62 全程）</a:t>
+              <a:t>三、问题发现：5 层审查（~168 个；PR #1-#86 全程）</a:t>
             </a:r>
           </a:p>
         </p:txBody>
@@ -10993,7 +10993,7 @@
                 </a:solidFill>
                 <a:latin typeface="Microsoft YaHei"/>
               </a:rPr>
-              <a:t>25 精确  (15%)</a:t>
+              <a:t>34 精确  (20%)</a:t>
             </a:r>
           </a:p>
         </p:txBody>
@@ -11028,7 +11028,7 @@
                 </a:solidFill>
                 <a:latin typeface="Microsoft YaHei"/>
               </a:rPr>
-              <a:t>全量审计 · 0 误报 · P1×7/P2×18</a:t>
+              <a:t>全量审计 · 0 误报 · 含 BCrypt SIOOBE 真 bug</a:t>
             </a:r>
           </a:p>
         </p:txBody>
@@ -20606,7 +20606,7 @@
                 </a:solidFill>
                 <a:latin typeface="Microsoft YaHei"/>
               </a:rPr>
-              <a:t>·  全程 62 PR / ~250 commit  ·  有效开发 19 天  ·  发现 ~162 个问题</a:t>
+              <a:t>·  全程 86 PR / ~280 commit  ·  有效开发 22 天  ·  发现 ~168 个问题</a:t>
             </a:r>
           </a:p>
         </p:txBody>

</xml_diff>